<commit_message>
Animate a running light along the comic frame outlines
Two glowing comets (lead dot plus fading tail) travel around each green
comic frame on slides 2-5 and 7 via native motion-path animations that
start automatically and loop until the slide ends.

Co-Authored-By: Claude Opus 5.5 <noreply@anthropic.com>
Claude-Session: https://claude.ai/code/session_01QqHU1Mec7wAVsmzx9ZzXpr
</commit_message>
<xml_diff>
--- a/FP-2_v23_modern.pptx
+++ b/FP-2_v23_modern.pptx
@@ -2898,6 +2898,502 @@
       </p:sp>
       <p:sp>
         <p:nvSpPr>
+          <p:cNvPr id="71" name="Світло рамки 2.8"/>
+          <p:cNvSpPr/>
+          <p:nvPr/>
+        </p:nvSpPr>
+        <p:spPr>
+          <a:xfrm>
+            <a:off x="3753612" y="6108192"/>
+            <a:ext cx="36576" cy="36576"/>
+          </a:xfrm>
+          <a:prstGeom prst="ellipse">
+            <a:avLst/>
+          </a:prstGeom>
+          <a:solidFill>
+            <a:srgbClr val="58F268">
+              <a:alpha val="20000"/>
+            </a:srgbClr>
+          </a:solidFill>
+          <a:ln>
+            <a:noFill/>
+          </a:ln>
+          <a:effectLst>
+            <a:glow rad="63500">
+              <a:srgbClr val="58F268">
+                <a:alpha val="12000"/>
+              </a:srgbClr>
+            </a:glow>
+          </a:effectLst>
+        </p:spPr>
+      </p:sp>
+      <p:sp>
+        <p:nvSpPr>
+          <p:cNvPr id="70" name="Світло рамки 2.7"/>
+          <p:cNvSpPr/>
+          <p:nvPr/>
+        </p:nvSpPr>
+        <p:spPr>
+          <a:xfrm>
+            <a:off x="3747734" y="6102314"/>
+            <a:ext cx="48332" cy="48332"/>
+          </a:xfrm>
+          <a:prstGeom prst="ellipse">
+            <a:avLst/>
+          </a:prstGeom>
+          <a:solidFill>
+            <a:srgbClr val="58F268">
+              <a:alpha val="31428"/>
+            </a:srgbClr>
+          </a:solidFill>
+          <a:ln>
+            <a:noFill/>
+          </a:ln>
+          <a:effectLst>
+            <a:glow rad="63500">
+              <a:srgbClr val="58F268">
+                <a:alpha val="18856"/>
+              </a:srgbClr>
+            </a:glow>
+          </a:effectLst>
+        </p:spPr>
+      </p:sp>
+      <p:sp>
+        <p:nvSpPr>
+          <p:cNvPr id="69" name="Світло рамки 2.6"/>
+          <p:cNvSpPr/>
+          <p:nvPr/>
+        </p:nvSpPr>
+        <p:spPr>
+          <a:xfrm>
+            <a:off x="3741856" y="6096436"/>
+            <a:ext cx="60089" cy="60089"/>
+          </a:xfrm>
+          <a:prstGeom prst="ellipse">
+            <a:avLst/>
+          </a:prstGeom>
+          <a:solidFill>
+            <a:srgbClr val="58F268">
+              <a:alpha val="42857"/>
+            </a:srgbClr>
+          </a:solidFill>
+          <a:ln>
+            <a:noFill/>
+          </a:ln>
+          <a:effectLst>
+            <a:glow rad="63500">
+              <a:srgbClr val="58F268">
+                <a:alpha val="25714"/>
+              </a:srgbClr>
+            </a:glow>
+          </a:effectLst>
+        </p:spPr>
+      </p:sp>
+      <p:sp>
+        <p:nvSpPr>
+          <p:cNvPr id="68" name="Світло рамки 2.5"/>
+          <p:cNvSpPr/>
+          <p:nvPr/>
+        </p:nvSpPr>
+        <p:spPr>
+          <a:xfrm>
+            <a:off x="3735978" y="6090558"/>
+            <a:ext cx="71845" cy="71845"/>
+          </a:xfrm>
+          <a:prstGeom prst="ellipse">
+            <a:avLst/>
+          </a:prstGeom>
+          <a:solidFill>
+            <a:srgbClr val="58F268">
+              <a:alpha val="54285"/>
+            </a:srgbClr>
+          </a:solidFill>
+          <a:ln>
+            <a:noFill/>
+          </a:ln>
+          <a:effectLst>
+            <a:glow rad="63500">
+              <a:srgbClr val="58F268">
+                <a:alpha val="32571"/>
+              </a:srgbClr>
+            </a:glow>
+          </a:effectLst>
+        </p:spPr>
+      </p:sp>
+      <p:sp>
+        <p:nvSpPr>
+          <p:cNvPr id="67" name="Світло рамки 2.4"/>
+          <p:cNvSpPr/>
+          <p:nvPr/>
+        </p:nvSpPr>
+        <p:spPr>
+          <a:xfrm>
+            <a:off x="3730099" y="6084679"/>
+            <a:ext cx="83602" cy="83602"/>
+          </a:xfrm>
+          <a:prstGeom prst="ellipse">
+            <a:avLst/>
+          </a:prstGeom>
+          <a:solidFill>
+            <a:srgbClr val="58F268">
+              <a:alpha val="65714"/>
+            </a:srgbClr>
+          </a:solidFill>
+          <a:ln>
+            <a:noFill/>
+          </a:ln>
+          <a:effectLst>
+            <a:glow rad="63500">
+              <a:srgbClr val="58F268">
+                <a:alpha val="39428"/>
+              </a:srgbClr>
+            </a:glow>
+          </a:effectLst>
+        </p:spPr>
+      </p:sp>
+      <p:sp>
+        <p:nvSpPr>
+          <p:cNvPr id="66" name="Світло рамки 2.3"/>
+          <p:cNvSpPr/>
+          <p:nvPr/>
+        </p:nvSpPr>
+        <p:spPr>
+          <a:xfrm>
+            <a:off x="3724221" y="6078801"/>
+            <a:ext cx="95358" cy="95358"/>
+          </a:xfrm>
+          <a:prstGeom prst="ellipse">
+            <a:avLst/>
+          </a:prstGeom>
+          <a:solidFill>
+            <a:srgbClr val="58F268">
+              <a:alpha val="77142"/>
+            </a:srgbClr>
+          </a:solidFill>
+          <a:ln>
+            <a:noFill/>
+          </a:ln>
+          <a:effectLst>
+            <a:glow rad="63500">
+              <a:srgbClr val="58F268">
+                <a:alpha val="46285"/>
+              </a:srgbClr>
+            </a:glow>
+          </a:effectLst>
+        </p:spPr>
+      </p:sp>
+      <p:sp>
+        <p:nvSpPr>
+          <p:cNvPr id="65" name="Світло рамки 2.2"/>
+          <p:cNvSpPr/>
+          <p:nvPr/>
+        </p:nvSpPr>
+        <p:spPr>
+          <a:xfrm>
+            <a:off x="3718343" y="6072923"/>
+            <a:ext cx="107115" cy="107115"/>
+          </a:xfrm>
+          <a:prstGeom prst="ellipse">
+            <a:avLst/>
+          </a:prstGeom>
+          <a:solidFill>
+            <a:srgbClr val="58F268">
+              <a:alpha val="88571"/>
+            </a:srgbClr>
+          </a:solidFill>
+          <a:ln>
+            <a:noFill/>
+          </a:ln>
+          <a:effectLst>
+            <a:glow rad="63500">
+              <a:srgbClr val="58F268">
+                <a:alpha val="53142"/>
+              </a:srgbClr>
+            </a:glow>
+          </a:effectLst>
+        </p:spPr>
+      </p:sp>
+      <p:sp>
+        <p:nvSpPr>
+          <p:cNvPr id="64" name="Світло рамки 2.1"/>
+          <p:cNvSpPr/>
+          <p:nvPr/>
+        </p:nvSpPr>
+        <p:spPr>
+          <a:xfrm>
+            <a:off x="3712464" y="6067044"/>
+            <a:ext cx="118872" cy="118872"/>
+          </a:xfrm>
+          <a:prstGeom prst="ellipse">
+            <a:avLst/>
+          </a:prstGeom>
+          <a:solidFill>
+            <a:srgbClr val="F2FFF3">
+              <a:alpha val="100000"/>
+            </a:srgbClr>
+          </a:solidFill>
+          <a:ln>
+            <a:noFill/>
+          </a:ln>
+          <a:effectLst>
+            <a:glow rad="101600">
+              <a:srgbClr val="58F268">
+                <a:alpha val="60000"/>
+              </a:srgbClr>
+            </a:glow>
+          </a:effectLst>
+        </p:spPr>
+      </p:sp>
+      <p:sp>
+        <p:nvSpPr>
+          <p:cNvPr id="63" name="Світло рамки 1.8"/>
+          <p:cNvSpPr/>
+          <p:nvPr/>
+        </p:nvSpPr>
+        <p:spPr>
+          <a:xfrm>
+            <a:off x="530352" y="1764792"/>
+            <a:ext cx="36576" cy="36576"/>
+          </a:xfrm>
+          <a:prstGeom prst="ellipse">
+            <a:avLst/>
+          </a:prstGeom>
+          <a:solidFill>
+            <a:srgbClr val="58F268">
+              <a:alpha val="20000"/>
+            </a:srgbClr>
+          </a:solidFill>
+          <a:ln>
+            <a:noFill/>
+          </a:ln>
+          <a:effectLst>
+            <a:glow rad="63500">
+              <a:srgbClr val="58F268">
+                <a:alpha val="12000"/>
+              </a:srgbClr>
+            </a:glow>
+          </a:effectLst>
+        </p:spPr>
+      </p:sp>
+      <p:sp>
+        <p:nvSpPr>
+          <p:cNvPr id="62" name="Світло рамки 1.7"/>
+          <p:cNvSpPr/>
+          <p:nvPr/>
+        </p:nvSpPr>
+        <p:spPr>
+          <a:xfrm>
+            <a:off x="524474" y="1758914"/>
+            <a:ext cx="48332" cy="48332"/>
+          </a:xfrm>
+          <a:prstGeom prst="ellipse">
+            <a:avLst/>
+          </a:prstGeom>
+          <a:solidFill>
+            <a:srgbClr val="58F268">
+              <a:alpha val="31428"/>
+            </a:srgbClr>
+          </a:solidFill>
+          <a:ln>
+            <a:noFill/>
+          </a:ln>
+          <a:effectLst>
+            <a:glow rad="63500">
+              <a:srgbClr val="58F268">
+                <a:alpha val="18856"/>
+              </a:srgbClr>
+            </a:glow>
+          </a:effectLst>
+        </p:spPr>
+      </p:sp>
+      <p:sp>
+        <p:nvSpPr>
+          <p:cNvPr id="61" name="Світло рамки 1.6"/>
+          <p:cNvSpPr/>
+          <p:nvPr/>
+        </p:nvSpPr>
+        <p:spPr>
+          <a:xfrm>
+            <a:off x="518596" y="1753036"/>
+            <a:ext cx="60089" cy="60089"/>
+          </a:xfrm>
+          <a:prstGeom prst="ellipse">
+            <a:avLst/>
+          </a:prstGeom>
+          <a:solidFill>
+            <a:srgbClr val="58F268">
+              <a:alpha val="42857"/>
+            </a:srgbClr>
+          </a:solidFill>
+          <a:ln>
+            <a:noFill/>
+          </a:ln>
+          <a:effectLst>
+            <a:glow rad="63500">
+              <a:srgbClr val="58F268">
+                <a:alpha val="25714"/>
+              </a:srgbClr>
+            </a:glow>
+          </a:effectLst>
+        </p:spPr>
+      </p:sp>
+      <p:sp>
+        <p:nvSpPr>
+          <p:cNvPr id="60" name="Світло рамки 1.5"/>
+          <p:cNvSpPr/>
+          <p:nvPr/>
+        </p:nvSpPr>
+        <p:spPr>
+          <a:xfrm>
+            <a:off x="512718" y="1747158"/>
+            <a:ext cx="71845" cy="71845"/>
+          </a:xfrm>
+          <a:prstGeom prst="ellipse">
+            <a:avLst/>
+          </a:prstGeom>
+          <a:solidFill>
+            <a:srgbClr val="58F268">
+              <a:alpha val="54285"/>
+            </a:srgbClr>
+          </a:solidFill>
+          <a:ln>
+            <a:noFill/>
+          </a:ln>
+          <a:effectLst>
+            <a:glow rad="63500">
+              <a:srgbClr val="58F268">
+                <a:alpha val="32571"/>
+              </a:srgbClr>
+            </a:glow>
+          </a:effectLst>
+        </p:spPr>
+      </p:sp>
+      <p:sp>
+        <p:nvSpPr>
+          <p:cNvPr id="59" name="Світло рамки 1.4"/>
+          <p:cNvSpPr/>
+          <p:nvPr/>
+        </p:nvSpPr>
+        <p:spPr>
+          <a:xfrm>
+            <a:off x="506839" y="1741279"/>
+            <a:ext cx="83602" cy="83602"/>
+          </a:xfrm>
+          <a:prstGeom prst="ellipse">
+            <a:avLst/>
+          </a:prstGeom>
+          <a:solidFill>
+            <a:srgbClr val="58F268">
+              <a:alpha val="65714"/>
+            </a:srgbClr>
+          </a:solidFill>
+          <a:ln>
+            <a:noFill/>
+          </a:ln>
+          <a:effectLst>
+            <a:glow rad="63500">
+              <a:srgbClr val="58F268">
+                <a:alpha val="39428"/>
+              </a:srgbClr>
+            </a:glow>
+          </a:effectLst>
+        </p:spPr>
+      </p:sp>
+      <p:sp>
+        <p:nvSpPr>
+          <p:cNvPr id="58" name="Світло рамки 1.3"/>
+          <p:cNvSpPr/>
+          <p:nvPr/>
+        </p:nvSpPr>
+        <p:spPr>
+          <a:xfrm>
+            <a:off x="500961" y="1735401"/>
+            <a:ext cx="95358" cy="95358"/>
+          </a:xfrm>
+          <a:prstGeom prst="ellipse">
+            <a:avLst/>
+          </a:prstGeom>
+          <a:solidFill>
+            <a:srgbClr val="58F268">
+              <a:alpha val="77142"/>
+            </a:srgbClr>
+          </a:solidFill>
+          <a:ln>
+            <a:noFill/>
+          </a:ln>
+          <a:effectLst>
+            <a:glow rad="63500">
+              <a:srgbClr val="58F268">
+                <a:alpha val="46285"/>
+              </a:srgbClr>
+            </a:glow>
+          </a:effectLst>
+        </p:spPr>
+      </p:sp>
+      <p:sp>
+        <p:nvSpPr>
+          <p:cNvPr id="57" name="Світло рамки 1.2"/>
+          <p:cNvSpPr/>
+          <p:nvPr/>
+        </p:nvSpPr>
+        <p:spPr>
+          <a:xfrm>
+            <a:off x="495083" y="1729523"/>
+            <a:ext cx="107115" cy="107115"/>
+          </a:xfrm>
+          <a:prstGeom prst="ellipse">
+            <a:avLst/>
+          </a:prstGeom>
+          <a:solidFill>
+            <a:srgbClr val="58F268">
+              <a:alpha val="88571"/>
+            </a:srgbClr>
+          </a:solidFill>
+          <a:ln>
+            <a:noFill/>
+          </a:ln>
+          <a:effectLst>
+            <a:glow rad="63500">
+              <a:srgbClr val="58F268">
+                <a:alpha val="53142"/>
+              </a:srgbClr>
+            </a:glow>
+          </a:effectLst>
+        </p:spPr>
+      </p:sp>
+      <p:sp>
+        <p:nvSpPr>
+          <p:cNvPr id="56" name="Світло рамки 1.1"/>
+          <p:cNvSpPr/>
+          <p:nvPr/>
+        </p:nvSpPr>
+        <p:spPr>
+          <a:xfrm>
+            <a:off x="489204" y="1723644"/>
+            <a:ext cx="118872" cy="118872"/>
+          </a:xfrm>
+          <a:prstGeom prst="ellipse">
+            <a:avLst/>
+          </a:prstGeom>
+          <a:solidFill>
+            <a:srgbClr val="F2FFF3">
+              <a:alpha val="100000"/>
+            </a:srgbClr>
+          </a:solidFill>
+          <a:ln>
+            <a:noFill/>
+          </a:ln>
+          <a:effectLst>
+            <a:glow rad="101600">
+              <a:srgbClr val="58F268">
+                <a:alpha val="60000"/>
+              </a:srgbClr>
+            </a:glow>
+          </a:effectLst>
+        </p:spPr>
+      </p:sp>
+      <p:sp>
+        <p:nvSpPr>
           <p:cNvPr id="6" name="Кути коміксу 01 кут 1"/>
           <p:cNvSpPr/>
           <p:nvPr/>
@@ -4558,6 +5054,409 @@
   <p:clrMapOvr>
     <a:masterClrMapping/>
   </p:clrMapOvr>
+  <p:timing>
+    <p:tnLst>
+      <p:par>
+        <p:cTn id="1" dur="indefinite" restart="never" nodeType="tmRoot">
+          <p:childTnLst>
+            <p:seq concurrent="1" nextAc="seek">
+              <p:cTn id="2" dur="indefinite" nodeType="mainSeq">
+                <p:childTnLst>
+                  <p:par>
+                    <p:cTn id="3" fill="hold">
+                      <p:stCondLst>
+                        <p:cond delay="indefinite"/>
+                        <p:cond evt="onBegin" delay="0">
+                          <p:tn val="2"/>
+                        </p:cond>
+                      </p:stCondLst>
+                      <p:childTnLst>
+                        <p:par>
+                          <p:cTn id="4" fill="hold">
+                            <p:stCondLst>
+                              <p:cond delay="0"/>
+                            </p:stCondLst>
+                            <p:childTnLst>
+                              <p:par>
+                                <p:cTn id="5" presetID="0" presetClass="path" presetSubtype="0" repeatCount="indefinite" accel="0" decel="0" fill="hold" nodeType="withEffect">
+                                  <p:stCondLst>
+                                    <p:cond delay="0"/>
+                                  </p:stCondLst>
+                                  <p:childTnLst>
+                                    <p:animMotion origin="layout" path="M 0 0 L 0.26438 0 L 0.26438 0.63333 L 0 0.63333 L 0 0 E" pathEditMode="relative" rAng="0" ptsTypes="AAAAA">
+                                      <p:cBhvr>
+                                        <p:cTn id="6" dur="5503" fill="hold"/>
+                                        <p:tgtEl>
+                                          <p:spTgt spid="56"/>
+                                        </p:tgtEl>
+                                        <p:attrNameLst>
+                                          <p:attrName>ppt_x</p:attrName>
+                                          <p:attrName>ppt_y</p:attrName>
+                                        </p:attrNameLst>
+                                      </p:cBhvr>
+                                      <p:rCtr x="0" y="0"/>
+                                    </p:animMotion>
+                                  </p:childTnLst>
+                                </p:cTn>
+                              </p:par>
+                              <p:par>
+                                <p:cTn id="7" presetID="0" presetClass="path" presetSubtype="0" repeatCount="indefinite" accel="0" decel="0" fill="hold" nodeType="withEffect">
+                                  <p:stCondLst>
+                                    <p:cond delay="55"/>
+                                  </p:stCondLst>
+                                  <p:childTnLst>
+                                    <p:animMotion origin="layout" path="M 0 0 L 0.26438 0 L 0.26438 0.63333 L 0 0.63333 L 0 0 E" pathEditMode="relative" rAng="0" ptsTypes="AAAAA">
+                                      <p:cBhvr>
+                                        <p:cTn id="8" dur="5503" fill="hold"/>
+                                        <p:tgtEl>
+                                          <p:spTgt spid="57"/>
+                                        </p:tgtEl>
+                                        <p:attrNameLst>
+                                          <p:attrName>ppt_x</p:attrName>
+                                          <p:attrName>ppt_y</p:attrName>
+                                        </p:attrNameLst>
+                                      </p:cBhvr>
+                                      <p:rCtr x="0" y="0"/>
+                                    </p:animMotion>
+                                  </p:childTnLst>
+                                </p:cTn>
+                              </p:par>
+                              <p:par>
+                                <p:cTn id="9" presetID="0" presetClass="path" presetSubtype="0" repeatCount="indefinite" accel="0" decel="0" fill="hold" nodeType="withEffect">
+                                  <p:stCondLst>
+                                    <p:cond delay="110"/>
+                                  </p:stCondLst>
+                                  <p:childTnLst>
+                                    <p:animMotion origin="layout" path="M 0 0 L 0.26438 0 L 0.26438 0.63333 L 0 0.63333 L 0 0 E" pathEditMode="relative" rAng="0" ptsTypes="AAAAA">
+                                      <p:cBhvr>
+                                        <p:cTn id="10" dur="5503" fill="hold"/>
+                                        <p:tgtEl>
+                                          <p:spTgt spid="58"/>
+                                        </p:tgtEl>
+                                        <p:attrNameLst>
+                                          <p:attrName>ppt_x</p:attrName>
+                                          <p:attrName>ppt_y</p:attrName>
+                                        </p:attrNameLst>
+                                      </p:cBhvr>
+                                      <p:rCtr x="0" y="0"/>
+                                    </p:animMotion>
+                                  </p:childTnLst>
+                                </p:cTn>
+                              </p:par>
+                              <p:par>
+                                <p:cTn id="11" presetID="0" presetClass="path" presetSubtype="0" repeatCount="indefinite" accel="0" decel="0" fill="hold" nodeType="withEffect">
+                                  <p:stCondLst>
+                                    <p:cond delay="165"/>
+                                  </p:stCondLst>
+                                  <p:childTnLst>
+                                    <p:animMotion origin="layout" path="M 0 0 L 0.26438 0 L 0.26438 0.63333 L 0 0.63333 L 0 0 E" pathEditMode="relative" rAng="0" ptsTypes="AAAAA">
+                                      <p:cBhvr>
+                                        <p:cTn id="12" dur="5503" fill="hold"/>
+                                        <p:tgtEl>
+                                          <p:spTgt spid="59"/>
+                                        </p:tgtEl>
+                                        <p:attrNameLst>
+                                          <p:attrName>ppt_x</p:attrName>
+                                          <p:attrName>ppt_y</p:attrName>
+                                        </p:attrNameLst>
+                                      </p:cBhvr>
+                                      <p:rCtr x="0" y="0"/>
+                                    </p:animMotion>
+                                  </p:childTnLst>
+                                </p:cTn>
+                              </p:par>
+                              <p:par>
+                                <p:cTn id="13" presetID="0" presetClass="path" presetSubtype="0" repeatCount="indefinite" accel="0" decel="0" fill="hold" nodeType="withEffect">
+                                  <p:stCondLst>
+                                    <p:cond delay="220"/>
+                                  </p:stCondLst>
+                                  <p:childTnLst>
+                                    <p:animMotion origin="layout" path="M 0 0 L 0.26438 0 L 0.26438 0.63333 L 0 0.63333 L 0 0 E" pathEditMode="relative" rAng="0" ptsTypes="AAAAA">
+                                      <p:cBhvr>
+                                        <p:cTn id="14" dur="5503" fill="hold"/>
+                                        <p:tgtEl>
+                                          <p:spTgt spid="60"/>
+                                        </p:tgtEl>
+                                        <p:attrNameLst>
+                                          <p:attrName>ppt_x</p:attrName>
+                                          <p:attrName>ppt_y</p:attrName>
+                                        </p:attrNameLst>
+                                      </p:cBhvr>
+                                      <p:rCtr x="0" y="0"/>
+                                    </p:animMotion>
+                                  </p:childTnLst>
+                                </p:cTn>
+                              </p:par>
+                              <p:par>
+                                <p:cTn id="15" presetID="0" presetClass="path" presetSubtype="0" repeatCount="indefinite" accel="0" decel="0" fill="hold" nodeType="withEffect">
+                                  <p:stCondLst>
+                                    <p:cond delay="275"/>
+                                  </p:stCondLst>
+                                  <p:childTnLst>
+                                    <p:animMotion origin="layout" path="M 0 0 L 0.26438 0 L 0.26438 0.63333 L 0 0.63333 L 0 0 E" pathEditMode="relative" rAng="0" ptsTypes="AAAAA">
+                                      <p:cBhvr>
+                                        <p:cTn id="16" dur="5503" fill="hold"/>
+                                        <p:tgtEl>
+                                          <p:spTgt spid="61"/>
+                                        </p:tgtEl>
+                                        <p:attrNameLst>
+                                          <p:attrName>ppt_x</p:attrName>
+                                          <p:attrName>ppt_y</p:attrName>
+                                        </p:attrNameLst>
+                                      </p:cBhvr>
+                                      <p:rCtr x="0" y="0"/>
+                                    </p:animMotion>
+                                  </p:childTnLst>
+                                </p:cTn>
+                              </p:par>
+                              <p:par>
+                                <p:cTn id="17" presetID="0" presetClass="path" presetSubtype="0" repeatCount="indefinite" accel="0" decel="0" fill="hold" nodeType="withEffect">
+                                  <p:stCondLst>
+                                    <p:cond delay="330"/>
+                                  </p:stCondLst>
+                                  <p:childTnLst>
+                                    <p:animMotion origin="layout" path="M 0 0 L 0.26438 0 L 0.26438 0.63333 L 0 0.63333 L 0 0 E" pathEditMode="relative" rAng="0" ptsTypes="AAAAA">
+                                      <p:cBhvr>
+                                        <p:cTn id="18" dur="5503" fill="hold"/>
+                                        <p:tgtEl>
+                                          <p:spTgt spid="62"/>
+                                        </p:tgtEl>
+                                        <p:attrNameLst>
+                                          <p:attrName>ppt_x</p:attrName>
+                                          <p:attrName>ppt_y</p:attrName>
+                                        </p:attrNameLst>
+                                      </p:cBhvr>
+                                      <p:rCtr x="0" y="0"/>
+                                    </p:animMotion>
+                                  </p:childTnLst>
+                                </p:cTn>
+                              </p:par>
+                              <p:par>
+                                <p:cTn id="19" presetID="0" presetClass="path" presetSubtype="0" repeatCount="indefinite" accel="0" decel="0" fill="hold" nodeType="withEffect">
+                                  <p:stCondLst>
+                                    <p:cond delay="385"/>
+                                  </p:stCondLst>
+                                  <p:childTnLst>
+                                    <p:animMotion origin="layout" path="M 0 0 L 0.26438 0 L 0.26438 0.63333 L 0 0.63333 L 0 0 E" pathEditMode="relative" rAng="0" ptsTypes="AAAAA">
+                                      <p:cBhvr>
+                                        <p:cTn id="20" dur="5503" fill="hold"/>
+                                        <p:tgtEl>
+                                          <p:spTgt spid="63"/>
+                                        </p:tgtEl>
+                                        <p:attrNameLst>
+                                          <p:attrName>ppt_x</p:attrName>
+                                          <p:attrName>ppt_y</p:attrName>
+                                        </p:attrNameLst>
+                                      </p:cBhvr>
+                                      <p:rCtr x="0" y="0"/>
+                                    </p:animMotion>
+                                  </p:childTnLst>
+                                </p:cTn>
+                              </p:par>
+                              <p:par>
+                                <p:cTn id="21" presetID="0" presetClass="path" presetSubtype="0" repeatCount="indefinite" accel="0" decel="0" fill="hold" nodeType="withEffect">
+                                  <p:stCondLst>
+                                    <p:cond delay="0"/>
+                                  </p:stCondLst>
+                                  <p:childTnLst>
+                                    <p:animMotion origin="layout" path="M 0 0 L -0.26438 0 L -0.26438 -0.63333 L 0 -0.63333 L 0 0 E" pathEditMode="relative" rAng="0" ptsTypes="AAAAA">
+                                      <p:cBhvr>
+                                        <p:cTn id="22" dur="5503" fill="hold"/>
+                                        <p:tgtEl>
+                                          <p:spTgt spid="64"/>
+                                        </p:tgtEl>
+                                        <p:attrNameLst>
+                                          <p:attrName>ppt_x</p:attrName>
+                                          <p:attrName>ppt_y</p:attrName>
+                                        </p:attrNameLst>
+                                      </p:cBhvr>
+                                      <p:rCtr x="0" y="0"/>
+                                    </p:animMotion>
+                                  </p:childTnLst>
+                                </p:cTn>
+                              </p:par>
+                              <p:par>
+                                <p:cTn id="23" presetID="0" presetClass="path" presetSubtype="0" repeatCount="indefinite" accel="0" decel="0" fill="hold" nodeType="withEffect">
+                                  <p:stCondLst>
+                                    <p:cond delay="55"/>
+                                  </p:stCondLst>
+                                  <p:childTnLst>
+                                    <p:animMotion origin="layout" path="M 0 0 L -0.26438 0 L -0.26438 -0.63333 L 0 -0.63333 L 0 0 E" pathEditMode="relative" rAng="0" ptsTypes="AAAAA">
+                                      <p:cBhvr>
+                                        <p:cTn id="24" dur="5503" fill="hold"/>
+                                        <p:tgtEl>
+                                          <p:spTgt spid="65"/>
+                                        </p:tgtEl>
+                                        <p:attrNameLst>
+                                          <p:attrName>ppt_x</p:attrName>
+                                          <p:attrName>ppt_y</p:attrName>
+                                        </p:attrNameLst>
+                                      </p:cBhvr>
+                                      <p:rCtr x="0" y="0"/>
+                                    </p:animMotion>
+                                  </p:childTnLst>
+                                </p:cTn>
+                              </p:par>
+                              <p:par>
+                                <p:cTn id="25" presetID="0" presetClass="path" presetSubtype="0" repeatCount="indefinite" accel="0" decel="0" fill="hold" nodeType="withEffect">
+                                  <p:stCondLst>
+                                    <p:cond delay="110"/>
+                                  </p:stCondLst>
+                                  <p:childTnLst>
+                                    <p:animMotion origin="layout" path="M 0 0 L -0.26438 0 L -0.26438 -0.63333 L 0 -0.63333 L 0 0 E" pathEditMode="relative" rAng="0" ptsTypes="AAAAA">
+                                      <p:cBhvr>
+                                        <p:cTn id="26" dur="5503" fill="hold"/>
+                                        <p:tgtEl>
+                                          <p:spTgt spid="66"/>
+                                        </p:tgtEl>
+                                        <p:attrNameLst>
+                                          <p:attrName>ppt_x</p:attrName>
+                                          <p:attrName>ppt_y</p:attrName>
+                                        </p:attrNameLst>
+                                      </p:cBhvr>
+                                      <p:rCtr x="0" y="0"/>
+                                    </p:animMotion>
+                                  </p:childTnLst>
+                                </p:cTn>
+                              </p:par>
+                              <p:par>
+                                <p:cTn id="27" presetID="0" presetClass="path" presetSubtype="0" repeatCount="indefinite" accel="0" decel="0" fill="hold" nodeType="withEffect">
+                                  <p:stCondLst>
+                                    <p:cond delay="165"/>
+                                  </p:stCondLst>
+                                  <p:childTnLst>
+                                    <p:animMotion origin="layout" path="M 0 0 L -0.26438 0 L -0.26438 -0.63333 L 0 -0.63333 L 0 0 E" pathEditMode="relative" rAng="0" ptsTypes="AAAAA">
+                                      <p:cBhvr>
+                                        <p:cTn id="28" dur="5503" fill="hold"/>
+                                        <p:tgtEl>
+                                          <p:spTgt spid="67"/>
+                                        </p:tgtEl>
+                                        <p:attrNameLst>
+                                          <p:attrName>ppt_x</p:attrName>
+                                          <p:attrName>ppt_y</p:attrName>
+                                        </p:attrNameLst>
+                                      </p:cBhvr>
+                                      <p:rCtr x="0" y="0"/>
+                                    </p:animMotion>
+                                  </p:childTnLst>
+                                </p:cTn>
+                              </p:par>
+                              <p:par>
+                                <p:cTn id="29" presetID="0" presetClass="path" presetSubtype="0" repeatCount="indefinite" accel="0" decel="0" fill="hold" nodeType="withEffect">
+                                  <p:stCondLst>
+                                    <p:cond delay="220"/>
+                                  </p:stCondLst>
+                                  <p:childTnLst>
+                                    <p:animMotion origin="layout" path="M 0 0 L -0.26438 0 L -0.26438 -0.63333 L 0 -0.63333 L 0 0 E" pathEditMode="relative" rAng="0" ptsTypes="AAAAA">
+                                      <p:cBhvr>
+                                        <p:cTn id="30" dur="5503" fill="hold"/>
+                                        <p:tgtEl>
+                                          <p:spTgt spid="68"/>
+                                        </p:tgtEl>
+                                        <p:attrNameLst>
+                                          <p:attrName>ppt_x</p:attrName>
+                                          <p:attrName>ppt_y</p:attrName>
+                                        </p:attrNameLst>
+                                      </p:cBhvr>
+                                      <p:rCtr x="0" y="0"/>
+                                    </p:animMotion>
+                                  </p:childTnLst>
+                                </p:cTn>
+                              </p:par>
+                              <p:par>
+                                <p:cTn id="31" presetID="0" presetClass="path" presetSubtype="0" repeatCount="indefinite" accel="0" decel="0" fill="hold" nodeType="withEffect">
+                                  <p:stCondLst>
+                                    <p:cond delay="275"/>
+                                  </p:stCondLst>
+                                  <p:childTnLst>
+                                    <p:animMotion origin="layout" path="M 0 0 L -0.26438 0 L -0.26438 -0.63333 L 0 -0.63333 L 0 0 E" pathEditMode="relative" rAng="0" ptsTypes="AAAAA">
+                                      <p:cBhvr>
+                                        <p:cTn id="32" dur="5503" fill="hold"/>
+                                        <p:tgtEl>
+                                          <p:spTgt spid="69"/>
+                                        </p:tgtEl>
+                                        <p:attrNameLst>
+                                          <p:attrName>ppt_x</p:attrName>
+                                          <p:attrName>ppt_y</p:attrName>
+                                        </p:attrNameLst>
+                                      </p:cBhvr>
+                                      <p:rCtr x="0" y="0"/>
+                                    </p:animMotion>
+                                  </p:childTnLst>
+                                </p:cTn>
+                              </p:par>
+                              <p:par>
+                                <p:cTn id="33" presetID="0" presetClass="path" presetSubtype="0" repeatCount="indefinite" accel="0" decel="0" fill="hold" nodeType="withEffect">
+                                  <p:stCondLst>
+                                    <p:cond delay="330"/>
+                                  </p:stCondLst>
+                                  <p:childTnLst>
+                                    <p:animMotion origin="layout" path="M 0 0 L -0.26438 0 L -0.26438 -0.63333 L 0 -0.63333 L 0 0 E" pathEditMode="relative" rAng="0" ptsTypes="AAAAA">
+                                      <p:cBhvr>
+                                        <p:cTn id="34" dur="5503" fill="hold"/>
+                                        <p:tgtEl>
+                                          <p:spTgt spid="70"/>
+                                        </p:tgtEl>
+                                        <p:attrNameLst>
+                                          <p:attrName>ppt_x</p:attrName>
+                                          <p:attrName>ppt_y</p:attrName>
+                                        </p:attrNameLst>
+                                      </p:cBhvr>
+                                      <p:rCtr x="0" y="0"/>
+                                    </p:animMotion>
+                                  </p:childTnLst>
+                                </p:cTn>
+                              </p:par>
+                              <p:par>
+                                <p:cTn id="35" presetID="0" presetClass="path" presetSubtype="0" repeatCount="indefinite" accel="0" decel="0" fill="hold" nodeType="withEffect">
+                                  <p:stCondLst>
+                                    <p:cond delay="385"/>
+                                  </p:stCondLst>
+                                  <p:childTnLst>
+                                    <p:animMotion origin="layout" path="M 0 0 L -0.26438 0 L -0.26438 -0.63333 L 0 -0.63333 L 0 0 E" pathEditMode="relative" rAng="0" ptsTypes="AAAAA">
+                                      <p:cBhvr>
+                                        <p:cTn id="36" dur="5503" fill="hold"/>
+                                        <p:tgtEl>
+                                          <p:spTgt spid="71"/>
+                                        </p:tgtEl>
+                                        <p:attrNameLst>
+                                          <p:attrName>ppt_x</p:attrName>
+                                          <p:attrName>ppt_y</p:attrName>
+                                        </p:attrNameLst>
+                                      </p:cBhvr>
+                                      <p:rCtr x="0" y="0"/>
+                                    </p:animMotion>
+                                  </p:childTnLst>
+                                </p:cTn>
+                              </p:par>
+                            </p:childTnLst>
+                          </p:cTn>
+                        </p:par>
+                      </p:childTnLst>
+                    </p:cTn>
+                  </p:par>
+                </p:childTnLst>
+              </p:cTn>
+              <p:prevCondLst>
+                <p:cond evt="onPrev" delay="0">
+                  <p:tgtEl>
+                    <p:sldTgt/>
+                  </p:tgtEl>
+                </p:cond>
+              </p:prevCondLst>
+              <p:nextCondLst>
+                <p:cond evt="onNext" delay="0">
+                  <p:tgtEl>
+                    <p:sldTgt/>
+                  </p:tgtEl>
+                </p:cond>
+              </p:nextCondLst>
+            </p:seq>
+          </p:childTnLst>
+        </p:cTn>
+      </p:par>
+    </p:tnLst>
+  </p:timing>
 </p:sld>
 </file>
 
@@ -4715,6 +5614,502 @@
             <a:glow rad="26670">
               <a:srgbClr val="58F268">
                 <a:alpha val="28800"/>
+              </a:srgbClr>
+            </a:glow>
+          </a:effectLst>
+        </p:spPr>
+      </p:sp>
+      <p:sp>
+        <p:nvSpPr>
+          <p:cNvPr id="49" name="Світло рамки 2.8"/>
+          <p:cNvSpPr/>
+          <p:nvPr/>
+        </p:nvSpPr>
+        <p:spPr>
+          <a:xfrm>
+            <a:off x="3753612" y="6108192"/>
+            <a:ext cx="36576" cy="36576"/>
+          </a:xfrm>
+          <a:prstGeom prst="ellipse">
+            <a:avLst/>
+          </a:prstGeom>
+          <a:solidFill>
+            <a:srgbClr val="58F268">
+              <a:alpha val="20000"/>
+            </a:srgbClr>
+          </a:solidFill>
+          <a:ln>
+            <a:noFill/>
+          </a:ln>
+          <a:effectLst>
+            <a:glow rad="63500">
+              <a:srgbClr val="58F268">
+                <a:alpha val="12000"/>
+              </a:srgbClr>
+            </a:glow>
+          </a:effectLst>
+        </p:spPr>
+      </p:sp>
+      <p:sp>
+        <p:nvSpPr>
+          <p:cNvPr id="48" name="Світло рамки 2.7"/>
+          <p:cNvSpPr/>
+          <p:nvPr/>
+        </p:nvSpPr>
+        <p:spPr>
+          <a:xfrm>
+            <a:off x="3747734" y="6102314"/>
+            <a:ext cx="48332" cy="48332"/>
+          </a:xfrm>
+          <a:prstGeom prst="ellipse">
+            <a:avLst/>
+          </a:prstGeom>
+          <a:solidFill>
+            <a:srgbClr val="58F268">
+              <a:alpha val="31428"/>
+            </a:srgbClr>
+          </a:solidFill>
+          <a:ln>
+            <a:noFill/>
+          </a:ln>
+          <a:effectLst>
+            <a:glow rad="63500">
+              <a:srgbClr val="58F268">
+                <a:alpha val="18856"/>
+              </a:srgbClr>
+            </a:glow>
+          </a:effectLst>
+        </p:spPr>
+      </p:sp>
+      <p:sp>
+        <p:nvSpPr>
+          <p:cNvPr id="47" name="Світло рамки 2.6"/>
+          <p:cNvSpPr/>
+          <p:nvPr/>
+        </p:nvSpPr>
+        <p:spPr>
+          <a:xfrm>
+            <a:off x="3741856" y="6096436"/>
+            <a:ext cx="60089" cy="60089"/>
+          </a:xfrm>
+          <a:prstGeom prst="ellipse">
+            <a:avLst/>
+          </a:prstGeom>
+          <a:solidFill>
+            <a:srgbClr val="58F268">
+              <a:alpha val="42857"/>
+            </a:srgbClr>
+          </a:solidFill>
+          <a:ln>
+            <a:noFill/>
+          </a:ln>
+          <a:effectLst>
+            <a:glow rad="63500">
+              <a:srgbClr val="58F268">
+                <a:alpha val="25714"/>
+              </a:srgbClr>
+            </a:glow>
+          </a:effectLst>
+        </p:spPr>
+      </p:sp>
+      <p:sp>
+        <p:nvSpPr>
+          <p:cNvPr id="46" name="Світло рамки 2.5"/>
+          <p:cNvSpPr/>
+          <p:nvPr/>
+        </p:nvSpPr>
+        <p:spPr>
+          <a:xfrm>
+            <a:off x="3735978" y="6090558"/>
+            <a:ext cx="71845" cy="71845"/>
+          </a:xfrm>
+          <a:prstGeom prst="ellipse">
+            <a:avLst/>
+          </a:prstGeom>
+          <a:solidFill>
+            <a:srgbClr val="58F268">
+              <a:alpha val="54285"/>
+            </a:srgbClr>
+          </a:solidFill>
+          <a:ln>
+            <a:noFill/>
+          </a:ln>
+          <a:effectLst>
+            <a:glow rad="63500">
+              <a:srgbClr val="58F268">
+                <a:alpha val="32571"/>
+              </a:srgbClr>
+            </a:glow>
+          </a:effectLst>
+        </p:spPr>
+      </p:sp>
+      <p:sp>
+        <p:nvSpPr>
+          <p:cNvPr id="45" name="Світло рамки 2.4"/>
+          <p:cNvSpPr/>
+          <p:nvPr/>
+        </p:nvSpPr>
+        <p:spPr>
+          <a:xfrm>
+            <a:off x="3730099" y="6084679"/>
+            <a:ext cx="83602" cy="83602"/>
+          </a:xfrm>
+          <a:prstGeom prst="ellipse">
+            <a:avLst/>
+          </a:prstGeom>
+          <a:solidFill>
+            <a:srgbClr val="58F268">
+              <a:alpha val="65714"/>
+            </a:srgbClr>
+          </a:solidFill>
+          <a:ln>
+            <a:noFill/>
+          </a:ln>
+          <a:effectLst>
+            <a:glow rad="63500">
+              <a:srgbClr val="58F268">
+                <a:alpha val="39428"/>
+              </a:srgbClr>
+            </a:glow>
+          </a:effectLst>
+        </p:spPr>
+      </p:sp>
+      <p:sp>
+        <p:nvSpPr>
+          <p:cNvPr id="44" name="Світло рамки 2.3"/>
+          <p:cNvSpPr/>
+          <p:nvPr/>
+        </p:nvSpPr>
+        <p:spPr>
+          <a:xfrm>
+            <a:off x="3724221" y="6078801"/>
+            <a:ext cx="95358" cy="95358"/>
+          </a:xfrm>
+          <a:prstGeom prst="ellipse">
+            <a:avLst/>
+          </a:prstGeom>
+          <a:solidFill>
+            <a:srgbClr val="58F268">
+              <a:alpha val="77142"/>
+            </a:srgbClr>
+          </a:solidFill>
+          <a:ln>
+            <a:noFill/>
+          </a:ln>
+          <a:effectLst>
+            <a:glow rad="63500">
+              <a:srgbClr val="58F268">
+                <a:alpha val="46285"/>
+              </a:srgbClr>
+            </a:glow>
+          </a:effectLst>
+        </p:spPr>
+      </p:sp>
+      <p:sp>
+        <p:nvSpPr>
+          <p:cNvPr id="43" name="Світло рамки 2.2"/>
+          <p:cNvSpPr/>
+          <p:nvPr/>
+        </p:nvSpPr>
+        <p:spPr>
+          <a:xfrm>
+            <a:off x="3718343" y="6072923"/>
+            <a:ext cx="107115" cy="107115"/>
+          </a:xfrm>
+          <a:prstGeom prst="ellipse">
+            <a:avLst/>
+          </a:prstGeom>
+          <a:solidFill>
+            <a:srgbClr val="58F268">
+              <a:alpha val="88571"/>
+            </a:srgbClr>
+          </a:solidFill>
+          <a:ln>
+            <a:noFill/>
+          </a:ln>
+          <a:effectLst>
+            <a:glow rad="63500">
+              <a:srgbClr val="58F268">
+                <a:alpha val="53142"/>
+              </a:srgbClr>
+            </a:glow>
+          </a:effectLst>
+        </p:spPr>
+      </p:sp>
+      <p:sp>
+        <p:nvSpPr>
+          <p:cNvPr id="42" name="Світло рамки 2.1"/>
+          <p:cNvSpPr/>
+          <p:nvPr/>
+        </p:nvSpPr>
+        <p:spPr>
+          <a:xfrm>
+            <a:off x="3712464" y="6067044"/>
+            <a:ext cx="118872" cy="118872"/>
+          </a:xfrm>
+          <a:prstGeom prst="ellipse">
+            <a:avLst/>
+          </a:prstGeom>
+          <a:solidFill>
+            <a:srgbClr val="F2FFF3">
+              <a:alpha val="100000"/>
+            </a:srgbClr>
+          </a:solidFill>
+          <a:ln>
+            <a:noFill/>
+          </a:ln>
+          <a:effectLst>
+            <a:glow rad="101600">
+              <a:srgbClr val="58F268">
+                <a:alpha val="60000"/>
+              </a:srgbClr>
+            </a:glow>
+          </a:effectLst>
+        </p:spPr>
+      </p:sp>
+      <p:sp>
+        <p:nvSpPr>
+          <p:cNvPr id="41" name="Світло рамки 1.8"/>
+          <p:cNvSpPr/>
+          <p:nvPr/>
+        </p:nvSpPr>
+        <p:spPr>
+          <a:xfrm>
+            <a:off x="530352" y="1764792"/>
+            <a:ext cx="36576" cy="36576"/>
+          </a:xfrm>
+          <a:prstGeom prst="ellipse">
+            <a:avLst/>
+          </a:prstGeom>
+          <a:solidFill>
+            <a:srgbClr val="58F268">
+              <a:alpha val="20000"/>
+            </a:srgbClr>
+          </a:solidFill>
+          <a:ln>
+            <a:noFill/>
+          </a:ln>
+          <a:effectLst>
+            <a:glow rad="63500">
+              <a:srgbClr val="58F268">
+                <a:alpha val="12000"/>
+              </a:srgbClr>
+            </a:glow>
+          </a:effectLst>
+        </p:spPr>
+      </p:sp>
+      <p:sp>
+        <p:nvSpPr>
+          <p:cNvPr id="40" name="Світло рамки 1.7"/>
+          <p:cNvSpPr/>
+          <p:nvPr/>
+        </p:nvSpPr>
+        <p:spPr>
+          <a:xfrm>
+            <a:off x="524474" y="1758914"/>
+            <a:ext cx="48332" cy="48332"/>
+          </a:xfrm>
+          <a:prstGeom prst="ellipse">
+            <a:avLst/>
+          </a:prstGeom>
+          <a:solidFill>
+            <a:srgbClr val="58F268">
+              <a:alpha val="31428"/>
+            </a:srgbClr>
+          </a:solidFill>
+          <a:ln>
+            <a:noFill/>
+          </a:ln>
+          <a:effectLst>
+            <a:glow rad="63500">
+              <a:srgbClr val="58F268">
+                <a:alpha val="18856"/>
+              </a:srgbClr>
+            </a:glow>
+          </a:effectLst>
+        </p:spPr>
+      </p:sp>
+      <p:sp>
+        <p:nvSpPr>
+          <p:cNvPr id="39" name="Світло рамки 1.6"/>
+          <p:cNvSpPr/>
+          <p:nvPr/>
+        </p:nvSpPr>
+        <p:spPr>
+          <a:xfrm>
+            <a:off x="518596" y="1753036"/>
+            <a:ext cx="60089" cy="60089"/>
+          </a:xfrm>
+          <a:prstGeom prst="ellipse">
+            <a:avLst/>
+          </a:prstGeom>
+          <a:solidFill>
+            <a:srgbClr val="58F268">
+              <a:alpha val="42857"/>
+            </a:srgbClr>
+          </a:solidFill>
+          <a:ln>
+            <a:noFill/>
+          </a:ln>
+          <a:effectLst>
+            <a:glow rad="63500">
+              <a:srgbClr val="58F268">
+                <a:alpha val="25714"/>
+              </a:srgbClr>
+            </a:glow>
+          </a:effectLst>
+        </p:spPr>
+      </p:sp>
+      <p:sp>
+        <p:nvSpPr>
+          <p:cNvPr id="38" name="Світло рамки 1.5"/>
+          <p:cNvSpPr/>
+          <p:nvPr/>
+        </p:nvSpPr>
+        <p:spPr>
+          <a:xfrm>
+            <a:off x="512718" y="1747158"/>
+            <a:ext cx="71845" cy="71845"/>
+          </a:xfrm>
+          <a:prstGeom prst="ellipse">
+            <a:avLst/>
+          </a:prstGeom>
+          <a:solidFill>
+            <a:srgbClr val="58F268">
+              <a:alpha val="54285"/>
+            </a:srgbClr>
+          </a:solidFill>
+          <a:ln>
+            <a:noFill/>
+          </a:ln>
+          <a:effectLst>
+            <a:glow rad="63500">
+              <a:srgbClr val="58F268">
+                <a:alpha val="32571"/>
+              </a:srgbClr>
+            </a:glow>
+          </a:effectLst>
+        </p:spPr>
+      </p:sp>
+      <p:sp>
+        <p:nvSpPr>
+          <p:cNvPr id="37" name="Світло рамки 1.4"/>
+          <p:cNvSpPr/>
+          <p:nvPr/>
+        </p:nvSpPr>
+        <p:spPr>
+          <a:xfrm>
+            <a:off x="506839" y="1741279"/>
+            <a:ext cx="83602" cy="83602"/>
+          </a:xfrm>
+          <a:prstGeom prst="ellipse">
+            <a:avLst/>
+          </a:prstGeom>
+          <a:solidFill>
+            <a:srgbClr val="58F268">
+              <a:alpha val="65714"/>
+            </a:srgbClr>
+          </a:solidFill>
+          <a:ln>
+            <a:noFill/>
+          </a:ln>
+          <a:effectLst>
+            <a:glow rad="63500">
+              <a:srgbClr val="58F268">
+                <a:alpha val="39428"/>
+              </a:srgbClr>
+            </a:glow>
+          </a:effectLst>
+        </p:spPr>
+      </p:sp>
+      <p:sp>
+        <p:nvSpPr>
+          <p:cNvPr id="36" name="Світло рамки 1.3"/>
+          <p:cNvSpPr/>
+          <p:nvPr/>
+        </p:nvSpPr>
+        <p:spPr>
+          <a:xfrm>
+            <a:off x="500961" y="1735401"/>
+            <a:ext cx="95358" cy="95358"/>
+          </a:xfrm>
+          <a:prstGeom prst="ellipse">
+            <a:avLst/>
+          </a:prstGeom>
+          <a:solidFill>
+            <a:srgbClr val="58F268">
+              <a:alpha val="77142"/>
+            </a:srgbClr>
+          </a:solidFill>
+          <a:ln>
+            <a:noFill/>
+          </a:ln>
+          <a:effectLst>
+            <a:glow rad="63500">
+              <a:srgbClr val="58F268">
+                <a:alpha val="46285"/>
+              </a:srgbClr>
+            </a:glow>
+          </a:effectLst>
+        </p:spPr>
+      </p:sp>
+      <p:sp>
+        <p:nvSpPr>
+          <p:cNvPr id="35" name="Світло рамки 1.2"/>
+          <p:cNvSpPr/>
+          <p:nvPr/>
+        </p:nvSpPr>
+        <p:spPr>
+          <a:xfrm>
+            <a:off x="495083" y="1729523"/>
+            <a:ext cx="107115" cy="107115"/>
+          </a:xfrm>
+          <a:prstGeom prst="ellipse">
+            <a:avLst/>
+          </a:prstGeom>
+          <a:solidFill>
+            <a:srgbClr val="58F268">
+              <a:alpha val="88571"/>
+            </a:srgbClr>
+          </a:solidFill>
+          <a:ln>
+            <a:noFill/>
+          </a:ln>
+          <a:effectLst>
+            <a:glow rad="63500">
+              <a:srgbClr val="58F268">
+                <a:alpha val="53142"/>
+              </a:srgbClr>
+            </a:glow>
+          </a:effectLst>
+        </p:spPr>
+      </p:sp>
+      <p:sp>
+        <p:nvSpPr>
+          <p:cNvPr id="34" name="Світло рамки 1.1"/>
+          <p:cNvSpPr/>
+          <p:nvPr/>
+        </p:nvSpPr>
+        <p:spPr>
+          <a:xfrm>
+            <a:off x="489204" y="1723644"/>
+            <a:ext cx="118872" cy="118872"/>
+          </a:xfrm>
+          <a:prstGeom prst="ellipse">
+            <a:avLst/>
+          </a:prstGeom>
+          <a:solidFill>
+            <a:srgbClr val="F2FFF3">
+              <a:alpha val="100000"/>
+            </a:srgbClr>
+          </a:solidFill>
+          <a:ln>
+            <a:noFill/>
+          </a:ln>
+          <a:effectLst>
+            <a:glow rad="101600">
+              <a:srgbClr val="58F268">
+                <a:alpha val="60000"/>
               </a:srgbClr>
             </a:glow>
           </a:effectLst>
@@ -5730,6 +7125,409 @@
   <p:clrMapOvr>
     <a:masterClrMapping/>
   </p:clrMapOvr>
+  <p:timing>
+    <p:tnLst>
+      <p:par>
+        <p:cTn id="1" dur="indefinite" restart="never" nodeType="tmRoot">
+          <p:childTnLst>
+            <p:seq concurrent="1" nextAc="seek">
+              <p:cTn id="2" dur="indefinite" nodeType="mainSeq">
+                <p:childTnLst>
+                  <p:par>
+                    <p:cTn id="3" fill="hold">
+                      <p:stCondLst>
+                        <p:cond delay="indefinite"/>
+                        <p:cond evt="onBegin" delay="0">
+                          <p:tn val="2"/>
+                        </p:cond>
+                      </p:stCondLst>
+                      <p:childTnLst>
+                        <p:par>
+                          <p:cTn id="4" fill="hold">
+                            <p:stCondLst>
+                              <p:cond delay="0"/>
+                            </p:stCondLst>
+                            <p:childTnLst>
+                              <p:par>
+                                <p:cTn id="5" presetID="0" presetClass="path" presetSubtype="0" repeatCount="indefinite" accel="0" decel="0" fill="hold" nodeType="withEffect">
+                                  <p:stCondLst>
+                                    <p:cond delay="0"/>
+                                  </p:stCondLst>
+                                  <p:childTnLst>
+                                    <p:animMotion origin="layout" path="M 0 0 L 0.26438 0 L 0.26438 0.63333 L 0 0.63333 L 0 0 E" pathEditMode="relative" rAng="0" ptsTypes="AAAAA">
+                                      <p:cBhvr>
+                                        <p:cTn id="6" dur="5503" fill="hold"/>
+                                        <p:tgtEl>
+                                          <p:spTgt spid="34"/>
+                                        </p:tgtEl>
+                                        <p:attrNameLst>
+                                          <p:attrName>ppt_x</p:attrName>
+                                          <p:attrName>ppt_y</p:attrName>
+                                        </p:attrNameLst>
+                                      </p:cBhvr>
+                                      <p:rCtr x="0" y="0"/>
+                                    </p:animMotion>
+                                  </p:childTnLst>
+                                </p:cTn>
+                              </p:par>
+                              <p:par>
+                                <p:cTn id="7" presetID="0" presetClass="path" presetSubtype="0" repeatCount="indefinite" accel="0" decel="0" fill="hold" nodeType="withEffect">
+                                  <p:stCondLst>
+                                    <p:cond delay="55"/>
+                                  </p:stCondLst>
+                                  <p:childTnLst>
+                                    <p:animMotion origin="layout" path="M 0 0 L 0.26438 0 L 0.26438 0.63333 L 0 0.63333 L 0 0 E" pathEditMode="relative" rAng="0" ptsTypes="AAAAA">
+                                      <p:cBhvr>
+                                        <p:cTn id="8" dur="5503" fill="hold"/>
+                                        <p:tgtEl>
+                                          <p:spTgt spid="35"/>
+                                        </p:tgtEl>
+                                        <p:attrNameLst>
+                                          <p:attrName>ppt_x</p:attrName>
+                                          <p:attrName>ppt_y</p:attrName>
+                                        </p:attrNameLst>
+                                      </p:cBhvr>
+                                      <p:rCtr x="0" y="0"/>
+                                    </p:animMotion>
+                                  </p:childTnLst>
+                                </p:cTn>
+                              </p:par>
+                              <p:par>
+                                <p:cTn id="9" presetID="0" presetClass="path" presetSubtype="0" repeatCount="indefinite" accel="0" decel="0" fill="hold" nodeType="withEffect">
+                                  <p:stCondLst>
+                                    <p:cond delay="110"/>
+                                  </p:stCondLst>
+                                  <p:childTnLst>
+                                    <p:animMotion origin="layout" path="M 0 0 L 0.26438 0 L 0.26438 0.63333 L 0 0.63333 L 0 0 E" pathEditMode="relative" rAng="0" ptsTypes="AAAAA">
+                                      <p:cBhvr>
+                                        <p:cTn id="10" dur="5503" fill="hold"/>
+                                        <p:tgtEl>
+                                          <p:spTgt spid="36"/>
+                                        </p:tgtEl>
+                                        <p:attrNameLst>
+                                          <p:attrName>ppt_x</p:attrName>
+                                          <p:attrName>ppt_y</p:attrName>
+                                        </p:attrNameLst>
+                                      </p:cBhvr>
+                                      <p:rCtr x="0" y="0"/>
+                                    </p:animMotion>
+                                  </p:childTnLst>
+                                </p:cTn>
+                              </p:par>
+                              <p:par>
+                                <p:cTn id="11" presetID="0" presetClass="path" presetSubtype="0" repeatCount="indefinite" accel="0" decel="0" fill="hold" nodeType="withEffect">
+                                  <p:stCondLst>
+                                    <p:cond delay="165"/>
+                                  </p:stCondLst>
+                                  <p:childTnLst>
+                                    <p:animMotion origin="layout" path="M 0 0 L 0.26438 0 L 0.26438 0.63333 L 0 0.63333 L 0 0 E" pathEditMode="relative" rAng="0" ptsTypes="AAAAA">
+                                      <p:cBhvr>
+                                        <p:cTn id="12" dur="5503" fill="hold"/>
+                                        <p:tgtEl>
+                                          <p:spTgt spid="37"/>
+                                        </p:tgtEl>
+                                        <p:attrNameLst>
+                                          <p:attrName>ppt_x</p:attrName>
+                                          <p:attrName>ppt_y</p:attrName>
+                                        </p:attrNameLst>
+                                      </p:cBhvr>
+                                      <p:rCtr x="0" y="0"/>
+                                    </p:animMotion>
+                                  </p:childTnLst>
+                                </p:cTn>
+                              </p:par>
+                              <p:par>
+                                <p:cTn id="13" presetID="0" presetClass="path" presetSubtype="0" repeatCount="indefinite" accel="0" decel="0" fill="hold" nodeType="withEffect">
+                                  <p:stCondLst>
+                                    <p:cond delay="220"/>
+                                  </p:stCondLst>
+                                  <p:childTnLst>
+                                    <p:animMotion origin="layout" path="M 0 0 L 0.26438 0 L 0.26438 0.63333 L 0 0.63333 L 0 0 E" pathEditMode="relative" rAng="0" ptsTypes="AAAAA">
+                                      <p:cBhvr>
+                                        <p:cTn id="14" dur="5503" fill="hold"/>
+                                        <p:tgtEl>
+                                          <p:spTgt spid="38"/>
+                                        </p:tgtEl>
+                                        <p:attrNameLst>
+                                          <p:attrName>ppt_x</p:attrName>
+                                          <p:attrName>ppt_y</p:attrName>
+                                        </p:attrNameLst>
+                                      </p:cBhvr>
+                                      <p:rCtr x="0" y="0"/>
+                                    </p:animMotion>
+                                  </p:childTnLst>
+                                </p:cTn>
+                              </p:par>
+                              <p:par>
+                                <p:cTn id="15" presetID="0" presetClass="path" presetSubtype="0" repeatCount="indefinite" accel="0" decel="0" fill="hold" nodeType="withEffect">
+                                  <p:stCondLst>
+                                    <p:cond delay="275"/>
+                                  </p:stCondLst>
+                                  <p:childTnLst>
+                                    <p:animMotion origin="layout" path="M 0 0 L 0.26438 0 L 0.26438 0.63333 L 0 0.63333 L 0 0 E" pathEditMode="relative" rAng="0" ptsTypes="AAAAA">
+                                      <p:cBhvr>
+                                        <p:cTn id="16" dur="5503" fill="hold"/>
+                                        <p:tgtEl>
+                                          <p:spTgt spid="39"/>
+                                        </p:tgtEl>
+                                        <p:attrNameLst>
+                                          <p:attrName>ppt_x</p:attrName>
+                                          <p:attrName>ppt_y</p:attrName>
+                                        </p:attrNameLst>
+                                      </p:cBhvr>
+                                      <p:rCtr x="0" y="0"/>
+                                    </p:animMotion>
+                                  </p:childTnLst>
+                                </p:cTn>
+                              </p:par>
+                              <p:par>
+                                <p:cTn id="17" presetID="0" presetClass="path" presetSubtype="0" repeatCount="indefinite" accel="0" decel="0" fill="hold" nodeType="withEffect">
+                                  <p:stCondLst>
+                                    <p:cond delay="330"/>
+                                  </p:stCondLst>
+                                  <p:childTnLst>
+                                    <p:animMotion origin="layout" path="M 0 0 L 0.26438 0 L 0.26438 0.63333 L 0 0.63333 L 0 0 E" pathEditMode="relative" rAng="0" ptsTypes="AAAAA">
+                                      <p:cBhvr>
+                                        <p:cTn id="18" dur="5503" fill="hold"/>
+                                        <p:tgtEl>
+                                          <p:spTgt spid="40"/>
+                                        </p:tgtEl>
+                                        <p:attrNameLst>
+                                          <p:attrName>ppt_x</p:attrName>
+                                          <p:attrName>ppt_y</p:attrName>
+                                        </p:attrNameLst>
+                                      </p:cBhvr>
+                                      <p:rCtr x="0" y="0"/>
+                                    </p:animMotion>
+                                  </p:childTnLst>
+                                </p:cTn>
+                              </p:par>
+                              <p:par>
+                                <p:cTn id="19" presetID="0" presetClass="path" presetSubtype="0" repeatCount="indefinite" accel="0" decel="0" fill="hold" nodeType="withEffect">
+                                  <p:stCondLst>
+                                    <p:cond delay="385"/>
+                                  </p:stCondLst>
+                                  <p:childTnLst>
+                                    <p:animMotion origin="layout" path="M 0 0 L 0.26438 0 L 0.26438 0.63333 L 0 0.63333 L 0 0 E" pathEditMode="relative" rAng="0" ptsTypes="AAAAA">
+                                      <p:cBhvr>
+                                        <p:cTn id="20" dur="5503" fill="hold"/>
+                                        <p:tgtEl>
+                                          <p:spTgt spid="41"/>
+                                        </p:tgtEl>
+                                        <p:attrNameLst>
+                                          <p:attrName>ppt_x</p:attrName>
+                                          <p:attrName>ppt_y</p:attrName>
+                                        </p:attrNameLst>
+                                      </p:cBhvr>
+                                      <p:rCtr x="0" y="0"/>
+                                    </p:animMotion>
+                                  </p:childTnLst>
+                                </p:cTn>
+                              </p:par>
+                              <p:par>
+                                <p:cTn id="21" presetID="0" presetClass="path" presetSubtype="0" repeatCount="indefinite" accel="0" decel="0" fill="hold" nodeType="withEffect">
+                                  <p:stCondLst>
+                                    <p:cond delay="0"/>
+                                  </p:stCondLst>
+                                  <p:childTnLst>
+                                    <p:animMotion origin="layout" path="M 0 0 L -0.26438 0 L -0.26438 -0.63333 L 0 -0.63333 L 0 0 E" pathEditMode="relative" rAng="0" ptsTypes="AAAAA">
+                                      <p:cBhvr>
+                                        <p:cTn id="22" dur="5503" fill="hold"/>
+                                        <p:tgtEl>
+                                          <p:spTgt spid="42"/>
+                                        </p:tgtEl>
+                                        <p:attrNameLst>
+                                          <p:attrName>ppt_x</p:attrName>
+                                          <p:attrName>ppt_y</p:attrName>
+                                        </p:attrNameLst>
+                                      </p:cBhvr>
+                                      <p:rCtr x="0" y="0"/>
+                                    </p:animMotion>
+                                  </p:childTnLst>
+                                </p:cTn>
+                              </p:par>
+                              <p:par>
+                                <p:cTn id="23" presetID="0" presetClass="path" presetSubtype="0" repeatCount="indefinite" accel="0" decel="0" fill="hold" nodeType="withEffect">
+                                  <p:stCondLst>
+                                    <p:cond delay="55"/>
+                                  </p:stCondLst>
+                                  <p:childTnLst>
+                                    <p:animMotion origin="layout" path="M 0 0 L -0.26438 0 L -0.26438 -0.63333 L 0 -0.63333 L 0 0 E" pathEditMode="relative" rAng="0" ptsTypes="AAAAA">
+                                      <p:cBhvr>
+                                        <p:cTn id="24" dur="5503" fill="hold"/>
+                                        <p:tgtEl>
+                                          <p:spTgt spid="43"/>
+                                        </p:tgtEl>
+                                        <p:attrNameLst>
+                                          <p:attrName>ppt_x</p:attrName>
+                                          <p:attrName>ppt_y</p:attrName>
+                                        </p:attrNameLst>
+                                      </p:cBhvr>
+                                      <p:rCtr x="0" y="0"/>
+                                    </p:animMotion>
+                                  </p:childTnLst>
+                                </p:cTn>
+                              </p:par>
+                              <p:par>
+                                <p:cTn id="25" presetID="0" presetClass="path" presetSubtype="0" repeatCount="indefinite" accel="0" decel="0" fill="hold" nodeType="withEffect">
+                                  <p:stCondLst>
+                                    <p:cond delay="110"/>
+                                  </p:stCondLst>
+                                  <p:childTnLst>
+                                    <p:animMotion origin="layout" path="M 0 0 L -0.26438 0 L -0.26438 -0.63333 L 0 -0.63333 L 0 0 E" pathEditMode="relative" rAng="0" ptsTypes="AAAAA">
+                                      <p:cBhvr>
+                                        <p:cTn id="26" dur="5503" fill="hold"/>
+                                        <p:tgtEl>
+                                          <p:spTgt spid="44"/>
+                                        </p:tgtEl>
+                                        <p:attrNameLst>
+                                          <p:attrName>ppt_x</p:attrName>
+                                          <p:attrName>ppt_y</p:attrName>
+                                        </p:attrNameLst>
+                                      </p:cBhvr>
+                                      <p:rCtr x="0" y="0"/>
+                                    </p:animMotion>
+                                  </p:childTnLst>
+                                </p:cTn>
+                              </p:par>
+                              <p:par>
+                                <p:cTn id="27" presetID="0" presetClass="path" presetSubtype="0" repeatCount="indefinite" accel="0" decel="0" fill="hold" nodeType="withEffect">
+                                  <p:stCondLst>
+                                    <p:cond delay="165"/>
+                                  </p:stCondLst>
+                                  <p:childTnLst>
+                                    <p:animMotion origin="layout" path="M 0 0 L -0.26438 0 L -0.26438 -0.63333 L 0 -0.63333 L 0 0 E" pathEditMode="relative" rAng="0" ptsTypes="AAAAA">
+                                      <p:cBhvr>
+                                        <p:cTn id="28" dur="5503" fill="hold"/>
+                                        <p:tgtEl>
+                                          <p:spTgt spid="45"/>
+                                        </p:tgtEl>
+                                        <p:attrNameLst>
+                                          <p:attrName>ppt_x</p:attrName>
+                                          <p:attrName>ppt_y</p:attrName>
+                                        </p:attrNameLst>
+                                      </p:cBhvr>
+                                      <p:rCtr x="0" y="0"/>
+                                    </p:animMotion>
+                                  </p:childTnLst>
+                                </p:cTn>
+                              </p:par>
+                              <p:par>
+                                <p:cTn id="29" presetID="0" presetClass="path" presetSubtype="0" repeatCount="indefinite" accel="0" decel="0" fill="hold" nodeType="withEffect">
+                                  <p:stCondLst>
+                                    <p:cond delay="220"/>
+                                  </p:stCondLst>
+                                  <p:childTnLst>
+                                    <p:animMotion origin="layout" path="M 0 0 L -0.26438 0 L -0.26438 -0.63333 L 0 -0.63333 L 0 0 E" pathEditMode="relative" rAng="0" ptsTypes="AAAAA">
+                                      <p:cBhvr>
+                                        <p:cTn id="30" dur="5503" fill="hold"/>
+                                        <p:tgtEl>
+                                          <p:spTgt spid="46"/>
+                                        </p:tgtEl>
+                                        <p:attrNameLst>
+                                          <p:attrName>ppt_x</p:attrName>
+                                          <p:attrName>ppt_y</p:attrName>
+                                        </p:attrNameLst>
+                                      </p:cBhvr>
+                                      <p:rCtr x="0" y="0"/>
+                                    </p:animMotion>
+                                  </p:childTnLst>
+                                </p:cTn>
+                              </p:par>
+                              <p:par>
+                                <p:cTn id="31" presetID="0" presetClass="path" presetSubtype="0" repeatCount="indefinite" accel="0" decel="0" fill="hold" nodeType="withEffect">
+                                  <p:stCondLst>
+                                    <p:cond delay="275"/>
+                                  </p:stCondLst>
+                                  <p:childTnLst>
+                                    <p:animMotion origin="layout" path="M 0 0 L -0.26438 0 L -0.26438 -0.63333 L 0 -0.63333 L 0 0 E" pathEditMode="relative" rAng="0" ptsTypes="AAAAA">
+                                      <p:cBhvr>
+                                        <p:cTn id="32" dur="5503" fill="hold"/>
+                                        <p:tgtEl>
+                                          <p:spTgt spid="47"/>
+                                        </p:tgtEl>
+                                        <p:attrNameLst>
+                                          <p:attrName>ppt_x</p:attrName>
+                                          <p:attrName>ppt_y</p:attrName>
+                                        </p:attrNameLst>
+                                      </p:cBhvr>
+                                      <p:rCtr x="0" y="0"/>
+                                    </p:animMotion>
+                                  </p:childTnLst>
+                                </p:cTn>
+                              </p:par>
+                              <p:par>
+                                <p:cTn id="33" presetID="0" presetClass="path" presetSubtype="0" repeatCount="indefinite" accel="0" decel="0" fill="hold" nodeType="withEffect">
+                                  <p:stCondLst>
+                                    <p:cond delay="330"/>
+                                  </p:stCondLst>
+                                  <p:childTnLst>
+                                    <p:animMotion origin="layout" path="M 0 0 L -0.26438 0 L -0.26438 -0.63333 L 0 -0.63333 L 0 0 E" pathEditMode="relative" rAng="0" ptsTypes="AAAAA">
+                                      <p:cBhvr>
+                                        <p:cTn id="34" dur="5503" fill="hold"/>
+                                        <p:tgtEl>
+                                          <p:spTgt spid="48"/>
+                                        </p:tgtEl>
+                                        <p:attrNameLst>
+                                          <p:attrName>ppt_x</p:attrName>
+                                          <p:attrName>ppt_y</p:attrName>
+                                        </p:attrNameLst>
+                                      </p:cBhvr>
+                                      <p:rCtr x="0" y="0"/>
+                                    </p:animMotion>
+                                  </p:childTnLst>
+                                </p:cTn>
+                              </p:par>
+                              <p:par>
+                                <p:cTn id="35" presetID="0" presetClass="path" presetSubtype="0" repeatCount="indefinite" accel="0" decel="0" fill="hold" nodeType="withEffect">
+                                  <p:stCondLst>
+                                    <p:cond delay="385"/>
+                                  </p:stCondLst>
+                                  <p:childTnLst>
+                                    <p:animMotion origin="layout" path="M 0 0 L -0.26438 0 L -0.26438 -0.63333 L 0 -0.63333 L 0 0 E" pathEditMode="relative" rAng="0" ptsTypes="AAAAA">
+                                      <p:cBhvr>
+                                        <p:cTn id="36" dur="5503" fill="hold"/>
+                                        <p:tgtEl>
+                                          <p:spTgt spid="49"/>
+                                        </p:tgtEl>
+                                        <p:attrNameLst>
+                                          <p:attrName>ppt_x</p:attrName>
+                                          <p:attrName>ppt_y</p:attrName>
+                                        </p:attrNameLst>
+                                      </p:cBhvr>
+                                      <p:rCtr x="0" y="0"/>
+                                    </p:animMotion>
+                                  </p:childTnLst>
+                                </p:cTn>
+                              </p:par>
+                            </p:childTnLst>
+                          </p:cTn>
+                        </p:par>
+                      </p:childTnLst>
+                    </p:cTn>
+                  </p:par>
+                </p:childTnLst>
+              </p:cTn>
+              <p:prevCondLst>
+                <p:cond evt="onPrev" delay="0">
+                  <p:tgtEl>
+                    <p:sldTgt/>
+                  </p:tgtEl>
+                </p:cond>
+              </p:prevCondLst>
+              <p:nextCondLst>
+                <p:cond evt="onNext" delay="0">
+                  <p:tgtEl>
+                    <p:sldTgt/>
+                  </p:tgtEl>
+                </p:cond>
+              </p:nextCondLst>
+            </p:seq>
+          </p:childTnLst>
+        </p:cTn>
+      </p:par>
+    </p:tnLst>
+  </p:timing>
 </p:sld>
 </file>
 
@@ -5887,6 +7685,502 @@
             <a:glow rad="26670">
               <a:srgbClr val="58F268">
                 <a:alpha val="28800"/>
+              </a:srgbClr>
+            </a:glow>
+          </a:effectLst>
+        </p:spPr>
+      </p:sp>
+      <p:sp>
+        <p:nvSpPr>
+          <p:cNvPr id="41" name="Світло рамки 2.8"/>
+          <p:cNvSpPr/>
+          <p:nvPr/>
+        </p:nvSpPr>
+        <p:spPr>
+          <a:xfrm>
+            <a:off x="11624767" y="5141704"/>
+            <a:ext cx="36576" cy="36576"/>
+          </a:xfrm>
+          <a:prstGeom prst="ellipse">
+            <a:avLst/>
+          </a:prstGeom>
+          <a:solidFill>
+            <a:srgbClr val="58F268">
+              <a:alpha val="20000"/>
+            </a:srgbClr>
+          </a:solidFill>
+          <a:ln>
+            <a:noFill/>
+          </a:ln>
+          <a:effectLst>
+            <a:glow rad="63500">
+              <a:srgbClr val="58F268">
+                <a:alpha val="12000"/>
+              </a:srgbClr>
+            </a:glow>
+          </a:effectLst>
+        </p:spPr>
+      </p:sp>
+      <p:sp>
+        <p:nvSpPr>
+          <p:cNvPr id="40" name="Світло рамки 2.7"/>
+          <p:cNvSpPr/>
+          <p:nvPr/>
+        </p:nvSpPr>
+        <p:spPr>
+          <a:xfrm>
+            <a:off x="11618889" y="5135826"/>
+            <a:ext cx="48332" cy="48332"/>
+          </a:xfrm>
+          <a:prstGeom prst="ellipse">
+            <a:avLst/>
+          </a:prstGeom>
+          <a:solidFill>
+            <a:srgbClr val="58F268">
+              <a:alpha val="31428"/>
+            </a:srgbClr>
+          </a:solidFill>
+          <a:ln>
+            <a:noFill/>
+          </a:ln>
+          <a:effectLst>
+            <a:glow rad="63500">
+              <a:srgbClr val="58F268">
+                <a:alpha val="18856"/>
+              </a:srgbClr>
+            </a:glow>
+          </a:effectLst>
+        </p:spPr>
+      </p:sp>
+      <p:sp>
+        <p:nvSpPr>
+          <p:cNvPr id="39" name="Світло рамки 2.6"/>
+          <p:cNvSpPr/>
+          <p:nvPr/>
+        </p:nvSpPr>
+        <p:spPr>
+          <a:xfrm>
+            <a:off x="11613011" y="5129948"/>
+            <a:ext cx="60089" cy="60089"/>
+          </a:xfrm>
+          <a:prstGeom prst="ellipse">
+            <a:avLst/>
+          </a:prstGeom>
+          <a:solidFill>
+            <a:srgbClr val="58F268">
+              <a:alpha val="42857"/>
+            </a:srgbClr>
+          </a:solidFill>
+          <a:ln>
+            <a:noFill/>
+          </a:ln>
+          <a:effectLst>
+            <a:glow rad="63500">
+              <a:srgbClr val="58F268">
+                <a:alpha val="25714"/>
+              </a:srgbClr>
+            </a:glow>
+          </a:effectLst>
+        </p:spPr>
+      </p:sp>
+      <p:sp>
+        <p:nvSpPr>
+          <p:cNvPr id="38" name="Світло рамки 2.5"/>
+          <p:cNvSpPr/>
+          <p:nvPr/>
+        </p:nvSpPr>
+        <p:spPr>
+          <a:xfrm>
+            <a:off x="11607133" y="5124070"/>
+            <a:ext cx="71845" cy="71845"/>
+          </a:xfrm>
+          <a:prstGeom prst="ellipse">
+            <a:avLst/>
+          </a:prstGeom>
+          <a:solidFill>
+            <a:srgbClr val="58F268">
+              <a:alpha val="54285"/>
+            </a:srgbClr>
+          </a:solidFill>
+          <a:ln>
+            <a:noFill/>
+          </a:ln>
+          <a:effectLst>
+            <a:glow rad="63500">
+              <a:srgbClr val="58F268">
+                <a:alpha val="32571"/>
+              </a:srgbClr>
+            </a:glow>
+          </a:effectLst>
+        </p:spPr>
+      </p:sp>
+      <p:sp>
+        <p:nvSpPr>
+          <p:cNvPr id="37" name="Світло рамки 2.4"/>
+          <p:cNvSpPr/>
+          <p:nvPr/>
+        </p:nvSpPr>
+        <p:spPr>
+          <a:xfrm>
+            <a:off x="11601254" y="5118191"/>
+            <a:ext cx="83602" cy="83602"/>
+          </a:xfrm>
+          <a:prstGeom prst="ellipse">
+            <a:avLst/>
+          </a:prstGeom>
+          <a:solidFill>
+            <a:srgbClr val="58F268">
+              <a:alpha val="65714"/>
+            </a:srgbClr>
+          </a:solidFill>
+          <a:ln>
+            <a:noFill/>
+          </a:ln>
+          <a:effectLst>
+            <a:glow rad="63500">
+              <a:srgbClr val="58F268">
+                <a:alpha val="39428"/>
+              </a:srgbClr>
+            </a:glow>
+          </a:effectLst>
+        </p:spPr>
+      </p:sp>
+      <p:sp>
+        <p:nvSpPr>
+          <p:cNvPr id="36" name="Світло рамки 2.3"/>
+          <p:cNvSpPr/>
+          <p:nvPr/>
+        </p:nvSpPr>
+        <p:spPr>
+          <a:xfrm>
+            <a:off x="11595376" y="5112313"/>
+            <a:ext cx="95358" cy="95358"/>
+          </a:xfrm>
+          <a:prstGeom prst="ellipse">
+            <a:avLst/>
+          </a:prstGeom>
+          <a:solidFill>
+            <a:srgbClr val="58F268">
+              <a:alpha val="77142"/>
+            </a:srgbClr>
+          </a:solidFill>
+          <a:ln>
+            <a:noFill/>
+          </a:ln>
+          <a:effectLst>
+            <a:glow rad="63500">
+              <a:srgbClr val="58F268">
+                <a:alpha val="46285"/>
+              </a:srgbClr>
+            </a:glow>
+          </a:effectLst>
+        </p:spPr>
+      </p:sp>
+      <p:sp>
+        <p:nvSpPr>
+          <p:cNvPr id="35" name="Світло рамки 2.2"/>
+          <p:cNvSpPr/>
+          <p:nvPr/>
+        </p:nvSpPr>
+        <p:spPr>
+          <a:xfrm>
+            <a:off x="11589498" y="5106435"/>
+            <a:ext cx="107115" cy="107115"/>
+          </a:xfrm>
+          <a:prstGeom prst="ellipse">
+            <a:avLst/>
+          </a:prstGeom>
+          <a:solidFill>
+            <a:srgbClr val="58F268">
+              <a:alpha val="88571"/>
+            </a:srgbClr>
+          </a:solidFill>
+          <a:ln>
+            <a:noFill/>
+          </a:ln>
+          <a:effectLst>
+            <a:glow rad="63500">
+              <a:srgbClr val="58F268">
+                <a:alpha val="53142"/>
+              </a:srgbClr>
+            </a:glow>
+          </a:effectLst>
+        </p:spPr>
+      </p:sp>
+      <p:sp>
+        <p:nvSpPr>
+          <p:cNvPr id="34" name="Світло рамки 2.1"/>
+          <p:cNvSpPr/>
+          <p:nvPr/>
+        </p:nvSpPr>
+        <p:spPr>
+          <a:xfrm>
+            <a:off x="11583619" y="5100556"/>
+            <a:ext cx="118872" cy="118872"/>
+          </a:xfrm>
+          <a:prstGeom prst="ellipse">
+            <a:avLst/>
+          </a:prstGeom>
+          <a:solidFill>
+            <a:srgbClr val="F2FFF3">
+              <a:alpha val="100000"/>
+            </a:srgbClr>
+          </a:solidFill>
+          <a:ln>
+            <a:noFill/>
+          </a:ln>
+          <a:effectLst>
+            <a:glow rad="101600">
+              <a:srgbClr val="58F268">
+                <a:alpha val="60000"/>
+              </a:srgbClr>
+            </a:glow>
+          </a:effectLst>
+        </p:spPr>
+      </p:sp>
+      <p:sp>
+        <p:nvSpPr>
+          <p:cNvPr id="33" name="Світло рамки 1.8"/>
+          <p:cNvSpPr/>
+          <p:nvPr/>
+        </p:nvSpPr>
+        <p:spPr>
+          <a:xfrm>
+            <a:off x="530352" y="1719072"/>
+            <a:ext cx="36576" cy="36576"/>
+          </a:xfrm>
+          <a:prstGeom prst="ellipse">
+            <a:avLst/>
+          </a:prstGeom>
+          <a:solidFill>
+            <a:srgbClr val="58F268">
+              <a:alpha val="20000"/>
+            </a:srgbClr>
+          </a:solidFill>
+          <a:ln>
+            <a:noFill/>
+          </a:ln>
+          <a:effectLst>
+            <a:glow rad="63500">
+              <a:srgbClr val="58F268">
+                <a:alpha val="12000"/>
+              </a:srgbClr>
+            </a:glow>
+          </a:effectLst>
+        </p:spPr>
+      </p:sp>
+      <p:sp>
+        <p:nvSpPr>
+          <p:cNvPr id="32" name="Світло рамки 1.7"/>
+          <p:cNvSpPr/>
+          <p:nvPr/>
+        </p:nvSpPr>
+        <p:spPr>
+          <a:xfrm>
+            <a:off x="524474" y="1713194"/>
+            <a:ext cx="48332" cy="48332"/>
+          </a:xfrm>
+          <a:prstGeom prst="ellipse">
+            <a:avLst/>
+          </a:prstGeom>
+          <a:solidFill>
+            <a:srgbClr val="58F268">
+              <a:alpha val="31428"/>
+            </a:srgbClr>
+          </a:solidFill>
+          <a:ln>
+            <a:noFill/>
+          </a:ln>
+          <a:effectLst>
+            <a:glow rad="63500">
+              <a:srgbClr val="58F268">
+                <a:alpha val="18856"/>
+              </a:srgbClr>
+            </a:glow>
+          </a:effectLst>
+        </p:spPr>
+      </p:sp>
+      <p:sp>
+        <p:nvSpPr>
+          <p:cNvPr id="31" name="Світло рамки 1.6"/>
+          <p:cNvSpPr/>
+          <p:nvPr/>
+        </p:nvSpPr>
+        <p:spPr>
+          <a:xfrm>
+            <a:off x="518596" y="1707316"/>
+            <a:ext cx="60089" cy="60089"/>
+          </a:xfrm>
+          <a:prstGeom prst="ellipse">
+            <a:avLst/>
+          </a:prstGeom>
+          <a:solidFill>
+            <a:srgbClr val="58F268">
+              <a:alpha val="42857"/>
+            </a:srgbClr>
+          </a:solidFill>
+          <a:ln>
+            <a:noFill/>
+          </a:ln>
+          <a:effectLst>
+            <a:glow rad="63500">
+              <a:srgbClr val="58F268">
+                <a:alpha val="25714"/>
+              </a:srgbClr>
+            </a:glow>
+          </a:effectLst>
+        </p:spPr>
+      </p:sp>
+      <p:sp>
+        <p:nvSpPr>
+          <p:cNvPr id="30" name="Світло рамки 1.5"/>
+          <p:cNvSpPr/>
+          <p:nvPr/>
+        </p:nvSpPr>
+        <p:spPr>
+          <a:xfrm>
+            <a:off x="512718" y="1701438"/>
+            <a:ext cx="71845" cy="71845"/>
+          </a:xfrm>
+          <a:prstGeom prst="ellipse">
+            <a:avLst/>
+          </a:prstGeom>
+          <a:solidFill>
+            <a:srgbClr val="58F268">
+              <a:alpha val="54285"/>
+            </a:srgbClr>
+          </a:solidFill>
+          <a:ln>
+            <a:noFill/>
+          </a:ln>
+          <a:effectLst>
+            <a:glow rad="63500">
+              <a:srgbClr val="58F268">
+                <a:alpha val="32571"/>
+              </a:srgbClr>
+            </a:glow>
+          </a:effectLst>
+        </p:spPr>
+      </p:sp>
+      <p:sp>
+        <p:nvSpPr>
+          <p:cNvPr id="29" name="Світло рамки 1.4"/>
+          <p:cNvSpPr/>
+          <p:nvPr/>
+        </p:nvSpPr>
+        <p:spPr>
+          <a:xfrm>
+            <a:off x="506839" y="1695559"/>
+            <a:ext cx="83602" cy="83602"/>
+          </a:xfrm>
+          <a:prstGeom prst="ellipse">
+            <a:avLst/>
+          </a:prstGeom>
+          <a:solidFill>
+            <a:srgbClr val="58F268">
+              <a:alpha val="65714"/>
+            </a:srgbClr>
+          </a:solidFill>
+          <a:ln>
+            <a:noFill/>
+          </a:ln>
+          <a:effectLst>
+            <a:glow rad="63500">
+              <a:srgbClr val="58F268">
+                <a:alpha val="39428"/>
+              </a:srgbClr>
+            </a:glow>
+          </a:effectLst>
+        </p:spPr>
+      </p:sp>
+      <p:sp>
+        <p:nvSpPr>
+          <p:cNvPr id="28" name="Світло рамки 1.3"/>
+          <p:cNvSpPr/>
+          <p:nvPr/>
+        </p:nvSpPr>
+        <p:spPr>
+          <a:xfrm>
+            <a:off x="500961" y="1689681"/>
+            <a:ext cx="95358" cy="95358"/>
+          </a:xfrm>
+          <a:prstGeom prst="ellipse">
+            <a:avLst/>
+          </a:prstGeom>
+          <a:solidFill>
+            <a:srgbClr val="58F268">
+              <a:alpha val="77142"/>
+            </a:srgbClr>
+          </a:solidFill>
+          <a:ln>
+            <a:noFill/>
+          </a:ln>
+          <a:effectLst>
+            <a:glow rad="63500">
+              <a:srgbClr val="58F268">
+                <a:alpha val="46285"/>
+              </a:srgbClr>
+            </a:glow>
+          </a:effectLst>
+        </p:spPr>
+      </p:sp>
+      <p:sp>
+        <p:nvSpPr>
+          <p:cNvPr id="27" name="Світло рамки 1.2"/>
+          <p:cNvSpPr/>
+          <p:nvPr/>
+        </p:nvSpPr>
+        <p:spPr>
+          <a:xfrm>
+            <a:off x="495083" y="1683803"/>
+            <a:ext cx="107115" cy="107115"/>
+          </a:xfrm>
+          <a:prstGeom prst="ellipse">
+            <a:avLst/>
+          </a:prstGeom>
+          <a:solidFill>
+            <a:srgbClr val="58F268">
+              <a:alpha val="88571"/>
+            </a:srgbClr>
+          </a:solidFill>
+          <a:ln>
+            <a:noFill/>
+          </a:ln>
+          <a:effectLst>
+            <a:glow rad="63500">
+              <a:srgbClr val="58F268">
+                <a:alpha val="53142"/>
+              </a:srgbClr>
+            </a:glow>
+          </a:effectLst>
+        </p:spPr>
+      </p:sp>
+      <p:sp>
+        <p:nvSpPr>
+          <p:cNvPr id="26" name="Світло рамки 1.1"/>
+          <p:cNvSpPr/>
+          <p:nvPr/>
+        </p:nvSpPr>
+        <p:spPr>
+          <a:xfrm>
+            <a:off x="489204" y="1677924"/>
+            <a:ext cx="118872" cy="118872"/>
+          </a:xfrm>
+          <a:prstGeom prst="ellipse">
+            <a:avLst/>
+          </a:prstGeom>
+          <a:solidFill>
+            <a:srgbClr val="F2FFF3">
+              <a:alpha val="100000"/>
+            </a:srgbClr>
+          </a:solidFill>
+          <a:ln>
+            <a:noFill/>
+          </a:ln>
+          <a:effectLst>
+            <a:glow rad="101600">
+              <a:srgbClr val="58F268">
+                <a:alpha val="60000"/>
               </a:srgbClr>
             </a:glow>
           </a:effectLst>
@@ -6765,6 +9059,409 @@
   <p:clrMapOvr>
     <a:masterClrMapping/>
   </p:clrMapOvr>
+  <p:timing>
+    <p:tnLst>
+      <p:par>
+        <p:cTn id="1" dur="indefinite" restart="never" nodeType="tmRoot">
+          <p:childTnLst>
+            <p:seq concurrent="1" nextAc="seek">
+              <p:cTn id="2" dur="indefinite" nodeType="mainSeq">
+                <p:childTnLst>
+                  <p:par>
+                    <p:cTn id="3" fill="hold">
+                      <p:stCondLst>
+                        <p:cond delay="indefinite"/>
+                        <p:cond evt="onBegin" delay="0">
+                          <p:tn val="2"/>
+                        </p:cond>
+                      </p:stCondLst>
+                      <p:childTnLst>
+                        <p:par>
+                          <p:cTn id="4" fill="hold">
+                            <p:stCondLst>
+                              <p:cond delay="0"/>
+                            </p:stCondLst>
+                            <p:childTnLst>
+                              <p:par>
+                                <p:cTn id="5" presetID="0" presetClass="path" presetSubtype="0" repeatCount="indefinite" accel="0" decel="0" fill="hold" nodeType="withEffect">
+                                  <p:stCondLst>
+                                    <p:cond delay="0"/>
+                                  </p:stCondLst>
+                                  <p:childTnLst>
+                                    <p:animMotion origin="layout" path="M 0 0 L 0.90997 0 L 0.90997 0.49907 L 0 0.49907 L 0 0 E" pathEditMode="relative" rAng="0" ptsTypes="AAAAA">
+                                      <p:cBhvr>
+                                        <p:cTn id="6" dur="10557" fill="hold"/>
+                                        <p:tgtEl>
+                                          <p:spTgt spid="26"/>
+                                        </p:tgtEl>
+                                        <p:attrNameLst>
+                                          <p:attrName>ppt_x</p:attrName>
+                                          <p:attrName>ppt_y</p:attrName>
+                                        </p:attrNameLst>
+                                      </p:cBhvr>
+                                      <p:rCtr x="0" y="0"/>
+                                    </p:animMotion>
+                                  </p:childTnLst>
+                                </p:cTn>
+                              </p:par>
+                              <p:par>
+                                <p:cTn id="7" presetID="0" presetClass="path" presetSubtype="0" repeatCount="indefinite" accel="0" decel="0" fill="hold" nodeType="withEffect">
+                                  <p:stCondLst>
+                                    <p:cond delay="55"/>
+                                  </p:stCondLst>
+                                  <p:childTnLst>
+                                    <p:animMotion origin="layout" path="M 0 0 L 0.90997 0 L 0.90997 0.49907 L 0 0.49907 L 0 0 E" pathEditMode="relative" rAng="0" ptsTypes="AAAAA">
+                                      <p:cBhvr>
+                                        <p:cTn id="8" dur="10557" fill="hold"/>
+                                        <p:tgtEl>
+                                          <p:spTgt spid="27"/>
+                                        </p:tgtEl>
+                                        <p:attrNameLst>
+                                          <p:attrName>ppt_x</p:attrName>
+                                          <p:attrName>ppt_y</p:attrName>
+                                        </p:attrNameLst>
+                                      </p:cBhvr>
+                                      <p:rCtr x="0" y="0"/>
+                                    </p:animMotion>
+                                  </p:childTnLst>
+                                </p:cTn>
+                              </p:par>
+                              <p:par>
+                                <p:cTn id="9" presetID="0" presetClass="path" presetSubtype="0" repeatCount="indefinite" accel="0" decel="0" fill="hold" nodeType="withEffect">
+                                  <p:stCondLst>
+                                    <p:cond delay="110"/>
+                                  </p:stCondLst>
+                                  <p:childTnLst>
+                                    <p:animMotion origin="layout" path="M 0 0 L 0.90997 0 L 0.90997 0.49907 L 0 0.49907 L 0 0 E" pathEditMode="relative" rAng="0" ptsTypes="AAAAA">
+                                      <p:cBhvr>
+                                        <p:cTn id="10" dur="10557" fill="hold"/>
+                                        <p:tgtEl>
+                                          <p:spTgt spid="28"/>
+                                        </p:tgtEl>
+                                        <p:attrNameLst>
+                                          <p:attrName>ppt_x</p:attrName>
+                                          <p:attrName>ppt_y</p:attrName>
+                                        </p:attrNameLst>
+                                      </p:cBhvr>
+                                      <p:rCtr x="0" y="0"/>
+                                    </p:animMotion>
+                                  </p:childTnLst>
+                                </p:cTn>
+                              </p:par>
+                              <p:par>
+                                <p:cTn id="11" presetID="0" presetClass="path" presetSubtype="0" repeatCount="indefinite" accel="0" decel="0" fill="hold" nodeType="withEffect">
+                                  <p:stCondLst>
+                                    <p:cond delay="165"/>
+                                  </p:stCondLst>
+                                  <p:childTnLst>
+                                    <p:animMotion origin="layout" path="M 0 0 L 0.90997 0 L 0.90997 0.49907 L 0 0.49907 L 0 0 E" pathEditMode="relative" rAng="0" ptsTypes="AAAAA">
+                                      <p:cBhvr>
+                                        <p:cTn id="12" dur="10557" fill="hold"/>
+                                        <p:tgtEl>
+                                          <p:spTgt spid="29"/>
+                                        </p:tgtEl>
+                                        <p:attrNameLst>
+                                          <p:attrName>ppt_x</p:attrName>
+                                          <p:attrName>ppt_y</p:attrName>
+                                        </p:attrNameLst>
+                                      </p:cBhvr>
+                                      <p:rCtr x="0" y="0"/>
+                                    </p:animMotion>
+                                  </p:childTnLst>
+                                </p:cTn>
+                              </p:par>
+                              <p:par>
+                                <p:cTn id="13" presetID="0" presetClass="path" presetSubtype="0" repeatCount="indefinite" accel="0" decel="0" fill="hold" nodeType="withEffect">
+                                  <p:stCondLst>
+                                    <p:cond delay="220"/>
+                                  </p:stCondLst>
+                                  <p:childTnLst>
+                                    <p:animMotion origin="layout" path="M 0 0 L 0.90997 0 L 0.90997 0.49907 L 0 0.49907 L 0 0 E" pathEditMode="relative" rAng="0" ptsTypes="AAAAA">
+                                      <p:cBhvr>
+                                        <p:cTn id="14" dur="10557" fill="hold"/>
+                                        <p:tgtEl>
+                                          <p:spTgt spid="30"/>
+                                        </p:tgtEl>
+                                        <p:attrNameLst>
+                                          <p:attrName>ppt_x</p:attrName>
+                                          <p:attrName>ppt_y</p:attrName>
+                                        </p:attrNameLst>
+                                      </p:cBhvr>
+                                      <p:rCtr x="0" y="0"/>
+                                    </p:animMotion>
+                                  </p:childTnLst>
+                                </p:cTn>
+                              </p:par>
+                              <p:par>
+                                <p:cTn id="15" presetID="0" presetClass="path" presetSubtype="0" repeatCount="indefinite" accel="0" decel="0" fill="hold" nodeType="withEffect">
+                                  <p:stCondLst>
+                                    <p:cond delay="275"/>
+                                  </p:stCondLst>
+                                  <p:childTnLst>
+                                    <p:animMotion origin="layout" path="M 0 0 L 0.90997 0 L 0.90997 0.49907 L 0 0.49907 L 0 0 E" pathEditMode="relative" rAng="0" ptsTypes="AAAAA">
+                                      <p:cBhvr>
+                                        <p:cTn id="16" dur="10557" fill="hold"/>
+                                        <p:tgtEl>
+                                          <p:spTgt spid="31"/>
+                                        </p:tgtEl>
+                                        <p:attrNameLst>
+                                          <p:attrName>ppt_x</p:attrName>
+                                          <p:attrName>ppt_y</p:attrName>
+                                        </p:attrNameLst>
+                                      </p:cBhvr>
+                                      <p:rCtr x="0" y="0"/>
+                                    </p:animMotion>
+                                  </p:childTnLst>
+                                </p:cTn>
+                              </p:par>
+                              <p:par>
+                                <p:cTn id="17" presetID="0" presetClass="path" presetSubtype="0" repeatCount="indefinite" accel="0" decel="0" fill="hold" nodeType="withEffect">
+                                  <p:stCondLst>
+                                    <p:cond delay="330"/>
+                                  </p:stCondLst>
+                                  <p:childTnLst>
+                                    <p:animMotion origin="layout" path="M 0 0 L 0.90997 0 L 0.90997 0.49907 L 0 0.49907 L 0 0 E" pathEditMode="relative" rAng="0" ptsTypes="AAAAA">
+                                      <p:cBhvr>
+                                        <p:cTn id="18" dur="10557" fill="hold"/>
+                                        <p:tgtEl>
+                                          <p:spTgt spid="32"/>
+                                        </p:tgtEl>
+                                        <p:attrNameLst>
+                                          <p:attrName>ppt_x</p:attrName>
+                                          <p:attrName>ppt_y</p:attrName>
+                                        </p:attrNameLst>
+                                      </p:cBhvr>
+                                      <p:rCtr x="0" y="0"/>
+                                    </p:animMotion>
+                                  </p:childTnLst>
+                                </p:cTn>
+                              </p:par>
+                              <p:par>
+                                <p:cTn id="19" presetID="0" presetClass="path" presetSubtype="0" repeatCount="indefinite" accel="0" decel="0" fill="hold" nodeType="withEffect">
+                                  <p:stCondLst>
+                                    <p:cond delay="385"/>
+                                  </p:stCondLst>
+                                  <p:childTnLst>
+                                    <p:animMotion origin="layout" path="M 0 0 L 0.90997 0 L 0.90997 0.49907 L 0 0.49907 L 0 0 E" pathEditMode="relative" rAng="0" ptsTypes="AAAAA">
+                                      <p:cBhvr>
+                                        <p:cTn id="20" dur="10557" fill="hold"/>
+                                        <p:tgtEl>
+                                          <p:spTgt spid="33"/>
+                                        </p:tgtEl>
+                                        <p:attrNameLst>
+                                          <p:attrName>ppt_x</p:attrName>
+                                          <p:attrName>ppt_y</p:attrName>
+                                        </p:attrNameLst>
+                                      </p:cBhvr>
+                                      <p:rCtr x="0" y="0"/>
+                                    </p:animMotion>
+                                  </p:childTnLst>
+                                </p:cTn>
+                              </p:par>
+                              <p:par>
+                                <p:cTn id="21" presetID="0" presetClass="path" presetSubtype="0" repeatCount="indefinite" accel="0" decel="0" fill="hold" nodeType="withEffect">
+                                  <p:stCondLst>
+                                    <p:cond delay="0"/>
+                                  </p:stCondLst>
+                                  <p:childTnLst>
+                                    <p:animMotion origin="layout" path="M 0 0 L -0.90997 0 L -0.90997 -0.49907 L 0 -0.49907 L 0 0 E" pathEditMode="relative" rAng="0" ptsTypes="AAAAA">
+                                      <p:cBhvr>
+                                        <p:cTn id="22" dur="10557" fill="hold"/>
+                                        <p:tgtEl>
+                                          <p:spTgt spid="34"/>
+                                        </p:tgtEl>
+                                        <p:attrNameLst>
+                                          <p:attrName>ppt_x</p:attrName>
+                                          <p:attrName>ppt_y</p:attrName>
+                                        </p:attrNameLst>
+                                      </p:cBhvr>
+                                      <p:rCtr x="0" y="0"/>
+                                    </p:animMotion>
+                                  </p:childTnLst>
+                                </p:cTn>
+                              </p:par>
+                              <p:par>
+                                <p:cTn id="23" presetID="0" presetClass="path" presetSubtype="0" repeatCount="indefinite" accel="0" decel="0" fill="hold" nodeType="withEffect">
+                                  <p:stCondLst>
+                                    <p:cond delay="55"/>
+                                  </p:stCondLst>
+                                  <p:childTnLst>
+                                    <p:animMotion origin="layout" path="M 0 0 L -0.90997 0 L -0.90997 -0.49907 L 0 -0.49907 L 0 0 E" pathEditMode="relative" rAng="0" ptsTypes="AAAAA">
+                                      <p:cBhvr>
+                                        <p:cTn id="24" dur="10557" fill="hold"/>
+                                        <p:tgtEl>
+                                          <p:spTgt spid="35"/>
+                                        </p:tgtEl>
+                                        <p:attrNameLst>
+                                          <p:attrName>ppt_x</p:attrName>
+                                          <p:attrName>ppt_y</p:attrName>
+                                        </p:attrNameLst>
+                                      </p:cBhvr>
+                                      <p:rCtr x="0" y="0"/>
+                                    </p:animMotion>
+                                  </p:childTnLst>
+                                </p:cTn>
+                              </p:par>
+                              <p:par>
+                                <p:cTn id="25" presetID="0" presetClass="path" presetSubtype="0" repeatCount="indefinite" accel="0" decel="0" fill="hold" nodeType="withEffect">
+                                  <p:stCondLst>
+                                    <p:cond delay="110"/>
+                                  </p:stCondLst>
+                                  <p:childTnLst>
+                                    <p:animMotion origin="layout" path="M 0 0 L -0.90997 0 L -0.90997 -0.49907 L 0 -0.49907 L 0 0 E" pathEditMode="relative" rAng="0" ptsTypes="AAAAA">
+                                      <p:cBhvr>
+                                        <p:cTn id="26" dur="10557" fill="hold"/>
+                                        <p:tgtEl>
+                                          <p:spTgt spid="36"/>
+                                        </p:tgtEl>
+                                        <p:attrNameLst>
+                                          <p:attrName>ppt_x</p:attrName>
+                                          <p:attrName>ppt_y</p:attrName>
+                                        </p:attrNameLst>
+                                      </p:cBhvr>
+                                      <p:rCtr x="0" y="0"/>
+                                    </p:animMotion>
+                                  </p:childTnLst>
+                                </p:cTn>
+                              </p:par>
+                              <p:par>
+                                <p:cTn id="27" presetID="0" presetClass="path" presetSubtype="0" repeatCount="indefinite" accel="0" decel="0" fill="hold" nodeType="withEffect">
+                                  <p:stCondLst>
+                                    <p:cond delay="165"/>
+                                  </p:stCondLst>
+                                  <p:childTnLst>
+                                    <p:animMotion origin="layout" path="M 0 0 L -0.90997 0 L -0.90997 -0.49907 L 0 -0.49907 L 0 0 E" pathEditMode="relative" rAng="0" ptsTypes="AAAAA">
+                                      <p:cBhvr>
+                                        <p:cTn id="28" dur="10557" fill="hold"/>
+                                        <p:tgtEl>
+                                          <p:spTgt spid="37"/>
+                                        </p:tgtEl>
+                                        <p:attrNameLst>
+                                          <p:attrName>ppt_x</p:attrName>
+                                          <p:attrName>ppt_y</p:attrName>
+                                        </p:attrNameLst>
+                                      </p:cBhvr>
+                                      <p:rCtr x="0" y="0"/>
+                                    </p:animMotion>
+                                  </p:childTnLst>
+                                </p:cTn>
+                              </p:par>
+                              <p:par>
+                                <p:cTn id="29" presetID="0" presetClass="path" presetSubtype="0" repeatCount="indefinite" accel="0" decel="0" fill="hold" nodeType="withEffect">
+                                  <p:stCondLst>
+                                    <p:cond delay="220"/>
+                                  </p:stCondLst>
+                                  <p:childTnLst>
+                                    <p:animMotion origin="layout" path="M 0 0 L -0.90997 0 L -0.90997 -0.49907 L 0 -0.49907 L 0 0 E" pathEditMode="relative" rAng="0" ptsTypes="AAAAA">
+                                      <p:cBhvr>
+                                        <p:cTn id="30" dur="10557" fill="hold"/>
+                                        <p:tgtEl>
+                                          <p:spTgt spid="38"/>
+                                        </p:tgtEl>
+                                        <p:attrNameLst>
+                                          <p:attrName>ppt_x</p:attrName>
+                                          <p:attrName>ppt_y</p:attrName>
+                                        </p:attrNameLst>
+                                      </p:cBhvr>
+                                      <p:rCtr x="0" y="0"/>
+                                    </p:animMotion>
+                                  </p:childTnLst>
+                                </p:cTn>
+                              </p:par>
+                              <p:par>
+                                <p:cTn id="31" presetID="0" presetClass="path" presetSubtype="0" repeatCount="indefinite" accel="0" decel="0" fill="hold" nodeType="withEffect">
+                                  <p:stCondLst>
+                                    <p:cond delay="275"/>
+                                  </p:stCondLst>
+                                  <p:childTnLst>
+                                    <p:animMotion origin="layout" path="M 0 0 L -0.90997 0 L -0.90997 -0.49907 L 0 -0.49907 L 0 0 E" pathEditMode="relative" rAng="0" ptsTypes="AAAAA">
+                                      <p:cBhvr>
+                                        <p:cTn id="32" dur="10557" fill="hold"/>
+                                        <p:tgtEl>
+                                          <p:spTgt spid="39"/>
+                                        </p:tgtEl>
+                                        <p:attrNameLst>
+                                          <p:attrName>ppt_x</p:attrName>
+                                          <p:attrName>ppt_y</p:attrName>
+                                        </p:attrNameLst>
+                                      </p:cBhvr>
+                                      <p:rCtr x="0" y="0"/>
+                                    </p:animMotion>
+                                  </p:childTnLst>
+                                </p:cTn>
+                              </p:par>
+                              <p:par>
+                                <p:cTn id="33" presetID="0" presetClass="path" presetSubtype="0" repeatCount="indefinite" accel="0" decel="0" fill="hold" nodeType="withEffect">
+                                  <p:stCondLst>
+                                    <p:cond delay="330"/>
+                                  </p:stCondLst>
+                                  <p:childTnLst>
+                                    <p:animMotion origin="layout" path="M 0 0 L -0.90997 0 L -0.90997 -0.49907 L 0 -0.49907 L 0 0 E" pathEditMode="relative" rAng="0" ptsTypes="AAAAA">
+                                      <p:cBhvr>
+                                        <p:cTn id="34" dur="10557" fill="hold"/>
+                                        <p:tgtEl>
+                                          <p:spTgt spid="40"/>
+                                        </p:tgtEl>
+                                        <p:attrNameLst>
+                                          <p:attrName>ppt_x</p:attrName>
+                                          <p:attrName>ppt_y</p:attrName>
+                                        </p:attrNameLst>
+                                      </p:cBhvr>
+                                      <p:rCtr x="0" y="0"/>
+                                    </p:animMotion>
+                                  </p:childTnLst>
+                                </p:cTn>
+                              </p:par>
+                              <p:par>
+                                <p:cTn id="35" presetID="0" presetClass="path" presetSubtype="0" repeatCount="indefinite" accel="0" decel="0" fill="hold" nodeType="withEffect">
+                                  <p:stCondLst>
+                                    <p:cond delay="385"/>
+                                  </p:stCondLst>
+                                  <p:childTnLst>
+                                    <p:animMotion origin="layout" path="M 0 0 L -0.90997 0 L -0.90997 -0.49907 L 0 -0.49907 L 0 0 E" pathEditMode="relative" rAng="0" ptsTypes="AAAAA">
+                                      <p:cBhvr>
+                                        <p:cTn id="36" dur="10557" fill="hold"/>
+                                        <p:tgtEl>
+                                          <p:spTgt spid="41"/>
+                                        </p:tgtEl>
+                                        <p:attrNameLst>
+                                          <p:attrName>ppt_x</p:attrName>
+                                          <p:attrName>ppt_y</p:attrName>
+                                        </p:attrNameLst>
+                                      </p:cBhvr>
+                                      <p:rCtr x="0" y="0"/>
+                                    </p:animMotion>
+                                  </p:childTnLst>
+                                </p:cTn>
+                              </p:par>
+                            </p:childTnLst>
+                          </p:cTn>
+                        </p:par>
+                      </p:childTnLst>
+                    </p:cTn>
+                  </p:par>
+                </p:childTnLst>
+              </p:cTn>
+              <p:prevCondLst>
+                <p:cond evt="onPrev" delay="0">
+                  <p:tgtEl>
+                    <p:sldTgt/>
+                  </p:tgtEl>
+                </p:cond>
+              </p:prevCondLst>
+              <p:nextCondLst>
+                <p:cond evt="onNext" delay="0">
+                  <p:tgtEl>
+                    <p:sldTgt/>
+                  </p:tgtEl>
+                </p:cond>
+              </p:nextCondLst>
+            </p:seq>
+          </p:childTnLst>
+        </p:cTn>
+      </p:par>
+    </p:tnLst>
+  </p:timing>
 </p:sld>
 </file>
 
@@ -6922,6 +9619,502 @@
             <a:glow rad="26670">
               <a:srgbClr val="58F268">
                 <a:alpha val="28800"/>
+              </a:srgbClr>
+            </a:glow>
+          </a:effectLst>
+        </p:spPr>
+      </p:sp>
+      <p:sp>
+        <p:nvSpPr>
+          <p:cNvPr id="51" name="Світло рамки 2.8"/>
+          <p:cNvSpPr/>
+          <p:nvPr/>
+        </p:nvSpPr>
+        <p:spPr>
+          <a:xfrm>
+            <a:off x="11624767" y="6108192"/>
+            <a:ext cx="36576" cy="36576"/>
+          </a:xfrm>
+          <a:prstGeom prst="ellipse">
+            <a:avLst/>
+          </a:prstGeom>
+          <a:solidFill>
+            <a:srgbClr val="58F268">
+              <a:alpha val="20000"/>
+            </a:srgbClr>
+          </a:solidFill>
+          <a:ln>
+            <a:noFill/>
+          </a:ln>
+          <a:effectLst>
+            <a:glow rad="63500">
+              <a:srgbClr val="58F268">
+                <a:alpha val="12000"/>
+              </a:srgbClr>
+            </a:glow>
+          </a:effectLst>
+        </p:spPr>
+      </p:sp>
+      <p:sp>
+        <p:nvSpPr>
+          <p:cNvPr id="50" name="Світло рамки 2.7"/>
+          <p:cNvSpPr/>
+          <p:nvPr/>
+        </p:nvSpPr>
+        <p:spPr>
+          <a:xfrm>
+            <a:off x="11618889" y="6102314"/>
+            <a:ext cx="48332" cy="48332"/>
+          </a:xfrm>
+          <a:prstGeom prst="ellipse">
+            <a:avLst/>
+          </a:prstGeom>
+          <a:solidFill>
+            <a:srgbClr val="58F268">
+              <a:alpha val="31428"/>
+            </a:srgbClr>
+          </a:solidFill>
+          <a:ln>
+            <a:noFill/>
+          </a:ln>
+          <a:effectLst>
+            <a:glow rad="63500">
+              <a:srgbClr val="58F268">
+                <a:alpha val="18856"/>
+              </a:srgbClr>
+            </a:glow>
+          </a:effectLst>
+        </p:spPr>
+      </p:sp>
+      <p:sp>
+        <p:nvSpPr>
+          <p:cNvPr id="49" name="Світло рамки 2.6"/>
+          <p:cNvSpPr/>
+          <p:nvPr/>
+        </p:nvSpPr>
+        <p:spPr>
+          <a:xfrm>
+            <a:off x="11613011" y="6096436"/>
+            <a:ext cx="60089" cy="60089"/>
+          </a:xfrm>
+          <a:prstGeom prst="ellipse">
+            <a:avLst/>
+          </a:prstGeom>
+          <a:solidFill>
+            <a:srgbClr val="58F268">
+              <a:alpha val="42857"/>
+            </a:srgbClr>
+          </a:solidFill>
+          <a:ln>
+            <a:noFill/>
+          </a:ln>
+          <a:effectLst>
+            <a:glow rad="63500">
+              <a:srgbClr val="58F268">
+                <a:alpha val="25714"/>
+              </a:srgbClr>
+            </a:glow>
+          </a:effectLst>
+        </p:spPr>
+      </p:sp>
+      <p:sp>
+        <p:nvSpPr>
+          <p:cNvPr id="48" name="Світло рамки 2.5"/>
+          <p:cNvSpPr/>
+          <p:nvPr/>
+        </p:nvSpPr>
+        <p:spPr>
+          <a:xfrm>
+            <a:off x="11607133" y="6090558"/>
+            <a:ext cx="71845" cy="71845"/>
+          </a:xfrm>
+          <a:prstGeom prst="ellipse">
+            <a:avLst/>
+          </a:prstGeom>
+          <a:solidFill>
+            <a:srgbClr val="58F268">
+              <a:alpha val="54285"/>
+            </a:srgbClr>
+          </a:solidFill>
+          <a:ln>
+            <a:noFill/>
+          </a:ln>
+          <a:effectLst>
+            <a:glow rad="63500">
+              <a:srgbClr val="58F268">
+                <a:alpha val="32571"/>
+              </a:srgbClr>
+            </a:glow>
+          </a:effectLst>
+        </p:spPr>
+      </p:sp>
+      <p:sp>
+        <p:nvSpPr>
+          <p:cNvPr id="47" name="Світло рамки 2.4"/>
+          <p:cNvSpPr/>
+          <p:nvPr/>
+        </p:nvSpPr>
+        <p:spPr>
+          <a:xfrm>
+            <a:off x="11601254" y="6084679"/>
+            <a:ext cx="83602" cy="83602"/>
+          </a:xfrm>
+          <a:prstGeom prst="ellipse">
+            <a:avLst/>
+          </a:prstGeom>
+          <a:solidFill>
+            <a:srgbClr val="58F268">
+              <a:alpha val="65714"/>
+            </a:srgbClr>
+          </a:solidFill>
+          <a:ln>
+            <a:noFill/>
+          </a:ln>
+          <a:effectLst>
+            <a:glow rad="63500">
+              <a:srgbClr val="58F268">
+                <a:alpha val="39428"/>
+              </a:srgbClr>
+            </a:glow>
+          </a:effectLst>
+        </p:spPr>
+      </p:sp>
+      <p:sp>
+        <p:nvSpPr>
+          <p:cNvPr id="46" name="Світло рамки 2.3"/>
+          <p:cNvSpPr/>
+          <p:nvPr/>
+        </p:nvSpPr>
+        <p:spPr>
+          <a:xfrm>
+            <a:off x="11595376" y="6078801"/>
+            <a:ext cx="95358" cy="95358"/>
+          </a:xfrm>
+          <a:prstGeom prst="ellipse">
+            <a:avLst/>
+          </a:prstGeom>
+          <a:solidFill>
+            <a:srgbClr val="58F268">
+              <a:alpha val="77142"/>
+            </a:srgbClr>
+          </a:solidFill>
+          <a:ln>
+            <a:noFill/>
+          </a:ln>
+          <a:effectLst>
+            <a:glow rad="63500">
+              <a:srgbClr val="58F268">
+                <a:alpha val="46285"/>
+              </a:srgbClr>
+            </a:glow>
+          </a:effectLst>
+        </p:spPr>
+      </p:sp>
+      <p:sp>
+        <p:nvSpPr>
+          <p:cNvPr id="45" name="Світло рамки 2.2"/>
+          <p:cNvSpPr/>
+          <p:nvPr/>
+        </p:nvSpPr>
+        <p:spPr>
+          <a:xfrm>
+            <a:off x="11589498" y="6072923"/>
+            <a:ext cx="107115" cy="107115"/>
+          </a:xfrm>
+          <a:prstGeom prst="ellipse">
+            <a:avLst/>
+          </a:prstGeom>
+          <a:solidFill>
+            <a:srgbClr val="58F268">
+              <a:alpha val="88571"/>
+            </a:srgbClr>
+          </a:solidFill>
+          <a:ln>
+            <a:noFill/>
+          </a:ln>
+          <a:effectLst>
+            <a:glow rad="63500">
+              <a:srgbClr val="58F268">
+                <a:alpha val="53142"/>
+              </a:srgbClr>
+            </a:glow>
+          </a:effectLst>
+        </p:spPr>
+      </p:sp>
+      <p:sp>
+        <p:nvSpPr>
+          <p:cNvPr id="44" name="Світло рамки 2.1"/>
+          <p:cNvSpPr/>
+          <p:nvPr/>
+        </p:nvSpPr>
+        <p:spPr>
+          <a:xfrm>
+            <a:off x="11583619" y="6067044"/>
+            <a:ext cx="118872" cy="118872"/>
+          </a:xfrm>
+          <a:prstGeom prst="ellipse">
+            <a:avLst/>
+          </a:prstGeom>
+          <a:solidFill>
+            <a:srgbClr val="F2FFF3">
+              <a:alpha val="100000"/>
+            </a:srgbClr>
+          </a:solidFill>
+          <a:ln>
+            <a:noFill/>
+          </a:ln>
+          <a:effectLst>
+            <a:glow rad="101600">
+              <a:srgbClr val="58F268">
+                <a:alpha val="60000"/>
+              </a:srgbClr>
+            </a:glow>
+          </a:effectLst>
+        </p:spPr>
+      </p:sp>
+      <p:sp>
+        <p:nvSpPr>
+          <p:cNvPr id="43" name="Світло рамки 1.8"/>
+          <p:cNvSpPr/>
+          <p:nvPr/>
+        </p:nvSpPr>
+        <p:spPr>
+          <a:xfrm>
+            <a:off x="7281367" y="1764792"/>
+            <a:ext cx="36576" cy="36576"/>
+          </a:xfrm>
+          <a:prstGeom prst="ellipse">
+            <a:avLst/>
+          </a:prstGeom>
+          <a:solidFill>
+            <a:srgbClr val="58F268">
+              <a:alpha val="20000"/>
+            </a:srgbClr>
+          </a:solidFill>
+          <a:ln>
+            <a:noFill/>
+          </a:ln>
+          <a:effectLst>
+            <a:glow rad="63500">
+              <a:srgbClr val="58F268">
+                <a:alpha val="12000"/>
+              </a:srgbClr>
+            </a:glow>
+          </a:effectLst>
+        </p:spPr>
+      </p:sp>
+      <p:sp>
+        <p:nvSpPr>
+          <p:cNvPr id="42" name="Світло рамки 1.7"/>
+          <p:cNvSpPr/>
+          <p:nvPr/>
+        </p:nvSpPr>
+        <p:spPr>
+          <a:xfrm>
+            <a:off x="7275489" y="1758914"/>
+            <a:ext cx="48332" cy="48332"/>
+          </a:xfrm>
+          <a:prstGeom prst="ellipse">
+            <a:avLst/>
+          </a:prstGeom>
+          <a:solidFill>
+            <a:srgbClr val="58F268">
+              <a:alpha val="31428"/>
+            </a:srgbClr>
+          </a:solidFill>
+          <a:ln>
+            <a:noFill/>
+          </a:ln>
+          <a:effectLst>
+            <a:glow rad="63500">
+              <a:srgbClr val="58F268">
+                <a:alpha val="18856"/>
+              </a:srgbClr>
+            </a:glow>
+          </a:effectLst>
+        </p:spPr>
+      </p:sp>
+      <p:sp>
+        <p:nvSpPr>
+          <p:cNvPr id="41" name="Світло рамки 1.6"/>
+          <p:cNvSpPr/>
+          <p:nvPr/>
+        </p:nvSpPr>
+        <p:spPr>
+          <a:xfrm>
+            <a:off x="7269611" y="1753036"/>
+            <a:ext cx="60089" cy="60089"/>
+          </a:xfrm>
+          <a:prstGeom prst="ellipse">
+            <a:avLst/>
+          </a:prstGeom>
+          <a:solidFill>
+            <a:srgbClr val="58F268">
+              <a:alpha val="42857"/>
+            </a:srgbClr>
+          </a:solidFill>
+          <a:ln>
+            <a:noFill/>
+          </a:ln>
+          <a:effectLst>
+            <a:glow rad="63500">
+              <a:srgbClr val="58F268">
+                <a:alpha val="25714"/>
+              </a:srgbClr>
+            </a:glow>
+          </a:effectLst>
+        </p:spPr>
+      </p:sp>
+      <p:sp>
+        <p:nvSpPr>
+          <p:cNvPr id="40" name="Світло рамки 1.5"/>
+          <p:cNvSpPr/>
+          <p:nvPr/>
+        </p:nvSpPr>
+        <p:spPr>
+          <a:xfrm>
+            <a:off x="7263733" y="1747158"/>
+            <a:ext cx="71845" cy="71845"/>
+          </a:xfrm>
+          <a:prstGeom prst="ellipse">
+            <a:avLst/>
+          </a:prstGeom>
+          <a:solidFill>
+            <a:srgbClr val="58F268">
+              <a:alpha val="54285"/>
+            </a:srgbClr>
+          </a:solidFill>
+          <a:ln>
+            <a:noFill/>
+          </a:ln>
+          <a:effectLst>
+            <a:glow rad="63500">
+              <a:srgbClr val="58F268">
+                <a:alpha val="32571"/>
+              </a:srgbClr>
+            </a:glow>
+          </a:effectLst>
+        </p:spPr>
+      </p:sp>
+      <p:sp>
+        <p:nvSpPr>
+          <p:cNvPr id="39" name="Світло рамки 1.4"/>
+          <p:cNvSpPr/>
+          <p:nvPr/>
+        </p:nvSpPr>
+        <p:spPr>
+          <a:xfrm>
+            <a:off x="7257854" y="1741279"/>
+            <a:ext cx="83602" cy="83602"/>
+          </a:xfrm>
+          <a:prstGeom prst="ellipse">
+            <a:avLst/>
+          </a:prstGeom>
+          <a:solidFill>
+            <a:srgbClr val="58F268">
+              <a:alpha val="65714"/>
+            </a:srgbClr>
+          </a:solidFill>
+          <a:ln>
+            <a:noFill/>
+          </a:ln>
+          <a:effectLst>
+            <a:glow rad="63500">
+              <a:srgbClr val="58F268">
+                <a:alpha val="39428"/>
+              </a:srgbClr>
+            </a:glow>
+          </a:effectLst>
+        </p:spPr>
+      </p:sp>
+      <p:sp>
+        <p:nvSpPr>
+          <p:cNvPr id="38" name="Світло рамки 1.3"/>
+          <p:cNvSpPr/>
+          <p:nvPr/>
+        </p:nvSpPr>
+        <p:spPr>
+          <a:xfrm>
+            <a:off x="7251976" y="1735401"/>
+            <a:ext cx="95358" cy="95358"/>
+          </a:xfrm>
+          <a:prstGeom prst="ellipse">
+            <a:avLst/>
+          </a:prstGeom>
+          <a:solidFill>
+            <a:srgbClr val="58F268">
+              <a:alpha val="77142"/>
+            </a:srgbClr>
+          </a:solidFill>
+          <a:ln>
+            <a:noFill/>
+          </a:ln>
+          <a:effectLst>
+            <a:glow rad="63500">
+              <a:srgbClr val="58F268">
+                <a:alpha val="46285"/>
+              </a:srgbClr>
+            </a:glow>
+          </a:effectLst>
+        </p:spPr>
+      </p:sp>
+      <p:sp>
+        <p:nvSpPr>
+          <p:cNvPr id="37" name="Світло рамки 1.2"/>
+          <p:cNvSpPr/>
+          <p:nvPr/>
+        </p:nvSpPr>
+        <p:spPr>
+          <a:xfrm>
+            <a:off x="7246098" y="1729523"/>
+            <a:ext cx="107115" cy="107115"/>
+          </a:xfrm>
+          <a:prstGeom prst="ellipse">
+            <a:avLst/>
+          </a:prstGeom>
+          <a:solidFill>
+            <a:srgbClr val="58F268">
+              <a:alpha val="88571"/>
+            </a:srgbClr>
+          </a:solidFill>
+          <a:ln>
+            <a:noFill/>
+          </a:ln>
+          <a:effectLst>
+            <a:glow rad="63500">
+              <a:srgbClr val="58F268">
+                <a:alpha val="53142"/>
+              </a:srgbClr>
+            </a:glow>
+          </a:effectLst>
+        </p:spPr>
+      </p:sp>
+      <p:sp>
+        <p:nvSpPr>
+          <p:cNvPr id="36" name="Світло рамки 1.1"/>
+          <p:cNvSpPr/>
+          <p:nvPr/>
+        </p:nvSpPr>
+        <p:spPr>
+          <a:xfrm>
+            <a:off x="7240219" y="1723644"/>
+            <a:ext cx="118872" cy="118872"/>
+          </a:xfrm>
+          <a:prstGeom prst="ellipse">
+            <a:avLst/>
+          </a:prstGeom>
+          <a:solidFill>
+            <a:srgbClr val="F2FFF3">
+              <a:alpha val="100000"/>
+            </a:srgbClr>
+          </a:solidFill>
+          <a:ln>
+            <a:noFill/>
+          </a:ln>
+          <a:effectLst>
+            <a:glow rad="101600">
+              <a:srgbClr val="58F268">
+                <a:alpha val="60000"/>
               </a:srgbClr>
             </a:glow>
           </a:effectLst>
@@ -8015,6 +11208,409 @@
   <p:clrMapOvr>
     <a:masterClrMapping/>
   </p:clrMapOvr>
+  <p:timing>
+    <p:tnLst>
+      <p:par>
+        <p:cTn id="1" dur="indefinite" restart="never" nodeType="tmRoot">
+          <p:childTnLst>
+            <p:seq concurrent="1" nextAc="seek">
+              <p:cTn id="2" dur="indefinite" nodeType="mainSeq">
+                <p:childTnLst>
+                  <p:par>
+                    <p:cTn id="3" fill="hold">
+                      <p:stCondLst>
+                        <p:cond delay="indefinite"/>
+                        <p:cond evt="onBegin" delay="0">
+                          <p:tn val="2"/>
+                        </p:cond>
+                      </p:stCondLst>
+                      <p:childTnLst>
+                        <p:par>
+                          <p:cTn id="4" fill="hold">
+                            <p:stCondLst>
+                              <p:cond delay="0"/>
+                            </p:stCondLst>
+                            <p:childTnLst>
+                              <p:par>
+                                <p:cTn id="5" presetID="0" presetClass="path" presetSubtype="0" repeatCount="indefinite" accel="0" decel="0" fill="hold" nodeType="withEffect">
+                                  <p:stCondLst>
+                                    <p:cond delay="0"/>
+                                  </p:stCondLst>
+                                  <p:childTnLst>
+                                    <p:animMotion origin="layout" path="M 0 0 L 0.35625 0 L 0.35625 0.63333 L 0 0.63333 L 0 0 E" pathEditMode="relative" rAng="0" ptsTypes="AAAAA">
+                                      <p:cBhvr>
+                                        <p:cTn id="6" dur="6317" fill="hold"/>
+                                        <p:tgtEl>
+                                          <p:spTgt spid="36"/>
+                                        </p:tgtEl>
+                                        <p:attrNameLst>
+                                          <p:attrName>ppt_x</p:attrName>
+                                          <p:attrName>ppt_y</p:attrName>
+                                        </p:attrNameLst>
+                                      </p:cBhvr>
+                                      <p:rCtr x="0" y="0"/>
+                                    </p:animMotion>
+                                  </p:childTnLst>
+                                </p:cTn>
+                              </p:par>
+                              <p:par>
+                                <p:cTn id="7" presetID="0" presetClass="path" presetSubtype="0" repeatCount="indefinite" accel="0" decel="0" fill="hold" nodeType="withEffect">
+                                  <p:stCondLst>
+                                    <p:cond delay="55"/>
+                                  </p:stCondLst>
+                                  <p:childTnLst>
+                                    <p:animMotion origin="layout" path="M 0 0 L 0.35625 0 L 0.35625 0.63333 L 0 0.63333 L 0 0 E" pathEditMode="relative" rAng="0" ptsTypes="AAAAA">
+                                      <p:cBhvr>
+                                        <p:cTn id="8" dur="6317" fill="hold"/>
+                                        <p:tgtEl>
+                                          <p:spTgt spid="37"/>
+                                        </p:tgtEl>
+                                        <p:attrNameLst>
+                                          <p:attrName>ppt_x</p:attrName>
+                                          <p:attrName>ppt_y</p:attrName>
+                                        </p:attrNameLst>
+                                      </p:cBhvr>
+                                      <p:rCtr x="0" y="0"/>
+                                    </p:animMotion>
+                                  </p:childTnLst>
+                                </p:cTn>
+                              </p:par>
+                              <p:par>
+                                <p:cTn id="9" presetID="0" presetClass="path" presetSubtype="0" repeatCount="indefinite" accel="0" decel="0" fill="hold" nodeType="withEffect">
+                                  <p:stCondLst>
+                                    <p:cond delay="110"/>
+                                  </p:stCondLst>
+                                  <p:childTnLst>
+                                    <p:animMotion origin="layout" path="M 0 0 L 0.35625 0 L 0.35625 0.63333 L 0 0.63333 L 0 0 E" pathEditMode="relative" rAng="0" ptsTypes="AAAAA">
+                                      <p:cBhvr>
+                                        <p:cTn id="10" dur="6317" fill="hold"/>
+                                        <p:tgtEl>
+                                          <p:spTgt spid="38"/>
+                                        </p:tgtEl>
+                                        <p:attrNameLst>
+                                          <p:attrName>ppt_x</p:attrName>
+                                          <p:attrName>ppt_y</p:attrName>
+                                        </p:attrNameLst>
+                                      </p:cBhvr>
+                                      <p:rCtr x="0" y="0"/>
+                                    </p:animMotion>
+                                  </p:childTnLst>
+                                </p:cTn>
+                              </p:par>
+                              <p:par>
+                                <p:cTn id="11" presetID="0" presetClass="path" presetSubtype="0" repeatCount="indefinite" accel="0" decel="0" fill="hold" nodeType="withEffect">
+                                  <p:stCondLst>
+                                    <p:cond delay="165"/>
+                                  </p:stCondLst>
+                                  <p:childTnLst>
+                                    <p:animMotion origin="layout" path="M 0 0 L 0.35625 0 L 0.35625 0.63333 L 0 0.63333 L 0 0 E" pathEditMode="relative" rAng="0" ptsTypes="AAAAA">
+                                      <p:cBhvr>
+                                        <p:cTn id="12" dur="6317" fill="hold"/>
+                                        <p:tgtEl>
+                                          <p:spTgt spid="39"/>
+                                        </p:tgtEl>
+                                        <p:attrNameLst>
+                                          <p:attrName>ppt_x</p:attrName>
+                                          <p:attrName>ppt_y</p:attrName>
+                                        </p:attrNameLst>
+                                      </p:cBhvr>
+                                      <p:rCtr x="0" y="0"/>
+                                    </p:animMotion>
+                                  </p:childTnLst>
+                                </p:cTn>
+                              </p:par>
+                              <p:par>
+                                <p:cTn id="13" presetID="0" presetClass="path" presetSubtype="0" repeatCount="indefinite" accel="0" decel="0" fill="hold" nodeType="withEffect">
+                                  <p:stCondLst>
+                                    <p:cond delay="220"/>
+                                  </p:stCondLst>
+                                  <p:childTnLst>
+                                    <p:animMotion origin="layout" path="M 0 0 L 0.35625 0 L 0.35625 0.63333 L 0 0.63333 L 0 0 E" pathEditMode="relative" rAng="0" ptsTypes="AAAAA">
+                                      <p:cBhvr>
+                                        <p:cTn id="14" dur="6317" fill="hold"/>
+                                        <p:tgtEl>
+                                          <p:spTgt spid="40"/>
+                                        </p:tgtEl>
+                                        <p:attrNameLst>
+                                          <p:attrName>ppt_x</p:attrName>
+                                          <p:attrName>ppt_y</p:attrName>
+                                        </p:attrNameLst>
+                                      </p:cBhvr>
+                                      <p:rCtr x="0" y="0"/>
+                                    </p:animMotion>
+                                  </p:childTnLst>
+                                </p:cTn>
+                              </p:par>
+                              <p:par>
+                                <p:cTn id="15" presetID="0" presetClass="path" presetSubtype="0" repeatCount="indefinite" accel="0" decel="0" fill="hold" nodeType="withEffect">
+                                  <p:stCondLst>
+                                    <p:cond delay="275"/>
+                                  </p:stCondLst>
+                                  <p:childTnLst>
+                                    <p:animMotion origin="layout" path="M 0 0 L 0.35625 0 L 0.35625 0.63333 L 0 0.63333 L 0 0 E" pathEditMode="relative" rAng="0" ptsTypes="AAAAA">
+                                      <p:cBhvr>
+                                        <p:cTn id="16" dur="6317" fill="hold"/>
+                                        <p:tgtEl>
+                                          <p:spTgt spid="41"/>
+                                        </p:tgtEl>
+                                        <p:attrNameLst>
+                                          <p:attrName>ppt_x</p:attrName>
+                                          <p:attrName>ppt_y</p:attrName>
+                                        </p:attrNameLst>
+                                      </p:cBhvr>
+                                      <p:rCtr x="0" y="0"/>
+                                    </p:animMotion>
+                                  </p:childTnLst>
+                                </p:cTn>
+                              </p:par>
+                              <p:par>
+                                <p:cTn id="17" presetID="0" presetClass="path" presetSubtype="0" repeatCount="indefinite" accel="0" decel="0" fill="hold" nodeType="withEffect">
+                                  <p:stCondLst>
+                                    <p:cond delay="330"/>
+                                  </p:stCondLst>
+                                  <p:childTnLst>
+                                    <p:animMotion origin="layout" path="M 0 0 L 0.35625 0 L 0.35625 0.63333 L 0 0.63333 L 0 0 E" pathEditMode="relative" rAng="0" ptsTypes="AAAAA">
+                                      <p:cBhvr>
+                                        <p:cTn id="18" dur="6317" fill="hold"/>
+                                        <p:tgtEl>
+                                          <p:spTgt spid="42"/>
+                                        </p:tgtEl>
+                                        <p:attrNameLst>
+                                          <p:attrName>ppt_x</p:attrName>
+                                          <p:attrName>ppt_y</p:attrName>
+                                        </p:attrNameLst>
+                                      </p:cBhvr>
+                                      <p:rCtr x="0" y="0"/>
+                                    </p:animMotion>
+                                  </p:childTnLst>
+                                </p:cTn>
+                              </p:par>
+                              <p:par>
+                                <p:cTn id="19" presetID="0" presetClass="path" presetSubtype="0" repeatCount="indefinite" accel="0" decel="0" fill="hold" nodeType="withEffect">
+                                  <p:stCondLst>
+                                    <p:cond delay="385"/>
+                                  </p:stCondLst>
+                                  <p:childTnLst>
+                                    <p:animMotion origin="layout" path="M 0 0 L 0.35625 0 L 0.35625 0.63333 L 0 0.63333 L 0 0 E" pathEditMode="relative" rAng="0" ptsTypes="AAAAA">
+                                      <p:cBhvr>
+                                        <p:cTn id="20" dur="6317" fill="hold"/>
+                                        <p:tgtEl>
+                                          <p:spTgt spid="43"/>
+                                        </p:tgtEl>
+                                        <p:attrNameLst>
+                                          <p:attrName>ppt_x</p:attrName>
+                                          <p:attrName>ppt_y</p:attrName>
+                                        </p:attrNameLst>
+                                      </p:cBhvr>
+                                      <p:rCtr x="0" y="0"/>
+                                    </p:animMotion>
+                                  </p:childTnLst>
+                                </p:cTn>
+                              </p:par>
+                              <p:par>
+                                <p:cTn id="21" presetID="0" presetClass="path" presetSubtype="0" repeatCount="indefinite" accel="0" decel="0" fill="hold" nodeType="withEffect">
+                                  <p:stCondLst>
+                                    <p:cond delay="0"/>
+                                  </p:stCondLst>
+                                  <p:childTnLst>
+                                    <p:animMotion origin="layout" path="M 0 0 L -0.35625 0 L -0.35625 -0.63333 L 0 -0.63333 L 0 0 E" pathEditMode="relative" rAng="0" ptsTypes="AAAAA">
+                                      <p:cBhvr>
+                                        <p:cTn id="22" dur="6317" fill="hold"/>
+                                        <p:tgtEl>
+                                          <p:spTgt spid="44"/>
+                                        </p:tgtEl>
+                                        <p:attrNameLst>
+                                          <p:attrName>ppt_x</p:attrName>
+                                          <p:attrName>ppt_y</p:attrName>
+                                        </p:attrNameLst>
+                                      </p:cBhvr>
+                                      <p:rCtr x="0" y="0"/>
+                                    </p:animMotion>
+                                  </p:childTnLst>
+                                </p:cTn>
+                              </p:par>
+                              <p:par>
+                                <p:cTn id="23" presetID="0" presetClass="path" presetSubtype="0" repeatCount="indefinite" accel="0" decel="0" fill="hold" nodeType="withEffect">
+                                  <p:stCondLst>
+                                    <p:cond delay="55"/>
+                                  </p:stCondLst>
+                                  <p:childTnLst>
+                                    <p:animMotion origin="layout" path="M 0 0 L -0.35625 0 L -0.35625 -0.63333 L 0 -0.63333 L 0 0 E" pathEditMode="relative" rAng="0" ptsTypes="AAAAA">
+                                      <p:cBhvr>
+                                        <p:cTn id="24" dur="6317" fill="hold"/>
+                                        <p:tgtEl>
+                                          <p:spTgt spid="45"/>
+                                        </p:tgtEl>
+                                        <p:attrNameLst>
+                                          <p:attrName>ppt_x</p:attrName>
+                                          <p:attrName>ppt_y</p:attrName>
+                                        </p:attrNameLst>
+                                      </p:cBhvr>
+                                      <p:rCtr x="0" y="0"/>
+                                    </p:animMotion>
+                                  </p:childTnLst>
+                                </p:cTn>
+                              </p:par>
+                              <p:par>
+                                <p:cTn id="25" presetID="0" presetClass="path" presetSubtype="0" repeatCount="indefinite" accel="0" decel="0" fill="hold" nodeType="withEffect">
+                                  <p:stCondLst>
+                                    <p:cond delay="110"/>
+                                  </p:stCondLst>
+                                  <p:childTnLst>
+                                    <p:animMotion origin="layout" path="M 0 0 L -0.35625 0 L -0.35625 -0.63333 L 0 -0.63333 L 0 0 E" pathEditMode="relative" rAng="0" ptsTypes="AAAAA">
+                                      <p:cBhvr>
+                                        <p:cTn id="26" dur="6317" fill="hold"/>
+                                        <p:tgtEl>
+                                          <p:spTgt spid="46"/>
+                                        </p:tgtEl>
+                                        <p:attrNameLst>
+                                          <p:attrName>ppt_x</p:attrName>
+                                          <p:attrName>ppt_y</p:attrName>
+                                        </p:attrNameLst>
+                                      </p:cBhvr>
+                                      <p:rCtr x="0" y="0"/>
+                                    </p:animMotion>
+                                  </p:childTnLst>
+                                </p:cTn>
+                              </p:par>
+                              <p:par>
+                                <p:cTn id="27" presetID="0" presetClass="path" presetSubtype="0" repeatCount="indefinite" accel="0" decel="0" fill="hold" nodeType="withEffect">
+                                  <p:stCondLst>
+                                    <p:cond delay="165"/>
+                                  </p:stCondLst>
+                                  <p:childTnLst>
+                                    <p:animMotion origin="layout" path="M 0 0 L -0.35625 0 L -0.35625 -0.63333 L 0 -0.63333 L 0 0 E" pathEditMode="relative" rAng="0" ptsTypes="AAAAA">
+                                      <p:cBhvr>
+                                        <p:cTn id="28" dur="6317" fill="hold"/>
+                                        <p:tgtEl>
+                                          <p:spTgt spid="47"/>
+                                        </p:tgtEl>
+                                        <p:attrNameLst>
+                                          <p:attrName>ppt_x</p:attrName>
+                                          <p:attrName>ppt_y</p:attrName>
+                                        </p:attrNameLst>
+                                      </p:cBhvr>
+                                      <p:rCtr x="0" y="0"/>
+                                    </p:animMotion>
+                                  </p:childTnLst>
+                                </p:cTn>
+                              </p:par>
+                              <p:par>
+                                <p:cTn id="29" presetID="0" presetClass="path" presetSubtype="0" repeatCount="indefinite" accel="0" decel="0" fill="hold" nodeType="withEffect">
+                                  <p:stCondLst>
+                                    <p:cond delay="220"/>
+                                  </p:stCondLst>
+                                  <p:childTnLst>
+                                    <p:animMotion origin="layout" path="M 0 0 L -0.35625 0 L -0.35625 -0.63333 L 0 -0.63333 L 0 0 E" pathEditMode="relative" rAng="0" ptsTypes="AAAAA">
+                                      <p:cBhvr>
+                                        <p:cTn id="30" dur="6317" fill="hold"/>
+                                        <p:tgtEl>
+                                          <p:spTgt spid="48"/>
+                                        </p:tgtEl>
+                                        <p:attrNameLst>
+                                          <p:attrName>ppt_x</p:attrName>
+                                          <p:attrName>ppt_y</p:attrName>
+                                        </p:attrNameLst>
+                                      </p:cBhvr>
+                                      <p:rCtr x="0" y="0"/>
+                                    </p:animMotion>
+                                  </p:childTnLst>
+                                </p:cTn>
+                              </p:par>
+                              <p:par>
+                                <p:cTn id="31" presetID="0" presetClass="path" presetSubtype="0" repeatCount="indefinite" accel="0" decel="0" fill="hold" nodeType="withEffect">
+                                  <p:stCondLst>
+                                    <p:cond delay="275"/>
+                                  </p:stCondLst>
+                                  <p:childTnLst>
+                                    <p:animMotion origin="layout" path="M 0 0 L -0.35625 0 L -0.35625 -0.63333 L 0 -0.63333 L 0 0 E" pathEditMode="relative" rAng="0" ptsTypes="AAAAA">
+                                      <p:cBhvr>
+                                        <p:cTn id="32" dur="6317" fill="hold"/>
+                                        <p:tgtEl>
+                                          <p:spTgt spid="49"/>
+                                        </p:tgtEl>
+                                        <p:attrNameLst>
+                                          <p:attrName>ppt_x</p:attrName>
+                                          <p:attrName>ppt_y</p:attrName>
+                                        </p:attrNameLst>
+                                      </p:cBhvr>
+                                      <p:rCtr x="0" y="0"/>
+                                    </p:animMotion>
+                                  </p:childTnLst>
+                                </p:cTn>
+                              </p:par>
+                              <p:par>
+                                <p:cTn id="33" presetID="0" presetClass="path" presetSubtype="0" repeatCount="indefinite" accel="0" decel="0" fill="hold" nodeType="withEffect">
+                                  <p:stCondLst>
+                                    <p:cond delay="330"/>
+                                  </p:stCondLst>
+                                  <p:childTnLst>
+                                    <p:animMotion origin="layout" path="M 0 0 L -0.35625 0 L -0.35625 -0.63333 L 0 -0.63333 L 0 0 E" pathEditMode="relative" rAng="0" ptsTypes="AAAAA">
+                                      <p:cBhvr>
+                                        <p:cTn id="34" dur="6317" fill="hold"/>
+                                        <p:tgtEl>
+                                          <p:spTgt spid="50"/>
+                                        </p:tgtEl>
+                                        <p:attrNameLst>
+                                          <p:attrName>ppt_x</p:attrName>
+                                          <p:attrName>ppt_y</p:attrName>
+                                        </p:attrNameLst>
+                                      </p:cBhvr>
+                                      <p:rCtr x="0" y="0"/>
+                                    </p:animMotion>
+                                  </p:childTnLst>
+                                </p:cTn>
+                              </p:par>
+                              <p:par>
+                                <p:cTn id="35" presetID="0" presetClass="path" presetSubtype="0" repeatCount="indefinite" accel="0" decel="0" fill="hold" nodeType="withEffect">
+                                  <p:stCondLst>
+                                    <p:cond delay="385"/>
+                                  </p:stCondLst>
+                                  <p:childTnLst>
+                                    <p:animMotion origin="layout" path="M 0 0 L -0.35625 0 L -0.35625 -0.63333 L 0 -0.63333 L 0 0 E" pathEditMode="relative" rAng="0" ptsTypes="AAAAA">
+                                      <p:cBhvr>
+                                        <p:cTn id="36" dur="6317" fill="hold"/>
+                                        <p:tgtEl>
+                                          <p:spTgt spid="51"/>
+                                        </p:tgtEl>
+                                        <p:attrNameLst>
+                                          <p:attrName>ppt_x</p:attrName>
+                                          <p:attrName>ppt_y</p:attrName>
+                                        </p:attrNameLst>
+                                      </p:cBhvr>
+                                      <p:rCtr x="0" y="0"/>
+                                    </p:animMotion>
+                                  </p:childTnLst>
+                                </p:cTn>
+                              </p:par>
+                            </p:childTnLst>
+                          </p:cTn>
+                        </p:par>
+                      </p:childTnLst>
+                    </p:cTn>
+                  </p:par>
+                </p:childTnLst>
+              </p:cTn>
+              <p:prevCondLst>
+                <p:cond evt="onPrev" delay="0">
+                  <p:tgtEl>
+                    <p:sldTgt/>
+                  </p:tgtEl>
+                </p:cond>
+              </p:prevCondLst>
+              <p:nextCondLst>
+                <p:cond evt="onNext" delay="0">
+                  <p:tgtEl>
+                    <p:sldTgt/>
+                  </p:tgtEl>
+                </p:cond>
+              </p:nextCondLst>
+            </p:seq>
+          </p:childTnLst>
+        </p:cTn>
+      </p:par>
+    </p:tnLst>
+  </p:timing>
 </p:sld>
 </file>
 
@@ -9552,6 +13148,502 @@
       </p:sp>
       <p:sp>
         <p:nvSpPr>
+          <p:cNvPr id="44" name="Світло рамки 2.8"/>
+          <p:cNvSpPr/>
+          <p:nvPr/>
+        </p:nvSpPr>
+        <p:spPr>
+          <a:xfrm>
+            <a:off x="11624767" y="6108192"/>
+            <a:ext cx="36576" cy="36576"/>
+          </a:xfrm>
+          <a:prstGeom prst="ellipse">
+            <a:avLst/>
+          </a:prstGeom>
+          <a:solidFill>
+            <a:srgbClr val="58F268">
+              <a:alpha val="20000"/>
+            </a:srgbClr>
+          </a:solidFill>
+          <a:ln>
+            <a:noFill/>
+          </a:ln>
+          <a:effectLst>
+            <a:glow rad="63500">
+              <a:srgbClr val="58F268">
+                <a:alpha val="12000"/>
+              </a:srgbClr>
+            </a:glow>
+          </a:effectLst>
+        </p:spPr>
+      </p:sp>
+      <p:sp>
+        <p:nvSpPr>
+          <p:cNvPr id="43" name="Світло рамки 2.7"/>
+          <p:cNvSpPr/>
+          <p:nvPr/>
+        </p:nvSpPr>
+        <p:spPr>
+          <a:xfrm>
+            <a:off x="11618889" y="6102314"/>
+            <a:ext cx="48332" cy="48332"/>
+          </a:xfrm>
+          <a:prstGeom prst="ellipse">
+            <a:avLst/>
+          </a:prstGeom>
+          <a:solidFill>
+            <a:srgbClr val="58F268">
+              <a:alpha val="31428"/>
+            </a:srgbClr>
+          </a:solidFill>
+          <a:ln>
+            <a:noFill/>
+          </a:ln>
+          <a:effectLst>
+            <a:glow rad="63500">
+              <a:srgbClr val="58F268">
+                <a:alpha val="18856"/>
+              </a:srgbClr>
+            </a:glow>
+          </a:effectLst>
+        </p:spPr>
+      </p:sp>
+      <p:sp>
+        <p:nvSpPr>
+          <p:cNvPr id="42" name="Світло рамки 2.6"/>
+          <p:cNvSpPr/>
+          <p:nvPr/>
+        </p:nvSpPr>
+        <p:spPr>
+          <a:xfrm>
+            <a:off x="11613011" y="6096436"/>
+            <a:ext cx="60089" cy="60089"/>
+          </a:xfrm>
+          <a:prstGeom prst="ellipse">
+            <a:avLst/>
+          </a:prstGeom>
+          <a:solidFill>
+            <a:srgbClr val="58F268">
+              <a:alpha val="42857"/>
+            </a:srgbClr>
+          </a:solidFill>
+          <a:ln>
+            <a:noFill/>
+          </a:ln>
+          <a:effectLst>
+            <a:glow rad="63500">
+              <a:srgbClr val="58F268">
+                <a:alpha val="25714"/>
+              </a:srgbClr>
+            </a:glow>
+          </a:effectLst>
+        </p:spPr>
+      </p:sp>
+      <p:sp>
+        <p:nvSpPr>
+          <p:cNvPr id="41" name="Світло рамки 2.5"/>
+          <p:cNvSpPr/>
+          <p:nvPr/>
+        </p:nvSpPr>
+        <p:spPr>
+          <a:xfrm>
+            <a:off x="11607133" y="6090558"/>
+            <a:ext cx="71845" cy="71845"/>
+          </a:xfrm>
+          <a:prstGeom prst="ellipse">
+            <a:avLst/>
+          </a:prstGeom>
+          <a:solidFill>
+            <a:srgbClr val="58F268">
+              <a:alpha val="54285"/>
+            </a:srgbClr>
+          </a:solidFill>
+          <a:ln>
+            <a:noFill/>
+          </a:ln>
+          <a:effectLst>
+            <a:glow rad="63500">
+              <a:srgbClr val="58F268">
+                <a:alpha val="32571"/>
+              </a:srgbClr>
+            </a:glow>
+          </a:effectLst>
+        </p:spPr>
+      </p:sp>
+      <p:sp>
+        <p:nvSpPr>
+          <p:cNvPr id="40" name="Світло рамки 2.4"/>
+          <p:cNvSpPr/>
+          <p:nvPr/>
+        </p:nvSpPr>
+        <p:spPr>
+          <a:xfrm>
+            <a:off x="11601254" y="6084679"/>
+            <a:ext cx="83602" cy="83602"/>
+          </a:xfrm>
+          <a:prstGeom prst="ellipse">
+            <a:avLst/>
+          </a:prstGeom>
+          <a:solidFill>
+            <a:srgbClr val="58F268">
+              <a:alpha val="65714"/>
+            </a:srgbClr>
+          </a:solidFill>
+          <a:ln>
+            <a:noFill/>
+          </a:ln>
+          <a:effectLst>
+            <a:glow rad="63500">
+              <a:srgbClr val="58F268">
+                <a:alpha val="39428"/>
+              </a:srgbClr>
+            </a:glow>
+          </a:effectLst>
+        </p:spPr>
+      </p:sp>
+      <p:sp>
+        <p:nvSpPr>
+          <p:cNvPr id="39" name="Світло рамки 2.3"/>
+          <p:cNvSpPr/>
+          <p:nvPr/>
+        </p:nvSpPr>
+        <p:spPr>
+          <a:xfrm>
+            <a:off x="11595376" y="6078801"/>
+            <a:ext cx="95358" cy="95358"/>
+          </a:xfrm>
+          <a:prstGeom prst="ellipse">
+            <a:avLst/>
+          </a:prstGeom>
+          <a:solidFill>
+            <a:srgbClr val="58F268">
+              <a:alpha val="77142"/>
+            </a:srgbClr>
+          </a:solidFill>
+          <a:ln>
+            <a:noFill/>
+          </a:ln>
+          <a:effectLst>
+            <a:glow rad="63500">
+              <a:srgbClr val="58F268">
+                <a:alpha val="46285"/>
+              </a:srgbClr>
+            </a:glow>
+          </a:effectLst>
+        </p:spPr>
+      </p:sp>
+      <p:sp>
+        <p:nvSpPr>
+          <p:cNvPr id="38" name="Світло рамки 2.2"/>
+          <p:cNvSpPr/>
+          <p:nvPr/>
+        </p:nvSpPr>
+        <p:spPr>
+          <a:xfrm>
+            <a:off x="11589498" y="6072923"/>
+            <a:ext cx="107115" cy="107115"/>
+          </a:xfrm>
+          <a:prstGeom prst="ellipse">
+            <a:avLst/>
+          </a:prstGeom>
+          <a:solidFill>
+            <a:srgbClr val="58F268">
+              <a:alpha val="88571"/>
+            </a:srgbClr>
+          </a:solidFill>
+          <a:ln>
+            <a:noFill/>
+          </a:ln>
+          <a:effectLst>
+            <a:glow rad="63500">
+              <a:srgbClr val="58F268">
+                <a:alpha val="53142"/>
+              </a:srgbClr>
+            </a:glow>
+          </a:effectLst>
+        </p:spPr>
+      </p:sp>
+      <p:sp>
+        <p:nvSpPr>
+          <p:cNvPr id="37" name="Світло рамки 2.1"/>
+          <p:cNvSpPr/>
+          <p:nvPr/>
+        </p:nvSpPr>
+        <p:spPr>
+          <a:xfrm>
+            <a:off x="11583619" y="6067044"/>
+            <a:ext cx="118872" cy="118872"/>
+          </a:xfrm>
+          <a:prstGeom prst="ellipse">
+            <a:avLst/>
+          </a:prstGeom>
+          <a:solidFill>
+            <a:srgbClr val="F2FFF3">
+              <a:alpha val="100000"/>
+            </a:srgbClr>
+          </a:solidFill>
+          <a:ln>
+            <a:noFill/>
+          </a:ln>
+          <a:effectLst>
+            <a:glow rad="101600">
+              <a:srgbClr val="58F268">
+                <a:alpha val="60000"/>
+              </a:srgbClr>
+            </a:glow>
+          </a:effectLst>
+        </p:spPr>
+      </p:sp>
+      <p:sp>
+        <p:nvSpPr>
+          <p:cNvPr id="36" name="Світло рамки 1.8"/>
+          <p:cNvSpPr/>
+          <p:nvPr/>
+        </p:nvSpPr>
+        <p:spPr>
+          <a:xfrm>
+            <a:off x="8401507" y="1764792"/>
+            <a:ext cx="36576" cy="36576"/>
+          </a:xfrm>
+          <a:prstGeom prst="ellipse">
+            <a:avLst/>
+          </a:prstGeom>
+          <a:solidFill>
+            <a:srgbClr val="58F268">
+              <a:alpha val="20000"/>
+            </a:srgbClr>
+          </a:solidFill>
+          <a:ln>
+            <a:noFill/>
+          </a:ln>
+          <a:effectLst>
+            <a:glow rad="63500">
+              <a:srgbClr val="58F268">
+                <a:alpha val="12000"/>
+              </a:srgbClr>
+            </a:glow>
+          </a:effectLst>
+        </p:spPr>
+      </p:sp>
+      <p:sp>
+        <p:nvSpPr>
+          <p:cNvPr id="35" name="Світло рамки 1.7"/>
+          <p:cNvSpPr/>
+          <p:nvPr/>
+        </p:nvSpPr>
+        <p:spPr>
+          <a:xfrm>
+            <a:off x="8395629" y="1758914"/>
+            <a:ext cx="48332" cy="48332"/>
+          </a:xfrm>
+          <a:prstGeom prst="ellipse">
+            <a:avLst/>
+          </a:prstGeom>
+          <a:solidFill>
+            <a:srgbClr val="58F268">
+              <a:alpha val="31428"/>
+            </a:srgbClr>
+          </a:solidFill>
+          <a:ln>
+            <a:noFill/>
+          </a:ln>
+          <a:effectLst>
+            <a:glow rad="63500">
+              <a:srgbClr val="58F268">
+                <a:alpha val="18856"/>
+              </a:srgbClr>
+            </a:glow>
+          </a:effectLst>
+        </p:spPr>
+      </p:sp>
+      <p:sp>
+        <p:nvSpPr>
+          <p:cNvPr id="34" name="Світло рамки 1.6"/>
+          <p:cNvSpPr/>
+          <p:nvPr/>
+        </p:nvSpPr>
+        <p:spPr>
+          <a:xfrm>
+            <a:off x="8389751" y="1753036"/>
+            <a:ext cx="60089" cy="60089"/>
+          </a:xfrm>
+          <a:prstGeom prst="ellipse">
+            <a:avLst/>
+          </a:prstGeom>
+          <a:solidFill>
+            <a:srgbClr val="58F268">
+              <a:alpha val="42857"/>
+            </a:srgbClr>
+          </a:solidFill>
+          <a:ln>
+            <a:noFill/>
+          </a:ln>
+          <a:effectLst>
+            <a:glow rad="63500">
+              <a:srgbClr val="58F268">
+                <a:alpha val="25714"/>
+              </a:srgbClr>
+            </a:glow>
+          </a:effectLst>
+        </p:spPr>
+      </p:sp>
+      <p:sp>
+        <p:nvSpPr>
+          <p:cNvPr id="33" name="Світло рамки 1.5"/>
+          <p:cNvSpPr/>
+          <p:nvPr/>
+        </p:nvSpPr>
+        <p:spPr>
+          <a:xfrm>
+            <a:off x="8383873" y="1747158"/>
+            <a:ext cx="71845" cy="71845"/>
+          </a:xfrm>
+          <a:prstGeom prst="ellipse">
+            <a:avLst/>
+          </a:prstGeom>
+          <a:solidFill>
+            <a:srgbClr val="58F268">
+              <a:alpha val="54285"/>
+            </a:srgbClr>
+          </a:solidFill>
+          <a:ln>
+            <a:noFill/>
+          </a:ln>
+          <a:effectLst>
+            <a:glow rad="63500">
+              <a:srgbClr val="58F268">
+                <a:alpha val="32571"/>
+              </a:srgbClr>
+            </a:glow>
+          </a:effectLst>
+        </p:spPr>
+      </p:sp>
+      <p:sp>
+        <p:nvSpPr>
+          <p:cNvPr id="32" name="Світло рамки 1.4"/>
+          <p:cNvSpPr/>
+          <p:nvPr/>
+        </p:nvSpPr>
+        <p:spPr>
+          <a:xfrm>
+            <a:off x="8377994" y="1741279"/>
+            <a:ext cx="83602" cy="83602"/>
+          </a:xfrm>
+          <a:prstGeom prst="ellipse">
+            <a:avLst/>
+          </a:prstGeom>
+          <a:solidFill>
+            <a:srgbClr val="58F268">
+              <a:alpha val="65714"/>
+            </a:srgbClr>
+          </a:solidFill>
+          <a:ln>
+            <a:noFill/>
+          </a:ln>
+          <a:effectLst>
+            <a:glow rad="63500">
+              <a:srgbClr val="58F268">
+                <a:alpha val="39428"/>
+              </a:srgbClr>
+            </a:glow>
+          </a:effectLst>
+        </p:spPr>
+      </p:sp>
+      <p:sp>
+        <p:nvSpPr>
+          <p:cNvPr id="31" name="Світло рамки 1.3"/>
+          <p:cNvSpPr/>
+          <p:nvPr/>
+        </p:nvSpPr>
+        <p:spPr>
+          <a:xfrm>
+            <a:off x="8372116" y="1735401"/>
+            <a:ext cx="95358" cy="95358"/>
+          </a:xfrm>
+          <a:prstGeom prst="ellipse">
+            <a:avLst/>
+          </a:prstGeom>
+          <a:solidFill>
+            <a:srgbClr val="58F268">
+              <a:alpha val="77142"/>
+            </a:srgbClr>
+          </a:solidFill>
+          <a:ln>
+            <a:noFill/>
+          </a:ln>
+          <a:effectLst>
+            <a:glow rad="63500">
+              <a:srgbClr val="58F268">
+                <a:alpha val="46285"/>
+              </a:srgbClr>
+            </a:glow>
+          </a:effectLst>
+        </p:spPr>
+      </p:sp>
+      <p:sp>
+        <p:nvSpPr>
+          <p:cNvPr id="30" name="Світло рамки 1.2"/>
+          <p:cNvSpPr/>
+          <p:nvPr/>
+        </p:nvSpPr>
+        <p:spPr>
+          <a:xfrm>
+            <a:off x="8366238" y="1729523"/>
+            <a:ext cx="107115" cy="107115"/>
+          </a:xfrm>
+          <a:prstGeom prst="ellipse">
+            <a:avLst/>
+          </a:prstGeom>
+          <a:solidFill>
+            <a:srgbClr val="58F268">
+              <a:alpha val="88571"/>
+            </a:srgbClr>
+          </a:solidFill>
+          <a:ln>
+            <a:noFill/>
+          </a:ln>
+          <a:effectLst>
+            <a:glow rad="63500">
+              <a:srgbClr val="58F268">
+                <a:alpha val="53142"/>
+              </a:srgbClr>
+            </a:glow>
+          </a:effectLst>
+        </p:spPr>
+      </p:sp>
+      <p:sp>
+        <p:nvSpPr>
+          <p:cNvPr id="29" name="Світло рамки 1.1"/>
+          <p:cNvSpPr/>
+          <p:nvPr/>
+        </p:nvSpPr>
+        <p:spPr>
+          <a:xfrm>
+            <a:off x="8360359" y="1723644"/>
+            <a:ext cx="118872" cy="118872"/>
+          </a:xfrm>
+          <a:prstGeom prst="ellipse">
+            <a:avLst/>
+          </a:prstGeom>
+          <a:solidFill>
+            <a:srgbClr val="F2FFF3">
+              <a:alpha val="100000"/>
+            </a:srgbClr>
+          </a:solidFill>
+          <a:ln>
+            <a:noFill/>
+          </a:ln>
+          <a:effectLst>
+            <a:glow rad="101600">
+              <a:srgbClr val="58F268">
+                <a:alpha val="60000"/>
+              </a:srgbClr>
+            </a:glow>
+          </a:effectLst>
+        </p:spPr>
+      </p:sp>
+      <p:sp>
+        <p:nvSpPr>
           <p:cNvPr id="19" name="Кути коміксу 05 кут 1"/>
           <p:cNvSpPr/>
           <p:nvPr/>
@@ -9916,6 +14008,409 @@
   <p:clrMapOvr>
     <a:masterClrMapping/>
   </p:clrMapOvr>
+  <p:timing>
+    <p:tnLst>
+      <p:par>
+        <p:cTn id="1" dur="indefinite" restart="never" nodeType="tmRoot">
+          <p:childTnLst>
+            <p:seq concurrent="1" nextAc="seek">
+              <p:cTn id="2" dur="indefinite" nodeType="mainSeq">
+                <p:childTnLst>
+                  <p:par>
+                    <p:cTn id="3" fill="hold">
+                      <p:stCondLst>
+                        <p:cond delay="indefinite"/>
+                        <p:cond evt="onBegin" delay="0">
+                          <p:tn val="2"/>
+                        </p:cond>
+                      </p:stCondLst>
+                      <p:childTnLst>
+                        <p:par>
+                          <p:cTn id="4" fill="hold">
+                            <p:stCondLst>
+                              <p:cond delay="0"/>
+                            </p:stCondLst>
+                            <p:childTnLst>
+                              <p:par>
+                                <p:cTn id="5" presetID="0" presetClass="path" presetSubtype="0" repeatCount="indefinite" accel="0" decel="0" fill="hold" nodeType="withEffect">
+                                  <p:stCondLst>
+                                    <p:cond delay="0"/>
+                                  </p:stCondLst>
+                                  <p:childTnLst>
+                                    <p:animMotion origin="layout" path="M 0 0 L 0.26438 0 L 0.26438 0.63333 L 0 0.63333 L 0 0 E" pathEditMode="relative" rAng="0" ptsTypes="AAAAA">
+                                      <p:cBhvr>
+                                        <p:cTn id="6" dur="5503" fill="hold"/>
+                                        <p:tgtEl>
+                                          <p:spTgt spid="29"/>
+                                        </p:tgtEl>
+                                        <p:attrNameLst>
+                                          <p:attrName>ppt_x</p:attrName>
+                                          <p:attrName>ppt_y</p:attrName>
+                                        </p:attrNameLst>
+                                      </p:cBhvr>
+                                      <p:rCtr x="0" y="0"/>
+                                    </p:animMotion>
+                                  </p:childTnLst>
+                                </p:cTn>
+                              </p:par>
+                              <p:par>
+                                <p:cTn id="7" presetID="0" presetClass="path" presetSubtype="0" repeatCount="indefinite" accel="0" decel="0" fill="hold" nodeType="withEffect">
+                                  <p:stCondLst>
+                                    <p:cond delay="55"/>
+                                  </p:stCondLst>
+                                  <p:childTnLst>
+                                    <p:animMotion origin="layout" path="M 0 0 L 0.26438 0 L 0.26438 0.63333 L 0 0.63333 L 0 0 E" pathEditMode="relative" rAng="0" ptsTypes="AAAAA">
+                                      <p:cBhvr>
+                                        <p:cTn id="8" dur="5503" fill="hold"/>
+                                        <p:tgtEl>
+                                          <p:spTgt spid="30"/>
+                                        </p:tgtEl>
+                                        <p:attrNameLst>
+                                          <p:attrName>ppt_x</p:attrName>
+                                          <p:attrName>ppt_y</p:attrName>
+                                        </p:attrNameLst>
+                                      </p:cBhvr>
+                                      <p:rCtr x="0" y="0"/>
+                                    </p:animMotion>
+                                  </p:childTnLst>
+                                </p:cTn>
+                              </p:par>
+                              <p:par>
+                                <p:cTn id="9" presetID="0" presetClass="path" presetSubtype="0" repeatCount="indefinite" accel="0" decel="0" fill="hold" nodeType="withEffect">
+                                  <p:stCondLst>
+                                    <p:cond delay="110"/>
+                                  </p:stCondLst>
+                                  <p:childTnLst>
+                                    <p:animMotion origin="layout" path="M 0 0 L 0.26438 0 L 0.26438 0.63333 L 0 0.63333 L 0 0 E" pathEditMode="relative" rAng="0" ptsTypes="AAAAA">
+                                      <p:cBhvr>
+                                        <p:cTn id="10" dur="5503" fill="hold"/>
+                                        <p:tgtEl>
+                                          <p:spTgt spid="31"/>
+                                        </p:tgtEl>
+                                        <p:attrNameLst>
+                                          <p:attrName>ppt_x</p:attrName>
+                                          <p:attrName>ppt_y</p:attrName>
+                                        </p:attrNameLst>
+                                      </p:cBhvr>
+                                      <p:rCtr x="0" y="0"/>
+                                    </p:animMotion>
+                                  </p:childTnLst>
+                                </p:cTn>
+                              </p:par>
+                              <p:par>
+                                <p:cTn id="11" presetID="0" presetClass="path" presetSubtype="0" repeatCount="indefinite" accel="0" decel="0" fill="hold" nodeType="withEffect">
+                                  <p:stCondLst>
+                                    <p:cond delay="165"/>
+                                  </p:stCondLst>
+                                  <p:childTnLst>
+                                    <p:animMotion origin="layout" path="M 0 0 L 0.26438 0 L 0.26438 0.63333 L 0 0.63333 L 0 0 E" pathEditMode="relative" rAng="0" ptsTypes="AAAAA">
+                                      <p:cBhvr>
+                                        <p:cTn id="12" dur="5503" fill="hold"/>
+                                        <p:tgtEl>
+                                          <p:spTgt spid="32"/>
+                                        </p:tgtEl>
+                                        <p:attrNameLst>
+                                          <p:attrName>ppt_x</p:attrName>
+                                          <p:attrName>ppt_y</p:attrName>
+                                        </p:attrNameLst>
+                                      </p:cBhvr>
+                                      <p:rCtr x="0" y="0"/>
+                                    </p:animMotion>
+                                  </p:childTnLst>
+                                </p:cTn>
+                              </p:par>
+                              <p:par>
+                                <p:cTn id="13" presetID="0" presetClass="path" presetSubtype="0" repeatCount="indefinite" accel="0" decel="0" fill="hold" nodeType="withEffect">
+                                  <p:stCondLst>
+                                    <p:cond delay="220"/>
+                                  </p:stCondLst>
+                                  <p:childTnLst>
+                                    <p:animMotion origin="layout" path="M 0 0 L 0.26438 0 L 0.26438 0.63333 L 0 0.63333 L 0 0 E" pathEditMode="relative" rAng="0" ptsTypes="AAAAA">
+                                      <p:cBhvr>
+                                        <p:cTn id="14" dur="5503" fill="hold"/>
+                                        <p:tgtEl>
+                                          <p:spTgt spid="33"/>
+                                        </p:tgtEl>
+                                        <p:attrNameLst>
+                                          <p:attrName>ppt_x</p:attrName>
+                                          <p:attrName>ppt_y</p:attrName>
+                                        </p:attrNameLst>
+                                      </p:cBhvr>
+                                      <p:rCtr x="0" y="0"/>
+                                    </p:animMotion>
+                                  </p:childTnLst>
+                                </p:cTn>
+                              </p:par>
+                              <p:par>
+                                <p:cTn id="15" presetID="0" presetClass="path" presetSubtype="0" repeatCount="indefinite" accel="0" decel="0" fill="hold" nodeType="withEffect">
+                                  <p:stCondLst>
+                                    <p:cond delay="275"/>
+                                  </p:stCondLst>
+                                  <p:childTnLst>
+                                    <p:animMotion origin="layout" path="M 0 0 L 0.26438 0 L 0.26438 0.63333 L 0 0.63333 L 0 0 E" pathEditMode="relative" rAng="0" ptsTypes="AAAAA">
+                                      <p:cBhvr>
+                                        <p:cTn id="16" dur="5503" fill="hold"/>
+                                        <p:tgtEl>
+                                          <p:spTgt spid="34"/>
+                                        </p:tgtEl>
+                                        <p:attrNameLst>
+                                          <p:attrName>ppt_x</p:attrName>
+                                          <p:attrName>ppt_y</p:attrName>
+                                        </p:attrNameLst>
+                                      </p:cBhvr>
+                                      <p:rCtr x="0" y="0"/>
+                                    </p:animMotion>
+                                  </p:childTnLst>
+                                </p:cTn>
+                              </p:par>
+                              <p:par>
+                                <p:cTn id="17" presetID="0" presetClass="path" presetSubtype="0" repeatCount="indefinite" accel="0" decel="0" fill="hold" nodeType="withEffect">
+                                  <p:stCondLst>
+                                    <p:cond delay="330"/>
+                                  </p:stCondLst>
+                                  <p:childTnLst>
+                                    <p:animMotion origin="layout" path="M 0 0 L 0.26438 0 L 0.26438 0.63333 L 0 0.63333 L 0 0 E" pathEditMode="relative" rAng="0" ptsTypes="AAAAA">
+                                      <p:cBhvr>
+                                        <p:cTn id="18" dur="5503" fill="hold"/>
+                                        <p:tgtEl>
+                                          <p:spTgt spid="35"/>
+                                        </p:tgtEl>
+                                        <p:attrNameLst>
+                                          <p:attrName>ppt_x</p:attrName>
+                                          <p:attrName>ppt_y</p:attrName>
+                                        </p:attrNameLst>
+                                      </p:cBhvr>
+                                      <p:rCtr x="0" y="0"/>
+                                    </p:animMotion>
+                                  </p:childTnLst>
+                                </p:cTn>
+                              </p:par>
+                              <p:par>
+                                <p:cTn id="19" presetID="0" presetClass="path" presetSubtype="0" repeatCount="indefinite" accel="0" decel="0" fill="hold" nodeType="withEffect">
+                                  <p:stCondLst>
+                                    <p:cond delay="385"/>
+                                  </p:stCondLst>
+                                  <p:childTnLst>
+                                    <p:animMotion origin="layout" path="M 0 0 L 0.26438 0 L 0.26438 0.63333 L 0 0.63333 L 0 0 E" pathEditMode="relative" rAng="0" ptsTypes="AAAAA">
+                                      <p:cBhvr>
+                                        <p:cTn id="20" dur="5503" fill="hold"/>
+                                        <p:tgtEl>
+                                          <p:spTgt spid="36"/>
+                                        </p:tgtEl>
+                                        <p:attrNameLst>
+                                          <p:attrName>ppt_x</p:attrName>
+                                          <p:attrName>ppt_y</p:attrName>
+                                        </p:attrNameLst>
+                                      </p:cBhvr>
+                                      <p:rCtr x="0" y="0"/>
+                                    </p:animMotion>
+                                  </p:childTnLst>
+                                </p:cTn>
+                              </p:par>
+                              <p:par>
+                                <p:cTn id="21" presetID="0" presetClass="path" presetSubtype="0" repeatCount="indefinite" accel="0" decel="0" fill="hold" nodeType="withEffect">
+                                  <p:stCondLst>
+                                    <p:cond delay="0"/>
+                                  </p:stCondLst>
+                                  <p:childTnLst>
+                                    <p:animMotion origin="layout" path="M 0 0 L -0.26438 0 L -0.26438 -0.63333 L 0 -0.63333 L 0 0 E" pathEditMode="relative" rAng="0" ptsTypes="AAAAA">
+                                      <p:cBhvr>
+                                        <p:cTn id="22" dur="5503" fill="hold"/>
+                                        <p:tgtEl>
+                                          <p:spTgt spid="37"/>
+                                        </p:tgtEl>
+                                        <p:attrNameLst>
+                                          <p:attrName>ppt_x</p:attrName>
+                                          <p:attrName>ppt_y</p:attrName>
+                                        </p:attrNameLst>
+                                      </p:cBhvr>
+                                      <p:rCtr x="0" y="0"/>
+                                    </p:animMotion>
+                                  </p:childTnLst>
+                                </p:cTn>
+                              </p:par>
+                              <p:par>
+                                <p:cTn id="23" presetID="0" presetClass="path" presetSubtype="0" repeatCount="indefinite" accel="0" decel="0" fill="hold" nodeType="withEffect">
+                                  <p:stCondLst>
+                                    <p:cond delay="55"/>
+                                  </p:stCondLst>
+                                  <p:childTnLst>
+                                    <p:animMotion origin="layout" path="M 0 0 L -0.26438 0 L -0.26438 -0.63333 L 0 -0.63333 L 0 0 E" pathEditMode="relative" rAng="0" ptsTypes="AAAAA">
+                                      <p:cBhvr>
+                                        <p:cTn id="24" dur="5503" fill="hold"/>
+                                        <p:tgtEl>
+                                          <p:spTgt spid="38"/>
+                                        </p:tgtEl>
+                                        <p:attrNameLst>
+                                          <p:attrName>ppt_x</p:attrName>
+                                          <p:attrName>ppt_y</p:attrName>
+                                        </p:attrNameLst>
+                                      </p:cBhvr>
+                                      <p:rCtr x="0" y="0"/>
+                                    </p:animMotion>
+                                  </p:childTnLst>
+                                </p:cTn>
+                              </p:par>
+                              <p:par>
+                                <p:cTn id="25" presetID="0" presetClass="path" presetSubtype="0" repeatCount="indefinite" accel="0" decel="0" fill="hold" nodeType="withEffect">
+                                  <p:stCondLst>
+                                    <p:cond delay="110"/>
+                                  </p:stCondLst>
+                                  <p:childTnLst>
+                                    <p:animMotion origin="layout" path="M 0 0 L -0.26438 0 L -0.26438 -0.63333 L 0 -0.63333 L 0 0 E" pathEditMode="relative" rAng="0" ptsTypes="AAAAA">
+                                      <p:cBhvr>
+                                        <p:cTn id="26" dur="5503" fill="hold"/>
+                                        <p:tgtEl>
+                                          <p:spTgt spid="39"/>
+                                        </p:tgtEl>
+                                        <p:attrNameLst>
+                                          <p:attrName>ppt_x</p:attrName>
+                                          <p:attrName>ppt_y</p:attrName>
+                                        </p:attrNameLst>
+                                      </p:cBhvr>
+                                      <p:rCtr x="0" y="0"/>
+                                    </p:animMotion>
+                                  </p:childTnLst>
+                                </p:cTn>
+                              </p:par>
+                              <p:par>
+                                <p:cTn id="27" presetID="0" presetClass="path" presetSubtype="0" repeatCount="indefinite" accel="0" decel="0" fill="hold" nodeType="withEffect">
+                                  <p:stCondLst>
+                                    <p:cond delay="165"/>
+                                  </p:stCondLst>
+                                  <p:childTnLst>
+                                    <p:animMotion origin="layout" path="M 0 0 L -0.26438 0 L -0.26438 -0.63333 L 0 -0.63333 L 0 0 E" pathEditMode="relative" rAng="0" ptsTypes="AAAAA">
+                                      <p:cBhvr>
+                                        <p:cTn id="28" dur="5503" fill="hold"/>
+                                        <p:tgtEl>
+                                          <p:spTgt spid="40"/>
+                                        </p:tgtEl>
+                                        <p:attrNameLst>
+                                          <p:attrName>ppt_x</p:attrName>
+                                          <p:attrName>ppt_y</p:attrName>
+                                        </p:attrNameLst>
+                                      </p:cBhvr>
+                                      <p:rCtr x="0" y="0"/>
+                                    </p:animMotion>
+                                  </p:childTnLst>
+                                </p:cTn>
+                              </p:par>
+                              <p:par>
+                                <p:cTn id="29" presetID="0" presetClass="path" presetSubtype="0" repeatCount="indefinite" accel="0" decel="0" fill="hold" nodeType="withEffect">
+                                  <p:stCondLst>
+                                    <p:cond delay="220"/>
+                                  </p:stCondLst>
+                                  <p:childTnLst>
+                                    <p:animMotion origin="layout" path="M 0 0 L -0.26438 0 L -0.26438 -0.63333 L 0 -0.63333 L 0 0 E" pathEditMode="relative" rAng="0" ptsTypes="AAAAA">
+                                      <p:cBhvr>
+                                        <p:cTn id="30" dur="5503" fill="hold"/>
+                                        <p:tgtEl>
+                                          <p:spTgt spid="41"/>
+                                        </p:tgtEl>
+                                        <p:attrNameLst>
+                                          <p:attrName>ppt_x</p:attrName>
+                                          <p:attrName>ppt_y</p:attrName>
+                                        </p:attrNameLst>
+                                      </p:cBhvr>
+                                      <p:rCtr x="0" y="0"/>
+                                    </p:animMotion>
+                                  </p:childTnLst>
+                                </p:cTn>
+                              </p:par>
+                              <p:par>
+                                <p:cTn id="31" presetID="0" presetClass="path" presetSubtype="0" repeatCount="indefinite" accel="0" decel="0" fill="hold" nodeType="withEffect">
+                                  <p:stCondLst>
+                                    <p:cond delay="275"/>
+                                  </p:stCondLst>
+                                  <p:childTnLst>
+                                    <p:animMotion origin="layout" path="M 0 0 L -0.26438 0 L -0.26438 -0.63333 L 0 -0.63333 L 0 0 E" pathEditMode="relative" rAng="0" ptsTypes="AAAAA">
+                                      <p:cBhvr>
+                                        <p:cTn id="32" dur="5503" fill="hold"/>
+                                        <p:tgtEl>
+                                          <p:spTgt spid="42"/>
+                                        </p:tgtEl>
+                                        <p:attrNameLst>
+                                          <p:attrName>ppt_x</p:attrName>
+                                          <p:attrName>ppt_y</p:attrName>
+                                        </p:attrNameLst>
+                                      </p:cBhvr>
+                                      <p:rCtr x="0" y="0"/>
+                                    </p:animMotion>
+                                  </p:childTnLst>
+                                </p:cTn>
+                              </p:par>
+                              <p:par>
+                                <p:cTn id="33" presetID="0" presetClass="path" presetSubtype="0" repeatCount="indefinite" accel="0" decel="0" fill="hold" nodeType="withEffect">
+                                  <p:stCondLst>
+                                    <p:cond delay="330"/>
+                                  </p:stCondLst>
+                                  <p:childTnLst>
+                                    <p:animMotion origin="layout" path="M 0 0 L -0.26438 0 L -0.26438 -0.63333 L 0 -0.63333 L 0 0 E" pathEditMode="relative" rAng="0" ptsTypes="AAAAA">
+                                      <p:cBhvr>
+                                        <p:cTn id="34" dur="5503" fill="hold"/>
+                                        <p:tgtEl>
+                                          <p:spTgt spid="43"/>
+                                        </p:tgtEl>
+                                        <p:attrNameLst>
+                                          <p:attrName>ppt_x</p:attrName>
+                                          <p:attrName>ppt_y</p:attrName>
+                                        </p:attrNameLst>
+                                      </p:cBhvr>
+                                      <p:rCtr x="0" y="0"/>
+                                    </p:animMotion>
+                                  </p:childTnLst>
+                                </p:cTn>
+                              </p:par>
+                              <p:par>
+                                <p:cTn id="35" presetID="0" presetClass="path" presetSubtype="0" repeatCount="indefinite" accel="0" decel="0" fill="hold" nodeType="withEffect">
+                                  <p:stCondLst>
+                                    <p:cond delay="385"/>
+                                  </p:stCondLst>
+                                  <p:childTnLst>
+                                    <p:animMotion origin="layout" path="M 0 0 L -0.26438 0 L -0.26438 -0.63333 L 0 -0.63333 L 0 0 E" pathEditMode="relative" rAng="0" ptsTypes="AAAAA">
+                                      <p:cBhvr>
+                                        <p:cTn id="36" dur="5503" fill="hold"/>
+                                        <p:tgtEl>
+                                          <p:spTgt spid="44"/>
+                                        </p:tgtEl>
+                                        <p:attrNameLst>
+                                          <p:attrName>ppt_x</p:attrName>
+                                          <p:attrName>ppt_y</p:attrName>
+                                        </p:attrNameLst>
+                                      </p:cBhvr>
+                                      <p:rCtr x="0" y="0"/>
+                                    </p:animMotion>
+                                  </p:childTnLst>
+                                </p:cTn>
+                              </p:par>
+                            </p:childTnLst>
+                          </p:cTn>
+                        </p:par>
+                      </p:childTnLst>
+                    </p:cTn>
+                  </p:par>
+                </p:childTnLst>
+              </p:cTn>
+              <p:prevCondLst>
+                <p:cond evt="onPrev" delay="0">
+                  <p:tgtEl>
+                    <p:sldTgt/>
+                  </p:tgtEl>
+                </p:cond>
+              </p:prevCondLst>
+              <p:nextCondLst>
+                <p:cond evt="onNext" delay="0">
+                  <p:tgtEl>
+                    <p:sldTgt/>
+                  </p:tgtEl>
+                </p:cond>
+              </p:nextCondLst>
+            </p:seq>
+          </p:childTnLst>
+        </p:cTn>
+      </p:par>
+    </p:tnLst>
+  </p:timing>
 </p:sld>
 </file>
 

</xml_diff>

<commit_message>
Remove running light animation from comic frames
Co-Authored-By: Claude Opus 5.5 <noreply@anthropic.com>
Claude-Session: https://claude.ai/code/session_01QqHU1Mec7wAVsmzx9ZzXpr
</commit_message>
<xml_diff>
--- a/FP-2_v23_modern.pptx
+++ b/FP-2_v23_modern.pptx
@@ -2898,502 +2898,6 @@
       </p:sp>
       <p:sp>
         <p:nvSpPr>
-          <p:cNvPr id="71" name="Світло рамки 2.8"/>
-          <p:cNvSpPr/>
-          <p:nvPr/>
-        </p:nvSpPr>
-        <p:spPr>
-          <a:xfrm>
-            <a:off x="3753612" y="6108192"/>
-            <a:ext cx="36576" cy="36576"/>
-          </a:xfrm>
-          <a:prstGeom prst="ellipse">
-            <a:avLst/>
-          </a:prstGeom>
-          <a:solidFill>
-            <a:srgbClr val="58F268">
-              <a:alpha val="20000"/>
-            </a:srgbClr>
-          </a:solidFill>
-          <a:ln>
-            <a:noFill/>
-          </a:ln>
-          <a:effectLst>
-            <a:glow rad="63500">
-              <a:srgbClr val="58F268">
-                <a:alpha val="12000"/>
-              </a:srgbClr>
-            </a:glow>
-          </a:effectLst>
-        </p:spPr>
-      </p:sp>
-      <p:sp>
-        <p:nvSpPr>
-          <p:cNvPr id="70" name="Світло рамки 2.7"/>
-          <p:cNvSpPr/>
-          <p:nvPr/>
-        </p:nvSpPr>
-        <p:spPr>
-          <a:xfrm>
-            <a:off x="3747734" y="6102314"/>
-            <a:ext cx="48332" cy="48332"/>
-          </a:xfrm>
-          <a:prstGeom prst="ellipse">
-            <a:avLst/>
-          </a:prstGeom>
-          <a:solidFill>
-            <a:srgbClr val="58F268">
-              <a:alpha val="31428"/>
-            </a:srgbClr>
-          </a:solidFill>
-          <a:ln>
-            <a:noFill/>
-          </a:ln>
-          <a:effectLst>
-            <a:glow rad="63500">
-              <a:srgbClr val="58F268">
-                <a:alpha val="18856"/>
-              </a:srgbClr>
-            </a:glow>
-          </a:effectLst>
-        </p:spPr>
-      </p:sp>
-      <p:sp>
-        <p:nvSpPr>
-          <p:cNvPr id="69" name="Світло рамки 2.6"/>
-          <p:cNvSpPr/>
-          <p:nvPr/>
-        </p:nvSpPr>
-        <p:spPr>
-          <a:xfrm>
-            <a:off x="3741856" y="6096436"/>
-            <a:ext cx="60089" cy="60089"/>
-          </a:xfrm>
-          <a:prstGeom prst="ellipse">
-            <a:avLst/>
-          </a:prstGeom>
-          <a:solidFill>
-            <a:srgbClr val="58F268">
-              <a:alpha val="42857"/>
-            </a:srgbClr>
-          </a:solidFill>
-          <a:ln>
-            <a:noFill/>
-          </a:ln>
-          <a:effectLst>
-            <a:glow rad="63500">
-              <a:srgbClr val="58F268">
-                <a:alpha val="25714"/>
-              </a:srgbClr>
-            </a:glow>
-          </a:effectLst>
-        </p:spPr>
-      </p:sp>
-      <p:sp>
-        <p:nvSpPr>
-          <p:cNvPr id="68" name="Світло рамки 2.5"/>
-          <p:cNvSpPr/>
-          <p:nvPr/>
-        </p:nvSpPr>
-        <p:spPr>
-          <a:xfrm>
-            <a:off x="3735978" y="6090558"/>
-            <a:ext cx="71845" cy="71845"/>
-          </a:xfrm>
-          <a:prstGeom prst="ellipse">
-            <a:avLst/>
-          </a:prstGeom>
-          <a:solidFill>
-            <a:srgbClr val="58F268">
-              <a:alpha val="54285"/>
-            </a:srgbClr>
-          </a:solidFill>
-          <a:ln>
-            <a:noFill/>
-          </a:ln>
-          <a:effectLst>
-            <a:glow rad="63500">
-              <a:srgbClr val="58F268">
-                <a:alpha val="32571"/>
-              </a:srgbClr>
-            </a:glow>
-          </a:effectLst>
-        </p:spPr>
-      </p:sp>
-      <p:sp>
-        <p:nvSpPr>
-          <p:cNvPr id="67" name="Світло рамки 2.4"/>
-          <p:cNvSpPr/>
-          <p:nvPr/>
-        </p:nvSpPr>
-        <p:spPr>
-          <a:xfrm>
-            <a:off x="3730099" y="6084679"/>
-            <a:ext cx="83602" cy="83602"/>
-          </a:xfrm>
-          <a:prstGeom prst="ellipse">
-            <a:avLst/>
-          </a:prstGeom>
-          <a:solidFill>
-            <a:srgbClr val="58F268">
-              <a:alpha val="65714"/>
-            </a:srgbClr>
-          </a:solidFill>
-          <a:ln>
-            <a:noFill/>
-          </a:ln>
-          <a:effectLst>
-            <a:glow rad="63500">
-              <a:srgbClr val="58F268">
-                <a:alpha val="39428"/>
-              </a:srgbClr>
-            </a:glow>
-          </a:effectLst>
-        </p:spPr>
-      </p:sp>
-      <p:sp>
-        <p:nvSpPr>
-          <p:cNvPr id="66" name="Світло рамки 2.3"/>
-          <p:cNvSpPr/>
-          <p:nvPr/>
-        </p:nvSpPr>
-        <p:spPr>
-          <a:xfrm>
-            <a:off x="3724221" y="6078801"/>
-            <a:ext cx="95358" cy="95358"/>
-          </a:xfrm>
-          <a:prstGeom prst="ellipse">
-            <a:avLst/>
-          </a:prstGeom>
-          <a:solidFill>
-            <a:srgbClr val="58F268">
-              <a:alpha val="77142"/>
-            </a:srgbClr>
-          </a:solidFill>
-          <a:ln>
-            <a:noFill/>
-          </a:ln>
-          <a:effectLst>
-            <a:glow rad="63500">
-              <a:srgbClr val="58F268">
-                <a:alpha val="46285"/>
-              </a:srgbClr>
-            </a:glow>
-          </a:effectLst>
-        </p:spPr>
-      </p:sp>
-      <p:sp>
-        <p:nvSpPr>
-          <p:cNvPr id="65" name="Світло рамки 2.2"/>
-          <p:cNvSpPr/>
-          <p:nvPr/>
-        </p:nvSpPr>
-        <p:spPr>
-          <a:xfrm>
-            <a:off x="3718343" y="6072923"/>
-            <a:ext cx="107115" cy="107115"/>
-          </a:xfrm>
-          <a:prstGeom prst="ellipse">
-            <a:avLst/>
-          </a:prstGeom>
-          <a:solidFill>
-            <a:srgbClr val="58F268">
-              <a:alpha val="88571"/>
-            </a:srgbClr>
-          </a:solidFill>
-          <a:ln>
-            <a:noFill/>
-          </a:ln>
-          <a:effectLst>
-            <a:glow rad="63500">
-              <a:srgbClr val="58F268">
-                <a:alpha val="53142"/>
-              </a:srgbClr>
-            </a:glow>
-          </a:effectLst>
-        </p:spPr>
-      </p:sp>
-      <p:sp>
-        <p:nvSpPr>
-          <p:cNvPr id="64" name="Світло рамки 2.1"/>
-          <p:cNvSpPr/>
-          <p:nvPr/>
-        </p:nvSpPr>
-        <p:spPr>
-          <a:xfrm>
-            <a:off x="3712464" y="6067044"/>
-            <a:ext cx="118872" cy="118872"/>
-          </a:xfrm>
-          <a:prstGeom prst="ellipse">
-            <a:avLst/>
-          </a:prstGeom>
-          <a:solidFill>
-            <a:srgbClr val="F2FFF3">
-              <a:alpha val="100000"/>
-            </a:srgbClr>
-          </a:solidFill>
-          <a:ln>
-            <a:noFill/>
-          </a:ln>
-          <a:effectLst>
-            <a:glow rad="101600">
-              <a:srgbClr val="58F268">
-                <a:alpha val="60000"/>
-              </a:srgbClr>
-            </a:glow>
-          </a:effectLst>
-        </p:spPr>
-      </p:sp>
-      <p:sp>
-        <p:nvSpPr>
-          <p:cNvPr id="63" name="Світло рамки 1.8"/>
-          <p:cNvSpPr/>
-          <p:nvPr/>
-        </p:nvSpPr>
-        <p:spPr>
-          <a:xfrm>
-            <a:off x="530352" y="1764792"/>
-            <a:ext cx="36576" cy="36576"/>
-          </a:xfrm>
-          <a:prstGeom prst="ellipse">
-            <a:avLst/>
-          </a:prstGeom>
-          <a:solidFill>
-            <a:srgbClr val="58F268">
-              <a:alpha val="20000"/>
-            </a:srgbClr>
-          </a:solidFill>
-          <a:ln>
-            <a:noFill/>
-          </a:ln>
-          <a:effectLst>
-            <a:glow rad="63500">
-              <a:srgbClr val="58F268">
-                <a:alpha val="12000"/>
-              </a:srgbClr>
-            </a:glow>
-          </a:effectLst>
-        </p:spPr>
-      </p:sp>
-      <p:sp>
-        <p:nvSpPr>
-          <p:cNvPr id="62" name="Світло рамки 1.7"/>
-          <p:cNvSpPr/>
-          <p:nvPr/>
-        </p:nvSpPr>
-        <p:spPr>
-          <a:xfrm>
-            <a:off x="524474" y="1758914"/>
-            <a:ext cx="48332" cy="48332"/>
-          </a:xfrm>
-          <a:prstGeom prst="ellipse">
-            <a:avLst/>
-          </a:prstGeom>
-          <a:solidFill>
-            <a:srgbClr val="58F268">
-              <a:alpha val="31428"/>
-            </a:srgbClr>
-          </a:solidFill>
-          <a:ln>
-            <a:noFill/>
-          </a:ln>
-          <a:effectLst>
-            <a:glow rad="63500">
-              <a:srgbClr val="58F268">
-                <a:alpha val="18856"/>
-              </a:srgbClr>
-            </a:glow>
-          </a:effectLst>
-        </p:spPr>
-      </p:sp>
-      <p:sp>
-        <p:nvSpPr>
-          <p:cNvPr id="61" name="Світло рамки 1.6"/>
-          <p:cNvSpPr/>
-          <p:nvPr/>
-        </p:nvSpPr>
-        <p:spPr>
-          <a:xfrm>
-            <a:off x="518596" y="1753036"/>
-            <a:ext cx="60089" cy="60089"/>
-          </a:xfrm>
-          <a:prstGeom prst="ellipse">
-            <a:avLst/>
-          </a:prstGeom>
-          <a:solidFill>
-            <a:srgbClr val="58F268">
-              <a:alpha val="42857"/>
-            </a:srgbClr>
-          </a:solidFill>
-          <a:ln>
-            <a:noFill/>
-          </a:ln>
-          <a:effectLst>
-            <a:glow rad="63500">
-              <a:srgbClr val="58F268">
-                <a:alpha val="25714"/>
-              </a:srgbClr>
-            </a:glow>
-          </a:effectLst>
-        </p:spPr>
-      </p:sp>
-      <p:sp>
-        <p:nvSpPr>
-          <p:cNvPr id="60" name="Світло рамки 1.5"/>
-          <p:cNvSpPr/>
-          <p:nvPr/>
-        </p:nvSpPr>
-        <p:spPr>
-          <a:xfrm>
-            <a:off x="512718" y="1747158"/>
-            <a:ext cx="71845" cy="71845"/>
-          </a:xfrm>
-          <a:prstGeom prst="ellipse">
-            <a:avLst/>
-          </a:prstGeom>
-          <a:solidFill>
-            <a:srgbClr val="58F268">
-              <a:alpha val="54285"/>
-            </a:srgbClr>
-          </a:solidFill>
-          <a:ln>
-            <a:noFill/>
-          </a:ln>
-          <a:effectLst>
-            <a:glow rad="63500">
-              <a:srgbClr val="58F268">
-                <a:alpha val="32571"/>
-              </a:srgbClr>
-            </a:glow>
-          </a:effectLst>
-        </p:spPr>
-      </p:sp>
-      <p:sp>
-        <p:nvSpPr>
-          <p:cNvPr id="59" name="Світло рамки 1.4"/>
-          <p:cNvSpPr/>
-          <p:nvPr/>
-        </p:nvSpPr>
-        <p:spPr>
-          <a:xfrm>
-            <a:off x="506839" y="1741279"/>
-            <a:ext cx="83602" cy="83602"/>
-          </a:xfrm>
-          <a:prstGeom prst="ellipse">
-            <a:avLst/>
-          </a:prstGeom>
-          <a:solidFill>
-            <a:srgbClr val="58F268">
-              <a:alpha val="65714"/>
-            </a:srgbClr>
-          </a:solidFill>
-          <a:ln>
-            <a:noFill/>
-          </a:ln>
-          <a:effectLst>
-            <a:glow rad="63500">
-              <a:srgbClr val="58F268">
-                <a:alpha val="39428"/>
-              </a:srgbClr>
-            </a:glow>
-          </a:effectLst>
-        </p:spPr>
-      </p:sp>
-      <p:sp>
-        <p:nvSpPr>
-          <p:cNvPr id="58" name="Світло рамки 1.3"/>
-          <p:cNvSpPr/>
-          <p:nvPr/>
-        </p:nvSpPr>
-        <p:spPr>
-          <a:xfrm>
-            <a:off x="500961" y="1735401"/>
-            <a:ext cx="95358" cy="95358"/>
-          </a:xfrm>
-          <a:prstGeom prst="ellipse">
-            <a:avLst/>
-          </a:prstGeom>
-          <a:solidFill>
-            <a:srgbClr val="58F268">
-              <a:alpha val="77142"/>
-            </a:srgbClr>
-          </a:solidFill>
-          <a:ln>
-            <a:noFill/>
-          </a:ln>
-          <a:effectLst>
-            <a:glow rad="63500">
-              <a:srgbClr val="58F268">
-                <a:alpha val="46285"/>
-              </a:srgbClr>
-            </a:glow>
-          </a:effectLst>
-        </p:spPr>
-      </p:sp>
-      <p:sp>
-        <p:nvSpPr>
-          <p:cNvPr id="57" name="Світло рамки 1.2"/>
-          <p:cNvSpPr/>
-          <p:nvPr/>
-        </p:nvSpPr>
-        <p:spPr>
-          <a:xfrm>
-            <a:off x="495083" y="1729523"/>
-            <a:ext cx="107115" cy="107115"/>
-          </a:xfrm>
-          <a:prstGeom prst="ellipse">
-            <a:avLst/>
-          </a:prstGeom>
-          <a:solidFill>
-            <a:srgbClr val="58F268">
-              <a:alpha val="88571"/>
-            </a:srgbClr>
-          </a:solidFill>
-          <a:ln>
-            <a:noFill/>
-          </a:ln>
-          <a:effectLst>
-            <a:glow rad="63500">
-              <a:srgbClr val="58F268">
-                <a:alpha val="53142"/>
-              </a:srgbClr>
-            </a:glow>
-          </a:effectLst>
-        </p:spPr>
-      </p:sp>
-      <p:sp>
-        <p:nvSpPr>
-          <p:cNvPr id="56" name="Світло рамки 1.1"/>
-          <p:cNvSpPr/>
-          <p:nvPr/>
-        </p:nvSpPr>
-        <p:spPr>
-          <a:xfrm>
-            <a:off x="489204" y="1723644"/>
-            <a:ext cx="118872" cy="118872"/>
-          </a:xfrm>
-          <a:prstGeom prst="ellipse">
-            <a:avLst/>
-          </a:prstGeom>
-          <a:solidFill>
-            <a:srgbClr val="F2FFF3">
-              <a:alpha val="100000"/>
-            </a:srgbClr>
-          </a:solidFill>
-          <a:ln>
-            <a:noFill/>
-          </a:ln>
-          <a:effectLst>
-            <a:glow rad="101600">
-              <a:srgbClr val="58F268">
-                <a:alpha val="60000"/>
-              </a:srgbClr>
-            </a:glow>
-          </a:effectLst>
-        </p:spPr>
-      </p:sp>
-      <p:sp>
-        <p:nvSpPr>
           <p:cNvPr id="6" name="Кути коміксу 01 кут 1"/>
           <p:cNvSpPr/>
           <p:nvPr/>
@@ -5054,409 +4558,6 @@
   <p:clrMapOvr>
     <a:masterClrMapping/>
   </p:clrMapOvr>
-  <p:timing>
-    <p:tnLst>
-      <p:par>
-        <p:cTn id="1" dur="indefinite" restart="never" nodeType="tmRoot">
-          <p:childTnLst>
-            <p:seq concurrent="1" nextAc="seek">
-              <p:cTn id="2" dur="indefinite" nodeType="mainSeq">
-                <p:childTnLst>
-                  <p:par>
-                    <p:cTn id="3" fill="hold">
-                      <p:stCondLst>
-                        <p:cond delay="indefinite"/>
-                        <p:cond evt="onBegin" delay="0">
-                          <p:tn val="2"/>
-                        </p:cond>
-                      </p:stCondLst>
-                      <p:childTnLst>
-                        <p:par>
-                          <p:cTn id="4" fill="hold">
-                            <p:stCondLst>
-                              <p:cond delay="0"/>
-                            </p:stCondLst>
-                            <p:childTnLst>
-                              <p:par>
-                                <p:cTn id="5" presetID="0" presetClass="path" presetSubtype="0" repeatCount="indefinite" accel="0" decel="0" fill="hold" nodeType="withEffect">
-                                  <p:stCondLst>
-                                    <p:cond delay="0"/>
-                                  </p:stCondLst>
-                                  <p:childTnLst>
-                                    <p:animMotion origin="layout" path="M 0 0 L 0.26438 0 L 0.26438 0.63333 L 0 0.63333 L 0 0 E" pathEditMode="relative" rAng="0" ptsTypes="AAAAA">
-                                      <p:cBhvr>
-                                        <p:cTn id="6" dur="5503" fill="hold"/>
-                                        <p:tgtEl>
-                                          <p:spTgt spid="56"/>
-                                        </p:tgtEl>
-                                        <p:attrNameLst>
-                                          <p:attrName>ppt_x</p:attrName>
-                                          <p:attrName>ppt_y</p:attrName>
-                                        </p:attrNameLst>
-                                      </p:cBhvr>
-                                      <p:rCtr x="0" y="0"/>
-                                    </p:animMotion>
-                                  </p:childTnLst>
-                                </p:cTn>
-                              </p:par>
-                              <p:par>
-                                <p:cTn id="7" presetID="0" presetClass="path" presetSubtype="0" repeatCount="indefinite" accel="0" decel="0" fill="hold" nodeType="withEffect">
-                                  <p:stCondLst>
-                                    <p:cond delay="55"/>
-                                  </p:stCondLst>
-                                  <p:childTnLst>
-                                    <p:animMotion origin="layout" path="M 0 0 L 0.26438 0 L 0.26438 0.63333 L 0 0.63333 L 0 0 E" pathEditMode="relative" rAng="0" ptsTypes="AAAAA">
-                                      <p:cBhvr>
-                                        <p:cTn id="8" dur="5503" fill="hold"/>
-                                        <p:tgtEl>
-                                          <p:spTgt spid="57"/>
-                                        </p:tgtEl>
-                                        <p:attrNameLst>
-                                          <p:attrName>ppt_x</p:attrName>
-                                          <p:attrName>ppt_y</p:attrName>
-                                        </p:attrNameLst>
-                                      </p:cBhvr>
-                                      <p:rCtr x="0" y="0"/>
-                                    </p:animMotion>
-                                  </p:childTnLst>
-                                </p:cTn>
-                              </p:par>
-                              <p:par>
-                                <p:cTn id="9" presetID="0" presetClass="path" presetSubtype="0" repeatCount="indefinite" accel="0" decel="0" fill="hold" nodeType="withEffect">
-                                  <p:stCondLst>
-                                    <p:cond delay="110"/>
-                                  </p:stCondLst>
-                                  <p:childTnLst>
-                                    <p:animMotion origin="layout" path="M 0 0 L 0.26438 0 L 0.26438 0.63333 L 0 0.63333 L 0 0 E" pathEditMode="relative" rAng="0" ptsTypes="AAAAA">
-                                      <p:cBhvr>
-                                        <p:cTn id="10" dur="5503" fill="hold"/>
-                                        <p:tgtEl>
-                                          <p:spTgt spid="58"/>
-                                        </p:tgtEl>
-                                        <p:attrNameLst>
-                                          <p:attrName>ppt_x</p:attrName>
-                                          <p:attrName>ppt_y</p:attrName>
-                                        </p:attrNameLst>
-                                      </p:cBhvr>
-                                      <p:rCtr x="0" y="0"/>
-                                    </p:animMotion>
-                                  </p:childTnLst>
-                                </p:cTn>
-                              </p:par>
-                              <p:par>
-                                <p:cTn id="11" presetID="0" presetClass="path" presetSubtype="0" repeatCount="indefinite" accel="0" decel="0" fill="hold" nodeType="withEffect">
-                                  <p:stCondLst>
-                                    <p:cond delay="165"/>
-                                  </p:stCondLst>
-                                  <p:childTnLst>
-                                    <p:animMotion origin="layout" path="M 0 0 L 0.26438 0 L 0.26438 0.63333 L 0 0.63333 L 0 0 E" pathEditMode="relative" rAng="0" ptsTypes="AAAAA">
-                                      <p:cBhvr>
-                                        <p:cTn id="12" dur="5503" fill="hold"/>
-                                        <p:tgtEl>
-                                          <p:spTgt spid="59"/>
-                                        </p:tgtEl>
-                                        <p:attrNameLst>
-                                          <p:attrName>ppt_x</p:attrName>
-                                          <p:attrName>ppt_y</p:attrName>
-                                        </p:attrNameLst>
-                                      </p:cBhvr>
-                                      <p:rCtr x="0" y="0"/>
-                                    </p:animMotion>
-                                  </p:childTnLst>
-                                </p:cTn>
-                              </p:par>
-                              <p:par>
-                                <p:cTn id="13" presetID="0" presetClass="path" presetSubtype="0" repeatCount="indefinite" accel="0" decel="0" fill="hold" nodeType="withEffect">
-                                  <p:stCondLst>
-                                    <p:cond delay="220"/>
-                                  </p:stCondLst>
-                                  <p:childTnLst>
-                                    <p:animMotion origin="layout" path="M 0 0 L 0.26438 0 L 0.26438 0.63333 L 0 0.63333 L 0 0 E" pathEditMode="relative" rAng="0" ptsTypes="AAAAA">
-                                      <p:cBhvr>
-                                        <p:cTn id="14" dur="5503" fill="hold"/>
-                                        <p:tgtEl>
-                                          <p:spTgt spid="60"/>
-                                        </p:tgtEl>
-                                        <p:attrNameLst>
-                                          <p:attrName>ppt_x</p:attrName>
-                                          <p:attrName>ppt_y</p:attrName>
-                                        </p:attrNameLst>
-                                      </p:cBhvr>
-                                      <p:rCtr x="0" y="0"/>
-                                    </p:animMotion>
-                                  </p:childTnLst>
-                                </p:cTn>
-                              </p:par>
-                              <p:par>
-                                <p:cTn id="15" presetID="0" presetClass="path" presetSubtype="0" repeatCount="indefinite" accel="0" decel="0" fill="hold" nodeType="withEffect">
-                                  <p:stCondLst>
-                                    <p:cond delay="275"/>
-                                  </p:stCondLst>
-                                  <p:childTnLst>
-                                    <p:animMotion origin="layout" path="M 0 0 L 0.26438 0 L 0.26438 0.63333 L 0 0.63333 L 0 0 E" pathEditMode="relative" rAng="0" ptsTypes="AAAAA">
-                                      <p:cBhvr>
-                                        <p:cTn id="16" dur="5503" fill="hold"/>
-                                        <p:tgtEl>
-                                          <p:spTgt spid="61"/>
-                                        </p:tgtEl>
-                                        <p:attrNameLst>
-                                          <p:attrName>ppt_x</p:attrName>
-                                          <p:attrName>ppt_y</p:attrName>
-                                        </p:attrNameLst>
-                                      </p:cBhvr>
-                                      <p:rCtr x="0" y="0"/>
-                                    </p:animMotion>
-                                  </p:childTnLst>
-                                </p:cTn>
-                              </p:par>
-                              <p:par>
-                                <p:cTn id="17" presetID="0" presetClass="path" presetSubtype="0" repeatCount="indefinite" accel="0" decel="0" fill="hold" nodeType="withEffect">
-                                  <p:stCondLst>
-                                    <p:cond delay="330"/>
-                                  </p:stCondLst>
-                                  <p:childTnLst>
-                                    <p:animMotion origin="layout" path="M 0 0 L 0.26438 0 L 0.26438 0.63333 L 0 0.63333 L 0 0 E" pathEditMode="relative" rAng="0" ptsTypes="AAAAA">
-                                      <p:cBhvr>
-                                        <p:cTn id="18" dur="5503" fill="hold"/>
-                                        <p:tgtEl>
-                                          <p:spTgt spid="62"/>
-                                        </p:tgtEl>
-                                        <p:attrNameLst>
-                                          <p:attrName>ppt_x</p:attrName>
-                                          <p:attrName>ppt_y</p:attrName>
-                                        </p:attrNameLst>
-                                      </p:cBhvr>
-                                      <p:rCtr x="0" y="0"/>
-                                    </p:animMotion>
-                                  </p:childTnLst>
-                                </p:cTn>
-                              </p:par>
-                              <p:par>
-                                <p:cTn id="19" presetID="0" presetClass="path" presetSubtype="0" repeatCount="indefinite" accel="0" decel="0" fill="hold" nodeType="withEffect">
-                                  <p:stCondLst>
-                                    <p:cond delay="385"/>
-                                  </p:stCondLst>
-                                  <p:childTnLst>
-                                    <p:animMotion origin="layout" path="M 0 0 L 0.26438 0 L 0.26438 0.63333 L 0 0.63333 L 0 0 E" pathEditMode="relative" rAng="0" ptsTypes="AAAAA">
-                                      <p:cBhvr>
-                                        <p:cTn id="20" dur="5503" fill="hold"/>
-                                        <p:tgtEl>
-                                          <p:spTgt spid="63"/>
-                                        </p:tgtEl>
-                                        <p:attrNameLst>
-                                          <p:attrName>ppt_x</p:attrName>
-                                          <p:attrName>ppt_y</p:attrName>
-                                        </p:attrNameLst>
-                                      </p:cBhvr>
-                                      <p:rCtr x="0" y="0"/>
-                                    </p:animMotion>
-                                  </p:childTnLst>
-                                </p:cTn>
-                              </p:par>
-                              <p:par>
-                                <p:cTn id="21" presetID="0" presetClass="path" presetSubtype="0" repeatCount="indefinite" accel="0" decel="0" fill="hold" nodeType="withEffect">
-                                  <p:stCondLst>
-                                    <p:cond delay="0"/>
-                                  </p:stCondLst>
-                                  <p:childTnLst>
-                                    <p:animMotion origin="layout" path="M 0 0 L -0.26438 0 L -0.26438 -0.63333 L 0 -0.63333 L 0 0 E" pathEditMode="relative" rAng="0" ptsTypes="AAAAA">
-                                      <p:cBhvr>
-                                        <p:cTn id="22" dur="5503" fill="hold"/>
-                                        <p:tgtEl>
-                                          <p:spTgt spid="64"/>
-                                        </p:tgtEl>
-                                        <p:attrNameLst>
-                                          <p:attrName>ppt_x</p:attrName>
-                                          <p:attrName>ppt_y</p:attrName>
-                                        </p:attrNameLst>
-                                      </p:cBhvr>
-                                      <p:rCtr x="0" y="0"/>
-                                    </p:animMotion>
-                                  </p:childTnLst>
-                                </p:cTn>
-                              </p:par>
-                              <p:par>
-                                <p:cTn id="23" presetID="0" presetClass="path" presetSubtype="0" repeatCount="indefinite" accel="0" decel="0" fill="hold" nodeType="withEffect">
-                                  <p:stCondLst>
-                                    <p:cond delay="55"/>
-                                  </p:stCondLst>
-                                  <p:childTnLst>
-                                    <p:animMotion origin="layout" path="M 0 0 L -0.26438 0 L -0.26438 -0.63333 L 0 -0.63333 L 0 0 E" pathEditMode="relative" rAng="0" ptsTypes="AAAAA">
-                                      <p:cBhvr>
-                                        <p:cTn id="24" dur="5503" fill="hold"/>
-                                        <p:tgtEl>
-                                          <p:spTgt spid="65"/>
-                                        </p:tgtEl>
-                                        <p:attrNameLst>
-                                          <p:attrName>ppt_x</p:attrName>
-                                          <p:attrName>ppt_y</p:attrName>
-                                        </p:attrNameLst>
-                                      </p:cBhvr>
-                                      <p:rCtr x="0" y="0"/>
-                                    </p:animMotion>
-                                  </p:childTnLst>
-                                </p:cTn>
-                              </p:par>
-                              <p:par>
-                                <p:cTn id="25" presetID="0" presetClass="path" presetSubtype="0" repeatCount="indefinite" accel="0" decel="0" fill="hold" nodeType="withEffect">
-                                  <p:stCondLst>
-                                    <p:cond delay="110"/>
-                                  </p:stCondLst>
-                                  <p:childTnLst>
-                                    <p:animMotion origin="layout" path="M 0 0 L -0.26438 0 L -0.26438 -0.63333 L 0 -0.63333 L 0 0 E" pathEditMode="relative" rAng="0" ptsTypes="AAAAA">
-                                      <p:cBhvr>
-                                        <p:cTn id="26" dur="5503" fill="hold"/>
-                                        <p:tgtEl>
-                                          <p:spTgt spid="66"/>
-                                        </p:tgtEl>
-                                        <p:attrNameLst>
-                                          <p:attrName>ppt_x</p:attrName>
-                                          <p:attrName>ppt_y</p:attrName>
-                                        </p:attrNameLst>
-                                      </p:cBhvr>
-                                      <p:rCtr x="0" y="0"/>
-                                    </p:animMotion>
-                                  </p:childTnLst>
-                                </p:cTn>
-                              </p:par>
-                              <p:par>
-                                <p:cTn id="27" presetID="0" presetClass="path" presetSubtype="0" repeatCount="indefinite" accel="0" decel="0" fill="hold" nodeType="withEffect">
-                                  <p:stCondLst>
-                                    <p:cond delay="165"/>
-                                  </p:stCondLst>
-                                  <p:childTnLst>
-                                    <p:animMotion origin="layout" path="M 0 0 L -0.26438 0 L -0.26438 -0.63333 L 0 -0.63333 L 0 0 E" pathEditMode="relative" rAng="0" ptsTypes="AAAAA">
-                                      <p:cBhvr>
-                                        <p:cTn id="28" dur="5503" fill="hold"/>
-                                        <p:tgtEl>
-                                          <p:spTgt spid="67"/>
-                                        </p:tgtEl>
-                                        <p:attrNameLst>
-                                          <p:attrName>ppt_x</p:attrName>
-                                          <p:attrName>ppt_y</p:attrName>
-                                        </p:attrNameLst>
-                                      </p:cBhvr>
-                                      <p:rCtr x="0" y="0"/>
-                                    </p:animMotion>
-                                  </p:childTnLst>
-                                </p:cTn>
-                              </p:par>
-                              <p:par>
-                                <p:cTn id="29" presetID="0" presetClass="path" presetSubtype="0" repeatCount="indefinite" accel="0" decel="0" fill="hold" nodeType="withEffect">
-                                  <p:stCondLst>
-                                    <p:cond delay="220"/>
-                                  </p:stCondLst>
-                                  <p:childTnLst>
-                                    <p:animMotion origin="layout" path="M 0 0 L -0.26438 0 L -0.26438 -0.63333 L 0 -0.63333 L 0 0 E" pathEditMode="relative" rAng="0" ptsTypes="AAAAA">
-                                      <p:cBhvr>
-                                        <p:cTn id="30" dur="5503" fill="hold"/>
-                                        <p:tgtEl>
-                                          <p:spTgt spid="68"/>
-                                        </p:tgtEl>
-                                        <p:attrNameLst>
-                                          <p:attrName>ppt_x</p:attrName>
-                                          <p:attrName>ppt_y</p:attrName>
-                                        </p:attrNameLst>
-                                      </p:cBhvr>
-                                      <p:rCtr x="0" y="0"/>
-                                    </p:animMotion>
-                                  </p:childTnLst>
-                                </p:cTn>
-                              </p:par>
-                              <p:par>
-                                <p:cTn id="31" presetID="0" presetClass="path" presetSubtype="0" repeatCount="indefinite" accel="0" decel="0" fill="hold" nodeType="withEffect">
-                                  <p:stCondLst>
-                                    <p:cond delay="275"/>
-                                  </p:stCondLst>
-                                  <p:childTnLst>
-                                    <p:animMotion origin="layout" path="M 0 0 L -0.26438 0 L -0.26438 -0.63333 L 0 -0.63333 L 0 0 E" pathEditMode="relative" rAng="0" ptsTypes="AAAAA">
-                                      <p:cBhvr>
-                                        <p:cTn id="32" dur="5503" fill="hold"/>
-                                        <p:tgtEl>
-                                          <p:spTgt spid="69"/>
-                                        </p:tgtEl>
-                                        <p:attrNameLst>
-                                          <p:attrName>ppt_x</p:attrName>
-                                          <p:attrName>ppt_y</p:attrName>
-                                        </p:attrNameLst>
-                                      </p:cBhvr>
-                                      <p:rCtr x="0" y="0"/>
-                                    </p:animMotion>
-                                  </p:childTnLst>
-                                </p:cTn>
-                              </p:par>
-                              <p:par>
-                                <p:cTn id="33" presetID="0" presetClass="path" presetSubtype="0" repeatCount="indefinite" accel="0" decel="0" fill="hold" nodeType="withEffect">
-                                  <p:stCondLst>
-                                    <p:cond delay="330"/>
-                                  </p:stCondLst>
-                                  <p:childTnLst>
-                                    <p:animMotion origin="layout" path="M 0 0 L -0.26438 0 L -0.26438 -0.63333 L 0 -0.63333 L 0 0 E" pathEditMode="relative" rAng="0" ptsTypes="AAAAA">
-                                      <p:cBhvr>
-                                        <p:cTn id="34" dur="5503" fill="hold"/>
-                                        <p:tgtEl>
-                                          <p:spTgt spid="70"/>
-                                        </p:tgtEl>
-                                        <p:attrNameLst>
-                                          <p:attrName>ppt_x</p:attrName>
-                                          <p:attrName>ppt_y</p:attrName>
-                                        </p:attrNameLst>
-                                      </p:cBhvr>
-                                      <p:rCtr x="0" y="0"/>
-                                    </p:animMotion>
-                                  </p:childTnLst>
-                                </p:cTn>
-                              </p:par>
-                              <p:par>
-                                <p:cTn id="35" presetID="0" presetClass="path" presetSubtype="0" repeatCount="indefinite" accel="0" decel="0" fill="hold" nodeType="withEffect">
-                                  <p:stCondLst>
-                                    <p:cond delay="385"/>
-                                  </p:stCondLst>
-                                  <p:childTnLst>
-                                    <p:animMotion origin="layout" path="M 0 0 L -0.26438 0 L -0.26438 -0.63333 L 0 -0.63333 L 0 0 E" pathEditMode="relative" rAng="0" ptsTypes="AAAAA">
-                                      <p:cBhvr>
-                                        <p:cTn id="36" dur="5503" fill="hold"/>
-                                        <p:tgtEl>
-                                          <p:spTgt spid="71"/>
-                                        </p:tgtEl>
-                                        <p:attrNameLst>
-                                          <p:attrName>ppt_x</p:attrName>
-                                          <p:attrName>ppt_y</p:attrName>
-                                        </p:attrNameLst>
-                                      </p:cBhvr>
-                                      <p:rCtr x="0" y="0"/>
-                                    </p:animMotion>
-                                  </p:childTnLst>
-                                </p:cTn>
-                              </p:par>
-                            </p:childTnLst>
-                          </p:cTn>
-                        </p:par>
-                      </p:childTnLst>
-                    </p:cTn>
-                  </p:par>
-                </p:childTnLst>
-              </p:cTn>
-              <p:prevCondLst>
-                <p:cond evt="onPrev" delay="0">
-                  <p:tgtEl>
-                    <p:sldTgt/>
-                  </p:tgtEl>
-                </p:cond>
-              </p:prevCondLst>
-              <p:nextCondLst>
-                <p:cond evt="onNext" delay="0">
-                  <p:tgtEl>
-                    <p:sldTgt/>
-                  </p:tgtEl>
-                </p:cond>
-              </p:nextCondLst>
-            </p:seq>
-          </p:childTnLst>
-        </p:cTn>
-      </p:par>
-    </p:tnLst>
-  </p:timing>
 </p:sld>
 </file>
 
@@ -5621,502 +4722,6 @@
       </p:sp>
       <p:sp>
         <p:nvSpPr>
-          <p:cNvPr id="49" name="Світло рамки 2.8"/>
-          <p:cNvSpPr/>
-          <p:nvPr/>
-        </p:nvSpPr>
-        <p:spPr>
-          <a:xfrm>
-            <a:off x="3753612" y="6108192"/>
-            <a:ext cx="36576" cy="36576"/>
-          </a:xfrm>
-          <a:prstGeom prst="ellipse">
-            <a:avLst/>
-          </a:prstGeom>
-          <a:solidFill>
-            <a:srgbClr val="58F268">
-              <a:alpha val="20000"/>
-            </a:srgbClr>
-          </a:solidFill>
-          <a:ln>
-            <a:noFill/>
-          </a:ln>
-          <a:effectLst>
-            <a:glow rad="63500">
-              <a:srgbClr val="58F268">
-                <a:alpha val="12000"/>
-              </a:srgbClr>
-            </a:glow>
-          </a:effectLst>
-        </p:spPr>
-      </p:sp>
-      <p:sp>
-        <p:nvSpPr>
-          <p:cNvPr id="48" name="Світло рамки 2.7"/>
-          <p:cNvSpPr/>
-          <p:nvPr/>
-        </p:nvSpPr>
-        <p:spPr>
-          <a:xfrm>
-            <a:off x="3747734" y="6102314"/>
-            <a:ext cx="48332" cy="48332"/>
-          </a:xfrm>
-          <a:prstGeom prst="ellipse">
-            <a:avLst/>
-          </a:prstGeom>
-          <a:solidFill>
-            <a:srgbClr val="58F268">
-              <a:alpha val="31428"/>
-            </a:srgbClr>
-          </a:solidFill>
-          <a:ln>
-            <a:noFill/>
-          </a:ln>
-          <a:effectLst>
-            <a:glow rad="63500">
-              <a:srgbClr val="58F268">
-                <a:alpha val="18856"/>
-              </a:srgbClr>
-            </a:glow>
-          </a:effectLst>
-        </p:spPr>
-      </p:sp>
-      <p:sp>
-        <p:nvSpPr>
-          <p:cNvPr id="47" name="Світло рамки 2.6"/>
-          <p:cNvSpPr/>
-          <p:nvPr/>
-        </p:nvSpPr>
-        <p:spPr>
-          <a:xfrm>
-            <a:off x="3741856" y="6096436"/>
-            <a:ext cx="60089" cy="60089"/>
-          </a:xfrm>
-          <a:prstGeom prst="ellipse">
-            <a:avLst/>
-          </a:prstGeom>
-          <a:solidFill>
-            <a:srgbClr val="58F268">
-              <a:alpha val="42857"/>
-            </a:srgbClr>
-          </a:solidFill>
-          <a:ln>
-            <a:noFill/>
-          </a:ln>
-          <a:effectLst>
-            <a:glow rad="63500">
-              <a:srgbClr val="58F268">
-                <a:alpha val="25714"/>
-              </a:srgbClr>
-            </a:glow>
-          </a:effectLst>
-        </p:spPr>
-      </p:sp>
-      <p:sp>
-        <p:nvSpPr>
-          <p:cNvPr id="46" name="Світло рамки 2.5"/>
-          <p:cNvSpPr/>
-          <p:nvPr/>
-        </p:nvSpPr>
-        <p:spPr>
-          <a:xfrm>
-            <a:off x="3735978" y="6090558"/>
-            <a:ext cx="71845" cy="71845"/>
-          </a:xfrm>
-          <a:prstGeom prst="ellipse">
-            <a:avLst/>
-          </a:prstGeom>
-          <a:solidFill>
-            <a:srgbClr val="58F268">
-              <a:alpha val="54285"/>
-            </a:srgbClr>
-          </a:solidFill>
-          <a:ln>
-            <a:noFill/>
-          </a:ln>
-          <a:effectLst>
-            <a:glow rad="63500">
-              <a:srgbClr val="58F268">
-                <a:alpha val="32571"/>
-              </a:srgbClr>
-            </a:glow>
-          </a:effectLst>
-        </p:spPr>
-      </p:sp>
-      <p:sp>
-        <p:nvSpPr>
-          <p:cNvPr id="45" name="Світло рамки 2.4"/>
-          <p:cNvSpPr/>
-          <p:nvPr/>
-        </p:nvSpPr>
-        <p:spPr>
-          <a:xfrm>
-            <a:off x="3730099" y="6084679"/>
-            <a:ext cx="83602" cy="83602"/>
-          </a:xfrm>
-          <a:prstGeom prst="ellipse">
-            <a:avLst/>
-          </a:prstGeom>
-          <a:solidFill>
-            <a:srgbClr val="58F268">
-              <a:alpha val="65714"/>
-            </a:srgbClr>
-          </a:solidFill>
-          <a:ln>
-            <a:noFill/>
-          </a:ln>
-          <a:effectLst>
-            <a:glow rad="63500">
-              <a:srgbClr val="58F268">
-                <a:alpha val="39428"/>
-              </a:srgbClr>
-            </a:glow>
-          </a:effectLst>
-        </p:spPr>
-      </p:sp>
-      <p:sp>
-        <p:nvSpPr>
-          <p:cNvPr id="44" name="Світло рамки 2.3"/>
-          <p:cNvSpPr/>
-          <p:nvPr/>
-        </p:nvSpPr>
-        <p:spPr>
-          <a:xfrm>
-            <a:off x="3724221" y="6078801"/>
-            <a:ext cx="95358" cy="95358"/>
-          </a:xfrm>
-          <a:prstGeom prst="ellipse">
-            <a:avLst/>
-          </a:prstGeom>
-          <a:solidFill>
-            <a:srgbClr val="58F268">
-              <a:alpha val="77142"/>
-            </a:srgbClr>
-          </a:solidFill>
-          <a:ln>
-            <a:noFill/>
-          </a:ln>
-          <a:effectLst>
-            <a:glow rad="63500">
-              <a:srgbClr val="58F268">
-                <a:alpha val="46285"/>
-              </a:srgbClr>
-            </a:glow>
-          </a:effectLst>
-        </p:spPr>
-      </p:sp>
-      <p:sp>
-        <p:nvSpPr>
-          <p:cNvPr id="43" name="Світло рамки 2.2"/>
-          <p:cNvSpPr/>
-          <p:nvPr/>
-        </p:nvSpPr>
-        <p:spPr>
-          <a:xfrm>
-            <a:off x="3718343" y="6072923"/>
-            <a:ext cx="107115" cy="107115"/>
-          </a:xfrm>
-          <a:prstGeom prst="ellipse">
-            <a:avLst/>
-          </a:prstGeom>
-          <a:solidFill>
-            <a:srgbClr val="58F268">
-              <a:alpha val="88571"/>
-            </a:srgbClr>
-          </a:solidFill>
-          <a:ln>
-            <a:noFill/>
-          </a:ln>
-          <a:effectLst>
-            <a:glow rad="63500">
-              <a:srgbClr val="58F268">
-                <a:alpha val="53142"/>
-              </a:srgbClr>
-            </a:glow>
-          </a:effectLst>
-        </p:spPr>
-      </p:sp>
-      <p:sp>
-        <p:nvSpPr>
-          <p:cNvPr id="42" name="Світло рамки 2.1"/>
-          <p:cNvSpPr/>
-          <p:nvPr/>
-        </p:nvSpPr>
-        <p:spPr>
-          <a:xfrm>
-            <a:off x="3712464" y="6067044"/>
-            <a:ext cx="118872" cy="118872"/>
-          </a:xfrm>
-          <a:prstGeom prst="ellipse">
-            <a:avLst/>
-          </a:prstGeom>
-          <a:solidFill>
-            <a:srgbClr val="F2FFF3">
-              <a:alpha val="100000"/>
-            </a:srgbClr>
-          </a:solidFill>
-          <a:ln>
-            <a:noFill/>
-          </a:ln>
-          <a:effectLst>
-            <a:glow rad="101600">
-              <a:srgbClr val="58F268">
-                <a:alpha val="60000"/>
-              </a:srgbClr>
-            </a:glow>
-          </a:effectLst>
-        </p:spPr>
-      </p:sp>
-      <p:sp>
-        <p:nvSpPr>
-          <p:cNvPr id="41" name="Світло рамки 1.8"/>
-          <p:cNvSpPr/>
-          <p:nvPr/>
-        </p:nvSpPr>
-        <p:spPr>
-          <a:xfrm>
-            <a:off x="530352" y="1764792"/>
-            <a:ext cx="36576" cy="36576"/>
-          </a:xfrm>
-          <a:prstGeom prst="ellipse">
-            <a:avLst/>
-          </a:prstGeom>
-          <a:solidFill>
-            <a:srgbClr val="58F268">
-              <a:alpha val="20000"/>
-            </a:srgbClr>
-          </a:solidFill>
-          <a:ln>
-            <a:noFill/>
-          </a:ln>
-          <a:effectLst>
-            <a:glow rad="63500">
-              <a:srgbClr val="58F268">
-                <a:alpha val="12000"/>
-              </a:srgbClr>
-            </a:glow>
-          </a:effectLst>
-        </p:spPr>
-      </p:sp>
-      <p:sp>
-        <p:nvSpPr>
-          <p:cNvPr id="40" name="Світло рамки 1.7"/>
-          <p:cNvSpPr/>
-          <p:nvPr/>
-        </p:nvSpPr>
-        <p:spPr>
-          <a:xfrm>
-            <a:off x="524474" y="1758914"/>
-            <a:ext cx="48332" cy="48332"/>
-          </a:xfrm>
-          <a:prstGeom prst="ellipse">
-            <a:avLst/>
-          </a:prstGeom>
-          <a:solidFill>
-            <a:srgbClr val="58F268">
-              <a:alpha val="31428"/>
-            </a:srgbClr>
-          </a:solidFill>
-          <a:ln>
-            <a:noFill/>
-          </a:ln>
-          <a:effectLst>
-            <a:glow rad="63500">
-              <a:srgbClr val="58F268">
-                <a:alpha val="18856"/>
-              </a:srgbClr>
-            </a:glow>
-          </a:effectLst>
-        </p:spPr>
-      </p:sp>
-      <p:sp>
-        <p:nvSpPr>
-          <p:cNvPr id="39" name="Світло рамки 1.6"/>
-          <p:cNvSpPr/>
-          <p:nvPr/>
-        </p:nvSpPr>
-        <p:spPr>
-          <a:xfrm>
-            <a:off x="518596" y="1753036"/>
-            <a:ext cx="60089" cy="60089"/>
-          </a:xfrm>
-          <a:prstGeom prst="ellipse">
-            <a:avLst/>
-          </a:prstGeom>
-          <a:solidFill>
-            <a:srgbClr val="58F268">
-              <a:alpha val="42857"/>
-            </a:srgbClr>
-          </a:solidFill>
-          <a:ln>
-            <a:noFill/>
-          </a:ln>
-          <a:effectLst>
-            <a:glow rad="63500">
-              <a:srgbClr val="58F268">
-                <a:alpha val="25714"/>
-              </a:srgbClr>
-            </a:glow>
-          </a:effectLst>
-        </p:spPr>
-      </p:sp>
-      <p:sp>
-        <p:nvSpPr>
-          <p:cNvPr id="38" name="Світло рамки 1.5"/>
-          <p:cNvSpPr/>
-          <p:nvPr/>
-        </p:nvSpPr>
-        <p:spPr>
-          <a:xfrm>
-            <a:off x="512718" y="1747158"/>
-            <a:ext cx="71845" cy="71845"/>
-          </a:xfrm>
-          <a:prstGeom prst="ellipse">
-            <a:avLst/>
-          </a:prstGeom>
-          <a:solidFill>
-            <a:srgbClr val="58F268">
-              <a:alpha val="54285"/>
-            </a:srgbClr>
-          </a:solidFill>
-          <a:ln>
-            <a:noFill/>
-          </a:ln>
-          <a:effectLst>
-            <a:glow rad="63500">
-              <a:srgbClr val="58F268">
-                <a:alpha val="32571"/>
-              </a:srgbClr>
-            </a:glow>
-          </a:effectLst>
-        </p:spPr>
-      </p:sp>
-      <p:sp>
-        <p:nvSpPr>
-          <p:cNvPr id="37" name="Світло рамки 1.4"/>
-          <p:cNvSpPr/>
-          <p:nvPr/>
-        </p:nvSpPr>
-        <p:spPr>
-          <a:xfrm>
-            <a:off x="506839" y="1741279"/>
-            <a:ext cx="83602" cy="83602"/>
-          </a:xfrm>
-          <a:prstGeom prst="ellipse">
-            <a:avLst/>
-          </a:prstGeom>
-          <a:solidFill>
-            <a:srgbClr val="58F268">
-              <a:alpha val="65714"/>
-            </a:srgbClr>
-          </a:solidFill>
-          <a:ln>
-            <a:noFill/>
-          </a:ln>
-          <a:effectLst>
-            <a:glow rad="63500">
-              <a:srgbClr val="58F268">
-                <a:alpha val="39428"/>
-              </a:srgbClr>
-            </a:glow>
-          </a:effectLst>
-        </p:spPr>
-      </p:sp>
-      <p:sp>
-        <p:nvSpPr>
-          <p:cNvPr id="36" name="Світло рамки 1.3"/>
-          <p:cNvSpPr/>
-          <p:nvPr/>
-        </p:nvSpPr>
-        <p:spPr>
-          <a:xfrm>
-            <a:off x="500961" y="1735401"/>
-            <a:ext cx="95358" cy="95358"/>
-          </a:xfrm>
-          <a:prstGeom prst="ellipse">
-            <a:avLst/>
-          </a:prstGeom>
-          <a:solidFill>
-            <a:srgbClr val="58F268">
-              <a:alpha val="77142"/>
-            </a:srgbClr>
-          </a:solidFill>
-          <a:ln>
-            <a:noFill/>
-          </a:ln>
-          <a:effectLst>
-            <a:glow rad="63500">
-              <a:srgbClr val="58F268">
-                <a:alpha val="46285"/>
-              </a:srgbClr>
-            </a:glow>
-          </a:effectLst>
-        </p:spPr>
-      </p:sp>
-      <p:sp>
-        <p:nvSpPr>
-          <p:cNvPr id="35" name="Світло рамки 1.2"/>
-          <p:cNvSpPr/>
-          <p:nvPr/>
-        </p:nvSpPr>
-        <p:spPr>
-          <a:xfrm>
-            <a:off x="495083" y="1729523"/>
-            <a:ext cx="107115" cy="107115"/>
-          </a:xfrm>
-          <a:prstGeom prst="ellipse">
-            <a:avLst/>
-          </a:prstGeom>
-          <a:solidFill>
-            <a:srgbClr val="58F268">
-              <a:alpha val="88571"/>
-            </a:srgbClr>
-          </a:solidFill>
-          <a:ln>
-            <a:noFill/>
-          </a:ln>
-          <a:effectLst>
-            <a:glow rad="63500">
-              <a:srgbClr val="58F268">
-                <a:alpha val="53142"/>
-              </a:srgbClr>
-            </a:glow>
-          </a:effectLst>
-        </p:spPr>
-      </p:sp>
-      <p:sp>
-        <p:nvSpPr>
-          <p:cNvPr id="34" name="Світло рамки 1.1"/>
-          <p:cNvSpPr/>
-          <p:nvPr/>
-        </p:nvSpPr>
-        <p:spPr>
-          <a:xfrm>
-            <a:off x="489204" y="1723644"/>
-            <a:ext cx="118872" cy="118872"/>
-          </a:xfrm>
-          <a:prstGeom prst="ellipse">
-            <a:avLst/>
-          </a:prstGeom>
-          <a:solidFill>
-            <a:srgbClr val="F2FFF3">
-              <a:alpha val="100000"/>
-            </a:srgbClr>
-          </a:solidFill>
-          <a:ln>
-            <a:noFill/>
-          </a:ln>
-          <a:effectLst>
-            <a:glow rad="101600">
-              <a:srgbClr val="58F268">
-                <a:alpha val="60000"/>
-              </a:srgbClr>
-            </a:glow>
-          </a:effectLst>
-        </p:spPr>
-      </p:sp>
-      <p:sp>
-        <p:nvSpPr>
           <p:cNvPr id="6" name="Кути коміксу 02 кут 1"/>
           <p:cNvSpPr/>
           <p:nvPr/>
@@ -7125,409 +5730,6 @@
   <p:clrMapOvr>
     <a:masterClrMapping/>
   </p:clrMapOvr>
-  <p:timing>
-    <p:tnLst>
-      <p:par>
-        <p:cTn id="1" dur="indefinite" restart="never" nodeType="tmRoot">
-          <p:childTnLst>
-            <p:seq concurrent="1" nextAc="seek">
-              <p:cTn id="2" dur="indefinite" nodeType="mainSeq">
-                <p:childTnLst>
-                  <p:par>
-                    <p:cTn id="3" fill="hold">
-                      <p:stCondLst>
-                        <p:cond delay="indefinite"/>
-                        <p:cond evt="onBegin" delay="0">
-                          <p:tn val="2"/>
-                        </p:cond>
-                      </p:stCondLst>
-                      <p:childTnLst>
-                        <p:par>
-                          <p:cTn id="4" fill="hold">
-                            <p:stCondLst>
-                              <p:cond delay="0"/>
-                            </p:stCondLst>
-                            <p:childTnLst>
-                              <p:par>
-                                <p:cTn id="5" presetID="0" presetClass="path" presetSubtype="0" repeatCount="indefinite" accel="0" decel="0" fill="hold" nodeType="withEffect">
-                                  <p:stCondLst>
-                                    <p:cond delay="0"/>
-                                  </p:stCondLst>
-                                  <p:childTnLst>
-                                    <p:animMotion origin="layout" path="M 0 0 L 0.26438 0 L 0.26438 0.63333 L 0 0.63333 L 0 0 E" pathEditMode="relative" rAng="0" ptsTypes="AAAAA">
-                                      <p:cBhvr>
-                                        <p:cTn id="6" dur="5503" fill="hold"/>
-                                        <p:tgtEl>
-                                          <p:spTgt spid="34"/>
-                                        </p:tgtEl>
-                                        <p:attrNameLst>
-                                          <p:attrName>ppt_x</p:attrName>
-                                          <p:attrName>ppt_y</p:attrName>
-                                        </p:attrNameLst>
-                                      </p:cBhvr>
-                                      <p:rCtr x="0" y="0"/>
-                                    </p:animMotion>
-                                  </p:childTnLst>
-                                </p:cTn>
-                              </p:par>
-                              <p:par>
-                                <p:cTn id="7" presetID="0" presetClass="path" presetSubtype="0" repeatCount="indefinite" accel="0" decel="0" fill="hold" nodeType="withEffect">
-                                  <p:stCondLst>
-                                    <p:cond delay="55"/>
-                                  </p:stCondLst>
-                                  <p:childTnLst>
-                                    <p:animMotion origin="layout" path="M 0 0 L 0.26438 0 L 0.26438 0.63333 L 0 0.63333 L 0 0 E" pathEditMode="relative" rAng="0" ptsTypes="AAAAA">
-                                      <p:cBhvr>
-                                        <p:cTn id="8" dur="5503" fill="hold"/>
-                                        <p:tgtEl>
-                                          <p:spTgt spid="35"/>
-                                        </p:tgtEl>
-                                        <p:attrNameLst>
-                                          <p:attrName>ppt_x</p:attrName>
-                                          <p:attrName>ppt_y</p:attrName>
-                                        </p:attrNameLst>
-                                      </p:cBhvr>
-                                      <p:rCtr x="0" y="0"/>
-                                    </p:animMotion>
-                                  </p:childTnLst>
-                                </p:cTn>
-                              </p:par>
-                              <p:par>
-                                <p:cTn id="9" presetID="0" presetClass="path" presetSubtype="0" repeatCount="indefinite" accel="0" decel="0" fill="hold" nodeType="withEffect">
-                                  <p:stCondLst>
-                                    <p:cond delay="110"/>
-                                  </p:stCondLst>
-                                  <p:childTnLst>
-                                    <p:animMotion origin="layout" path="M 0 0 L 0.26438 0 L 0.26438 0.63333 L 0 0.63333 L 0 0 E" pathEditMode="relative" rAng="0" ptsTypes="AAAAA">
-                                      <p:cBhvr>
-                                        <p:cTn id="10" dur="5503" fill="hold"/>
-                                        <p:tgtEl>
-                                          <p:spTgt spid="36"/>
-                                        </p:tgtEl>
-                                        <p:attrNameLst>
-                                          <p:attrName>ppt_x</p:attrName>
-                                          <p:attrName>ppt_y</p:attrName>
-                                        </p:attrNameLst>
-                                      </p:cBhvr>
-                                      <p:rCtr x="0" y="0"/>
-                                    </p:animMotion>
-                                  </p:childTnLst>
-                                </p:cTn>
-                              </p:par>
-                              <p:par>
-                                <p:cTn id="11" presetID="0" presetClass="path" presetSubtype="0" repeatCount="indefinite" accel="0" decel="0" fill="hold" nodeType="withEffect">
-                                  <p:stCondLst>
-                                    <p:cond delay="165"/>
-                                  </p:stCondLst>
-                                  <p:childTnLst>
-                                    <p:animMotion origin="layout" path="M 0 0 L 0.26438 0 L 0.26438 0.63333 L 0 0.63333 L 0 0 E" pathEditMode="relative" rAng="0" ptsTypes="AAAAA">
-                                      <p:cBhvr>
-                                        <p:cTn id="12" dur="5503" fill="hold"/>
-                                        <p:tgtEl>
-                                          <p:spTgt spid="37"/>
-                                        </p:tgtEl>
-                                        <p:attrNameLst>
-                                          <p:attrName>ppt_x</p:attrName>
-                                          <p:attrName>ppt_y</p:attrName>
-                                        </p:attrNameLst>
-                                      </p:cBhvr>
-                                      <p:rCtr x="0" y="0"/>
-                                    </p:animMotion>
-                                  </p:childTnLst>
-                                </p:cTn>
-                              </p:par>
-                              <p:par>
-                                <p:cTn id="13" presetID="0" presetClass="path" presetSubtype="0" repeatCount="indefinite" accel="0" decel="0" fill="hold" nodeType="withEffect">
-                                  <p:stCondLst>
-                                    <p:cond delay="220"/>
-                                  </p:stCondLst>
-                                  <p:childTnLst>
-                                    <p:animMotion origin="layout" path="M 0 0 L 0.26438 0 L 0.26438 0.63333 L 0 0.63333 L 0 0 E" pathEditMode="relative" rAng="0" ptsTypes="AAAAA">
-                                      <p:cBhvr>
-                                        <p:cTn id="14" dur="5503" fill="hold"/>
-                                        <p:tgtEl>
-                                          <p:spTgt spid="38"/>
-                                        </p:tgtEl>
-                                        <p:attrNameLst>
-                                          <p:attrName>ppt_x</p:attrName>
-                                          <p:attrName>ppt_y</p:attrName>
-                                        </p:attrNameLst>
-                                      </p:cBhvr>
-                                      <p:rCtr x="0" y="0"/>
-                                    </p:animMotion>
-                                  </p:childTnLst>
-                                </p:cTn>
-                              </p:par>
-                              <p:par>
-                                <p:cTn id="15" presetID="0" presetClass="path" presetSubtype="0" repeatCount="indefinite" accel="0" decel="0" fill="hold" nodeType="withEffect">
-                                  <p:stCondLst>
-                                    <p:cond delay="275"/>
-                                  </p:stCondLst>
-                                  <p:childTnLst>
-                                    <p:animMotion origin="layout" path="M 0 0 L 0.26438 0 L 0.26438 0.63333 L 0 0.63333 L 0 0 E" pathEditMode="relative" rAng="0" ptsTypes="AAAAA">
-                                      <p:cBhvr>
-                                        <p:cTn id="16" dur="5503" fill="hold"/>
-                                        <p:tgtEl>
-                                          <p:spTgt spid="39"/>
-                                        </p:tgtEl>
-                                        <p:attrNameLst>
-                                          <p:attrName>ppt_x</p:attrName>
-                                          <p:attrName>ppt_y</p:attrName>
-                                        </p:attrNameLst>
-                                      </p:cBhvr>
-                                      <p:rCtr x="0" y="0"/>
-                                    </p:animMotion>
-                                  </p:childTnLst>
-                                </p:cTn>
-                              </p:par>
-                              <p:par>
-                                <p:cTn id="17" presetID="0" presetClass="path" presetSubtype="0" repeatCount="indefinite" accel="0" decel="0" fill="hold" nodeType="withEffect">
-                                  <p:stCondLst>
-                                    <p:cond delay="330"/>
-                                  </p:stCondLst>
-                                  <p:childTnLst>
-                                    <p:animMotion origin="layout" path="M 0 0 L 0.26438 0 L 0.26438 0.63333 L 0 0.63333 L 0 0 E" pathEditMode="relative" rAng="0" ptsTypes="AAAAA">
-                                      <p:cBhvr>
-                                        <p:cTn id="18" dur="5503" fill="hold"/>
-                                        <p:tgtEl>
-                                          <p:spTgt spid="40"/>
-                                        </p:tgtEl>
-                                        <p:attrNameLst>
-                                          <p:attrName>ppt_x</p:attrName>
-                                          <p:attrName>ppt_y</p:attrName>
-                                        </p:attrNameLst>
-                                      </p:cBhvr>
-                                      <p:rCtr x="0" y="0"/>
-                                    </p:animMotion>
-                                  </p:childTnLst>
-                                </p:cTn>
-                              </p:par>
-                              <p:par>
-                                <p:cTn id="19" presetID="0" presetClass="path" presetSubtype="0" repeatCount="indefinite" accel="0" decel="0" fill="hold" nodeType="withEffect">
-                                  <p:stCondLst>
-                                    <p:cond delay="385"/>
-                                  </p:stCondLst>
-                                  <p:childTnLst>
-                                    <p:animMotion origin="layout" path="M 0 0 L 0.26438 0 L 0.26438 0.63333 L 0 0.63333 L 0 0 E" pathEditMode="relative" rAng="0" ptsTypes="AAAAA">
-                                      <p:cBhvr>
-                                        <p:cTn id="20" dur="5503" fill="hold"/>
-                                        <p:tgtEl>
-                                          <p:spTgt spid="41"/>
-                                        </p:tgtEl>
-                                        <p:attrNameLst>
-                                          <p:attrName>ppt_x</p:attrName>
-                                          <p:attrName>ppt_y</p:attrName>
-                                        </p:attrNameLst>
-                                      </p:cBhvr>
-                                      <p:rCtr x="0" y="0"/>
-                                    </p:animMotion>
-                                  </p:childTnLst>
-                                </p:cTn>
-                              </p:par>
-                              <p:par>
-                                <p:cTn id="21" presetID="0" presetClass="path" presetSubtype="0" repeatCount="indefinite" accel="0" decel="0" fill="hold" nodeType="withEffect">
-                                  <p:stCondLst>
-                                    <p:cond delay="0"/>
-                                  </p:stCondLst>
-                                  <p:childTnLst>
-                                    <p:animMotion origin="layout" path="M 0 0 L -0.26438 0 L -0.26438 -0.63333 L 0 -0.63333 L 0 0 E" pathEditMode="relative" rAng="0" ptsTypes="AAAAA">
-                                      <p:cBhvr>
-                                        <p:cTn id="22" dur="5503" fill="hold"/>
-                                        <p:tgtEl>
-                                          <p:spTgt spid="42"/>
-                                        </p:tgtEl>
-                                        <p:attrNameLst>
-                                          <p:attrName>ppt_x</p:attrName>
-                                          <p:attrName>ppt_y</p:attrName>
-                                        </p:attrNameLst>
-                                      </p:cBhvr>
-                                      <p:rCtr x="0" y="0"/>
-                                    </p:animMotion>
-                                  </p:childTnLst>
-                                </p:cTn>
-                              </p:par>
-                              <p:par>
-                                <p:cTn id="23" presetID="0" presetClass="path" presetSubtype="0" repeatCount="indefinite" accel="0" decel="0" fill="hold" nodeType="withEffect">
-                                  <p:stCondLst>
-                                    <p:cond delay="55"/>
-                                  </p:stCondLst>
-                                  <p:childTnLst>
-                                    <p:animMotion origin="layout" path="M 0 0 L -0.26438 0 L -0.26438 -0.63333 L 0 -0.63333 L 0 0 E" pathEditMode="relative" rAng="0" ptsTypes="AAAAA">
-                                      <p:cBhvr>
-                                        <p:cTn id="24" dur="5503" fill="hold"/>
-                                        <p:tgtEl>
-                                          <p:spTgt spid="43"/>
-                                        </p:tgtEl>
-                                        <p:attrNameLst>
-                                          <p:attrName>ppt_x</p:attrName>
-                                          <p:attrName>ppt_y</p:attrName>
-                                        </p:attrNameLst>
-                                      </p:cBhvr>
-                                      <p:rCtr x="0" y="0"/>
-                                    </p:animMotion>
-                                  </p:childTnLst>
-                                </p:cTn>
-                              </p:par>
-                              <p:par>
-                                <p:cTn id="25" presetID="0" presetClass="path" presetSubtype="0" repeatCount="indefinite" accel="0" decel="0" fill="hold" nodeType="withEffect">
-                                  <p:stCondLst>
-                                    <p:cond delay="110"/>
-                                  </p:stCondLst>
-                                  <p:childTnLst>
-                                    <p:animMotion origin="layout" path="M 0 0 L -0.26438 0 L -0.26438 -0.63333 L 0 -0.63333 L 0 0 E" pathEditMode="relative" rAng="0" ptsTypes="AAAAA">
-                                      <p:cBhvr>
-                                        <p:cTn id="26" dur="5503" fill="hold"/>
-                                        <p:tgtEl>
-                                          <p:spTgt spid="44"/>
-                                        </p:tgtEl>
-                                        <p:attrNameLst>
-                                          <p:attrName>ppt_x</p:attrName>
-                                          <p:attrName>ppt_y</p:attrName>
-                                        </p:attrNameLst>
-                                      </p:cBhvr>
-                                      <p:rCtr x="0" y="0"/>
-                                    </p:animMotion>
-                                  </p:childTnLst>
-                                </p:cTn>
-                              </p:par>
-                              <p:par>
-                                <p:cTn id="27" presetID="0" presetClass="path" presetSubtype="0" repeatCount="indefinite" accel="0" decel="0" fill="hold" nodeType="withEffect">
-                                  <p:stCondLst>
-                                    <p:cond delay="165"/>
-                                  </p:stCondLst>
-                                  <p:childTnLst>
-                                    <p:animMotion origin="layout" path="M 0 0 L -0.26438 0 L -0.26438 -0.63333 L 0 -0.63333 L 0 0 E" pathEditMode="relative" rAng="0" ptsTypes="AAAAA">
-                                      <p:cBhvr>
-                                        <p:cTn id="28" dur="5503" fill="hold"/>
-                                        <p:tgtEl>
-                                          <p:spTgt spid="45"/>
-                                        </p:tgtEl>
-                                        <p:attrNameLst>
-                                          <p:attrName>ppt_x</p:attrName>
-                                          <p:attrName>ppt_y</p:attrName>
-                                        </p:attrNameLst>
-                                      </p:cBhvr>
-                                      <p:rCtr x="0" y="0"/>
-                                    </p:animMotion>
-                                  </p:childTnLst>
-                                </p:cTn>
-                              </p:par>
-                              <p:par>
-                                <p:cTn id="29" presetID="0" presetClass="path" presetSubtype="0" repeatCount="indefinite" accel="0" decel="0" fill="hold" nodeType="withEffect">
-                                  <p:stCondLst>
-                                    <p:cond delay="220"/>
-                                  </p:stCondLst>
-                                  <p:childTnLst>
-                                    <p:animMotion origin="layout" path="M 0 0 L -0.26438 0 L -0.26438 -0.63333 L 0 -0.63333 L 0 0 E" pathEditMode="relative" rAng="0" ptsTypes="AAAAA">
-                                      <p:cBhvr>
-                                        <p:cTn id="30" dur="5503" fill="hold"/>
-                                        <p:tgtEl>
-                                          <p:spTgt spid="46"/>
-                                        </p:tgtEl>
-                                        <p:attrNameLst>
-                                          <p:attrName>ppt_x</p:attrName>
-                                          <p:attrName>ppt_y</p:attrName>
-                                        </p:attrNameLst>
-                                      </p:cBhvr>
-                                      <p:rCtr x="0" y="0"/>
-                                    </p:animMotion>
-                                  </p:childTnLst>
-                                </p:cTn>
-                              </p:par>
-                              <p:par>
-                                <p:cTn id="31" presetID="0" presetClass="path" presetSubtype="0" repeatCount="indefinite" accel="0" decel="0" fill="hold" nodeType="withEffect">
-                                  <p:stCondLst>
-                                    <p:cond delay="275"/>
-                                  </p:stCondLst>
-                                  <p:childTnLst>
-                                    <p:animMotion origin="layout" path="M 0 0 L -0.26438 0 L -0.26438 -0.63333 L 0 -0.63333 L 0 0 E" pathEditMode="relative" rAng="0" ptsTypes="AAAAA">
-                                      <p:cBhvr>
-                                        <p:cTn id="32" dur="5503" fill="hold"/>
-                                        <p:tgtEl>
-                                          <p:spTgt spid="47"/>
-                                        </p:tgtEl>
-                                        <p:attrNameLst>
-                                          <p:attrName>ppt_x</p:attrName>
-                                          <p:attrName>ppt_y</p:attrName>
-                                        </p:attrNameLst>
-                                      </p:cBhvr>
-                                      <p:rCtr x="0" y="0"/>
-                                    </p:animMotion>
-                                  </p:childTnLst>
-                                </p:cTn>
-                              </p:par>
-                              <p:par>
-                                <p:cTn id="33" presetID="0" presetClass="path" presetSubtype="0" repeatCount="indefinite" accel="0" decel="0" fill="hold" nodeType="withEffect">
-                                  <p:stCondLst>
-                                    <p:cond delay="330"/>
-                                  </p:stCondLst>
-                                  <p:childTnLst>
-                                    <p:animMotion origin="layout" path="M 0 0 L -0.26438 0 L -0.26438 -0.63333 L 0 -0.63333 L 0 0 E" pathEditMode="relative" rAng="0" ptsTypes="AAAAA">
-                                      <p:cBhvr>
-                                        <p:cTn id="34" dur="5503" fill="hold"/>
-                                        <p:tgtEl>
-                                          <p:spTgt spid="48"/>
-                                        </p:tgtEl>
-                                        <p:attrNameLst>
-                                          <p:attrName>ppt_x</p:attrName>
-                                          <p:attrName>ppt_y</p:attrName>
-                                        </p:attrNameLst>
-                                      </p:cBhvr>
-                                      <p:rCtr x="0" y="0"/>
-                                    </p:animMotion>
-                                  </p:childTnLst>
-                                </p:cTn>
-                              </p:par>
-                              <p:par>
-                                <p:cTn id="35" presetID="0" presetClass="path" presetSubtype="0" repeatCount="indefinite" accel="0" decel="0" fill="hold" nodeType="withEffect">
-                                  <p:stCondLst>
-                                    <p:cond delay="385"/>
-                                  </p:stCondLst>
-                                  <p:childTnLst>
-                                    <p:animMotion origin="layout" path="M 0 0 L -0.26438 0 L -0.26438 -0.63333 L 0 -0.63333 L 0 0 E" pathEditMode="relative" rAng="0" ptsTypes="AAAAA">
-                                      <p:cBhvr>
-                                        <p:cTn id="36" dur="5503" fill="hold"/>
-                                        <p:tgtEl>
-                                          <p:spTgt spid="49"/>
-                                        </p:tgtEl>
-                                        <p:attrNameLst>
-                                          <p:attrName>ppt_x</p:attrName>
-                                          <p:attrName>ppt_y</p:attrName>
-                                        </p:attrNameLst>
-                                      </p:cBhvr>
-                                      <p:rCtr x="0" y="0"/>
-                                    </p:animMotion>
-                                  </p:childTnLst>
-                                </p:cTn>
-                              </p:par>
-                            </p:childTnLst>
-                          </p:cTn>
-                        </p:par>
-                      </p:childTnLst>
-                    </p:cTn>
-                  </p:par>
-                </p:childTnLst>
-              </p:cTn>
-              <p:prevCondLst>
-                <p:cond evt="onPrev" delay="0">
-                  <p:tgtEl>
-                    <p:sldTgt/>
-                  </p:tgtEl>
-                </p:cond>
-              </p:prevCondLst>
-              <p:nextCondLst>
-                <p:cond evt="onNext" delay="0">
-                  <p:tgtEl>
-                    <p:sldTgt/>
-                  </p:tgtEl>
-                </p:cond>
-              </p:nextCondLst>
-            </p:seq>
-          </p:childTnLst>
-        </p:cTn>
-      </p:par>
-    </p:tnLst>
-  </p:timing>
 </p:sld>
 </file>
 
@@ -7692,502 +5894,6 @@
       </p:sp>
       <p:sp>
         <p:nvSpPr>
-          <p:cNvPr id="41" name="Світло рамки 2.8"/>
-          <p:cNvSpPr/>
-          <p:nvPr/>
-        </p:nvSpPr>
-        <p:spPr>
-          <a:xfrm>
-            <a:off x="11624767" y="5141704"/>
-            <a:ext cx="36576" cy="36576"/>
-          </a:xfrm>
-          <a:prstGeom prst="ellipse">
-            <a:avLst/>
-          </a:prstGeom>
-          <a:solidFill>
-            <a:srgbClr val="58F268">
-              <a:alpha val="20000"/>
-            </a:srgbClr>
-          </a:solidFill>
-          <a:ln>
-            <a:noFill/>
-          </a:ln>
-          <a:effectLst>
-            <a:glow rad="63500">
-              <a:srgbClr val="58F268">
-                <a:alpha val="12000"/>
-              </a:srgbClr>
-            </a:glow>
-          </a:effectLst>
-        </p:spPr>
-      </p:sp>
-      <p:sp>
-        <p:nvSpPr>
-          <p:cNvPr id="40" name="Світло рамки 2.7"/>
-          <p:cNvSpPr/>
-          <p:nvPr/>
-        </p:nvSpPr>
-        <p:spPr>
-          <a:xfrm>
-            <a:off x="11618889" y="5135826"/>
-            <a:ext cx="48332" cy="48332"/>
-          </a:xfrm>
-          <a:prstGeom prst="ellipse">
-            <a:avLst/>
-          </a:prstGeom>
-          <a:solidFill>
-            <a:srgbClr val="58F268">
-              <a:alpha val="31428"/>
-            </a:srgbClr>
-          </a:solidFill>
-          <a:ln>
-            <a:noFill/>
-          </a:ln>
-          <a:effectLst>
-            <a:glow rad="63500">
-              <a:srgbClr val="58F268">
-                <a:alpha val="18856"/>
-              </a:srgbClr>
-            </a:glow>
-          </a:effectLst>
-        </p:spPr>
-      </p:sp>
-      <p:sp>
-        <p:nvSpPr>
-          <p:cNvPr id="39" name="Світло рамки 2.6"/>
-          <p:cNvSpPr/>
-          <p:nvPr/>
-        </p:nvSpPr>
-        <p:spPr>
-          <a:xfrm>
-            <a:off x="11613011" y="5129948"/>
-            <a:ext cx="60089" cy="60089"/>
-          </a:xfrm>
-          <a:prstGeom prst="ellipse">
-            <a:avLst/>
-          </a:prstGeom>
-          <a:solidFill>
-            <a:srgbClr val="58F268">
-              <a:alpha val="42857"/>
-            </a:srgbClr>
-          </a:solidFill>
-          <a:ln>
-            <a:noFill/>
-          </a:ln>
-          <a:effectLst>
-            <a:glow rad="63500">
-              <a:srgbClr val="58F268">
-                <a:alpha val="25714"/>
-              </a:srgbClr>
-            </a:glow>
-          </a:effectLst>
-        </p:spPr>
-      </p:sp>
-      <p:sp>
-        <p:nvSpPr>
-          <p:cNvPr id="38" name="Світло рамки 2.5"/>
-          <p:cNvSpPr/>
-          <p:nvPr/>
-        </p:nvSpPr>
-        <p:spPr>
-          <a:xfrm>
-            <a:off x="11607133" y="5124070"/>
-            <a:ext cx="71845" cy="71845"/>
-          </a:xfrm>
-          <a:prstGeom prst="ellipse">
-            <a:avLst/>
-          </a:prstGeom>
-          <a:solidFill>
-            <a:srgbClr val="58F268">
-              <a:alpha val="54285"/>
-            </a:srgbClr>
-          </a:solidFill>
-          <a:ln>
-            <a:noFill/>
-          </a:ln>
-          <a:effectLst>
-            <a:glow rad="63500">
-              <a:srgbClr val="58F268">
-                <a:alpha val="32571"/>
-              </a:srgbClr>
-            </a:glow>
-          </a:effectLst>
-        </p:spPr>
-      </p:sp>
-      <p:sp>
-        <p:nvSpPr>
-          <p:cNvPr id="37" name="Світло рамки 2.4"/>
-          <p:cNvSpPr/>
-          <p:nvPr/>
-        </p:nvSpPr>
-        <p:spPr>
-          <a:xfrm>
-            <a:off x="11601254" y="5118191"/>
-            <a:ext cx="83602" cy="83602"/>
-          </a:xfrm>
-          <a:prstGeom prst="ellipse">
-            <a:avLst/>
-          </a:prstGeom>
-          <a:solidFill>
-            <a:srgbClr val="58F268">
-              <a:alpha val="65714"/>
-            </a:srgbClr>
-          </a:solidFill>
-          <a:ln>
-            <a:noFill/>
-          </a:ln>
-          <a:effectLst>
-            <a:glow rad="63500">
-              <a:srgbClr val="58F268">
-                <a:alpha val="39428"/>
-              </a:srgbClr>
-            </a:glow>
-          </a:effectLst>
-        </p:spPr>
-      </p:sp>
-      <p:sp>
-        <p:nvSpPr>
-          <p:cNvPr id="36" name="Світло рамки 2.3"/>
-          <p:cNvSpPr/>
-          <p:nvPr/>
-        </p:nvSpPr>
-        <p:spPr>
-          <a:xfrm>
-            <a:off x="11595376" y="5112313"/>
-            <a:ext cx="95358" cy="95358"/>
-          </a:xfrm>
-          <a:prstGeom prst="ellipse">
-            <a:avLst/>
-          </a:prstGeom>
-          <a:solidFill>
-            <a:srgbClr val="58F268">
-              <a:alpha val="77142"/>
-            </a:srgbClr>
-          </a:solidFill>
-          <a:ln>
-            <a:noFill/>
-          </a:ln>
-          <a:effectLst>
-            <a:glow rad="63500">
-              <a:srgbClr val="58F268">
-                <a:alpha val="46285"/>
-              </a:srgbClr>
-            </a:glow>
-          </a:effectLst>
-        </p:spPr>
-      </p:sp>
-      <p:sp>
-        <p:nvSpPr>
-          <p:cNvPr id="35" name="Світло рамки 2.2"/>
-          <p:cNvSpPr/>
-          <p:nvPr/>
-        </p:nvSpPr>
-        <p:spPr>
-          <a:xfrm>
-            <a:off x="11589498" y="5106435"/>
-            <a:ext cx="107115" cy="107115"/>
-          </a:xfrm>
-          <a:prstGeom prst="ellipse">
-            <a:avLst/>
-          </a:prstGeom>
-          <a:solidFill>
-            <a:srgbClr val="58F268">
-              <a:alpha val="88571"/>
-            </a:srgbClr>
-          </a:solidFill>
-          <a:ln>
-            <a:noFill/>
-          </a:ln>
-          <a:effectLst>
-            <a:glow rad="63500">
-              <a:srgbClr val="58F268">
-                <a:alpha val="53142"/>
-              </a:srgbClr>
-            </a:glow>
-          </a:effectLst>
-        </p:spPr>
-      </p:sp>
-      <p:sp>
-        <p:nvSpPr>
-          <p:cNvPr id="34" name="Світло рамки 2.1"/>
-          <p:cNvSpPr/>
-          <p:nvPr/>
-        </p:nvSpPr>
-        <p:spPr>
-          <a:xfrm>
-            <a:off x="11583619" y="5100556"/>
-            <a:ext cx="118872" cy="118872"/>
-          </a:xfrm>
-          <a:prstGeom prst="ellipse">
-            <a:avLst/>
-          </a:prstGeom>
-          <a:solidFill>
-            <a:srgbClr val="F2FFF3">
-              <a:alpha val="100000"/>
-            </a:srgbClr>
-          </a:solidFill>
-          <a:ln>
-            <a:noFill/>
-          </a:ln>
-          <a:effectLst>
-            <a:glow rad="101600">
-              <a:srgbClr val="58F268">
-                <a:alpha val="60000"/>
-              </a:srgbClr>
-            </a:glow>
-          </a:effectLst>
-        </p:spPr>
-      </p:sp>
-      <p:sp>
-        <p:nvSpPr>
-          <p:cNvPr id="33" name="Світло рамки 1.8"/>
-          <p:cNvSpPr/>
-          <p:nvPr/>
-        </p:nvSpPr>
-        <p:spPr>
-          <a:xfrm>
-            <a:off x="530352" y="1719072"/>
-            <a:ext cx="36576" cy="36576"/>
-          </a:xfrm>
-          <a:prstGeom prst="ellipse">
-            <a:avLst/>
-          </a:prstGeom>
-          <a:solidFill>
-            <a:srgbClr val="58F268">
-              <a:alpha val="20000"/>
-            </a:srgbClr>
-          </a:solidFill>
-          <a:ln>
-            <a:noFill/>
-          </a:ln>
-          <a:effectLst>
-            <a:glow rad="63500">
-              <a:srgbClr val="58F268">
-                <a:alpha val="12000"/>
-              </a:srgbClr>
-            </a:glow>
-          </a:effectLst>
-        </p:spPr>
-      </p:sp>
-      <p:sp>
-        <p:nvSpPr>
-          <p:cNvPr id="32" name="Світло рамки 1.7"/>
-          <p:cNvSpPr/>
-          <p:nvPr/>
-        </p:nvSpPr>
-        <p:spPr>
-          <a:xfrm>
-            <a:off x="524474" y="1713194"/>
-            <a:ext cx="48332" cy="48332"/>
-          </a:xfrm>
-          <a:prstGeom prst="ellipse">
-            <a:avLst/>
-          </a:prstGeom>
-          <a:solidFill>
-            <a:srgbClr val="58F268">
-              <a:alpha val="31428"/>
-            </a:srgbClr>
-          </a:solidFill>
-          <a:ln>
-            <a:noFill/>
-          </a:ln>
-          <a:effectLst>
-            <a:glow rad="63500">
-              <a:srgbClr val="58F268">
-                <a:alpha val="18856"/>
-              </a:srgbClr>
-            </a:glow>
-          </a:effectLst>
-        </p:spPr>
-      </p:sp>
-      <p:sp>
-        <p:nvSpPr>
-          <p:cNvPr id="31" name="Світло рамки 1.6"/>
-          <p:cNvSpPr/>
-          <p:nvPr/>
-        </p:nvSpPr>
-        <p:spPr>
-          <a:xfrm>
-            <a:off x="518596" y="1707316"/>
-            <a:ext cx="60089" cy="60089"/>
-          </a:xfrm>
-          <a:prstGeom prst="ellipse">
-            <a:avLst/>
-          </a:prstGeom>
-          <a:solidFill>
-            <a:srgbClr val="58F268">
-              <a:alpha val="42857"/>
-            </a:srgbClr>
-          </a:solidFill>
-          <a:ln>
-            <a:noFill/>
-          </a:ln>
-          <a:effectLst>
-            <a:glow rad="63500">
-              <a:srgbClr val="58F268">
-                <a:alpha val="25714"/>
-              </a:srgbClr>
-            </a:glow>
-          </a:effectLst>
-        </p:spPr>
-      </p:sp>
-      <p:sp>
-        <p:nvSpPr>
-          <p:cNvPr id="30" name="Світло рамки 1.5"/>
-          <p:cNvSpPr/>
-          <p:nvPr/>
-        </p:nvSpPr>
-        <p:spPr>
-          <a:xfrm>
-            <a:off x="512718" y="1701438"/>
-            <a:ext cx="71845" cy="71845"/>
-          </a:xfrm>
-          <a:prstGeom prst="ellipse">
-            <a:avLst/>
-          </a:prstGeom>
-          <a:solidFill>
-            <a:srgbClr val="58F268">
-              <a:alpha val="54285"/>
-            </a:srgbClr>
-          </a:solidFill>
-          <a:ln>
-            <a:noFill/>
-          </a:ln>
-          <a:effectLst>
-            <a:glow rad="63500">
-              <a:srgbClr val="58F268">
-                <a:alpha val="32571"/>
-              </a:srgbClr>
-            </a:glow>
-          </a:effectLst>
-        </p:spPr>
-      </p:sp>
-      <p:sp>
-        <p:nvSpPr>
-          <p:cNvPr id="29" name="Світло рамки 1.4"/>
-          <p:cNvSpPr/>
-          <p:nvPr/>
-        </p:nvSpPr>
-        <p:spPr>
-          <a:xfrm>
-            <a:off x="506839" y="1695559"/>
-            <a:ext cx="83602" cy="83602"/>
-          </a:xfrm>
-          <a:prstGeom prst="ellipse">
-            <a:avLst/>
-          </a:prstGeom>
-          <a:solidFill>
-            <a:srgbClr val="58F268">
-              <a:alpha val="65714"/>
-            </a:srgbClr>
-          </a:solidFill>
-          <a:ln>
-            <a:noFill/>
-          </a:ln>
-          <a:effectLst>
-            <a:glow rad="63500">
-              <a:srgbClr val="58F268">
-                <a:alpha val="39428"/>
-              </a:srgbClr>
-            </a:glow>
-          </a:effectLst>
-        </p:spPr>
-      </p:sp>
-      <p:sp>
-        <p:nvSpPr>
-          <p:cNvPr id="28" name="Світло рамки 1.3"/>
-          <p:cNvSpPr/>
-          <p:nvPr/>
-        </p:nvSpPr>
-        <p:spPr>
-          <a:xfrm>
-            <a:off x="500961" y="1689681"/>
-            <a:ext cx="95358" cy="95358"/>
-          </a:xfrm>
-          <a:prstGeom prst="ellipse">
-            <a:avLst/>
-          </a:prstGeom>
-          <a:solidFill>
-            <a:srgbClr val="58F268">
-              <a:alpha val="77142"/>
-            </a:srgbClr>
-          </a:solidFill>
-          <a:ln>
-            <a:noFill/>
-          </a:ln>
-          <a:effectLst>
-            <a:glow rad="63500">
-              <a:srgbClr val="58F268">
-                <a:alpha val="46285"/>
-              </a:srgbClr>
-            </a:glow>
-          </a:effectLst>
-        </p:spPr>
-      </p:sp>
-      <p:sp>
-        <p:nvSpPr>
-          <p:cNvPr id="27" name="Світло рамки 1.2"/>
-          <p:cNvSpPr/>
-          <p:nvPr/>
-        </p:nvSpPr>
-        <p:spPr>
-          <a:xfrm>
-            <a:off x="495083" y="1683803"/>
-            <a:ext cx="107115" cy="107115"/>
-          </a:xfrm>
-          <a:prstGeom prst="ellipse">
-            <a:avLst/>
-          </a:prstGeom>
-          <a:solidFill>
-            <a:srgbClr val="58F268">
-              <a:alpha val="88571"/>
-            </a:srgbClr>
-          </a:solidFill>
-          <a:ln>
-            <a:noFill/>
-          </a:ln>
-          <a:effectLst>
-            <a:glow rad="63500">
-              <a:srgbClr val="58F268">
-                <a:alpha val="53142"/>
-              </a:srgbClr>
-            </a:glow>
-          </a:effectLst>
-        </p:spPr>
-      </p:sp>
-      <p:sp>
-        <p:nvSpPr>
-          <p:cNvPr id="26" name="Світло рамки 1.1"/>
-          <p:cNvSpPr/>
-          <p:nvPr/>
-        </p:nvSpPr>
-        <p:spPr>
-          <a:xfrm>
-            <a:off x="489204" y="1677924"/>
-            <a:ext cx="118872" cy="118872"/>
-          </a:xfrm>
-          <a:prstGeom prst="ellipse">
-            <a:avLst/>
-          </a:prstGeom>
-          <a:solidFill>
-            <a:srgbClr val="F2FFF3">
-              <a:alpha val="100000"/>
-            </a:srgbClr>
-          </a:solidFill>
-          <a:ln>
-            <a:noFill/>
-          </a:ln>
-          <a:effectLst>
-            <a:glow rad="101600">
-              <a:srgbClr val="58F268">
-                <a:alpha val="60000"/>
-              </a:srgbClr>
-            </a:glow>
-          </a:effectLst>
-        </p:spPr>
-      </p:sp>
-      <p:sp>
-        <p:nvSpPr>
           <p:cNvPr id="6" name="Кути коміксу 03 кут 1"/>
           <p:cNvSpPr/>
           <p:nvPr/>
@@ -9059,409 +6765,6 @@
   <p:clrMapOvr>
     <a:masterClrMapping/>
   </p:clrMapOvr>
-  <p:timing>
-    <p:tnLst>
-      <p:par>
-        <p:cTn id="1" dur="indefinite" restart="never" nodeType="tmRoot">
-          <p:childTnLst>
-            <p:seq concurrent="1" nextAc="seek">
-              <p:cTn id="2" dur="indefinite" nodeType="mainSeq">
-                <p:childTnLst>
-                  <p:par>
-                    <p:cTn id="3" fill="hold">
-                      <p:stCondLst>
-                        <p:cond delay="indefinite"/>
-                        <p:cond evt="onBegin" delay="0">
-                          <p:tn val="2"/>
-                        </p:cond>
-                      </p:stCondLst>
-                      <p:childTnLst>
-                        <p:par>
-                          <p:cTn id="4" fill="hold">
-                            <p:stCondLst>
-                              <p:cond delay="0"/>
-                            </p:stCondLst>
-                            <p:childTnLst>
-                              <p:par>
-                                <p:cTn id="5" presetID="0" presetClass="path" presetSubtype="0" repeatCount="indefinite" accel="0" decel="0" fill="hold" nodeType="withEffect">
-                                  <p:stCondLst>
-                                    <p:cond delay="0"/>
-                                  </p:stCondLst>
-                                  <p:childTnLst>
-                                    <p:animMotion origin="layout" path="M 0 0 L 0.90997 0 L 0.90997 0.49907 L 0 0.49907 L 0 0 E" pathEditMode="relative" rAng="0" ptsTypes="AAAAA">
-                                      <p:cBhvr>
-                                        <p:cTn id="6" dur="10557" fill="hold"/>
-                                        <p:tgtEl>
-                                          <p:spTgt spid="26"/>
-                                        </p:tgtEl>
-                                        <p:attrNameLst>
-                                          <p:attrName>ppt_x</p:attrName>
-                                          <p:attrName>ppt_y</p:attrName>
-                                        </p:attrNameLst>
-                                      </p:cBhvr>
-                                      <p:rCtr x="0" y="0"/>
-                                    </p:animMotion>
-                                  </p:childTnLst>
-                                </p:cTn>
-                              </p:par>
-                              <p:par>
-                                <p:cTn id="7" presetID="0" presetClass="path" presetSubtype="0" repeatCount="indefinite" accel="0" decel="0" fill="hold" nodeType="withEffect">
-                                  <p:stCondLst>
-                                    <p:cond delay="55"/>
-                                  </p:stCondLst>
-                                  <p:childTnLst>
-                                    <p:animMotion origin="layout" path="M 0 0 L 0.90997 0 L 0.90997 0.49907 L 0 0.49907 L 0 0 E" pathEditMode="relative" rAng="0" ptsTypes="AAAAA">
-                                      <p:cBhvr>
-                                        <p:cTn id="8" dur="10557" fill="hold"/>
-                                        <p:tgtEl>
-                                          <p:spTgt spid="27"/>
-                                        </p:tgtEl>
-                                        <p:attrNameLst>
-                                          <p:attrName>ppt_x</p:attrName>
-                                          <p:attrName>ppt_y</p:attrName>
-                                        </p:attrNameLst>
-                                      </p:cBhvr>
-                                      <p:rCtr x="0" y="0"/>
-                                    </p:animMotion>
-                                  </p:childTnLst>
-                                </p:cTn>
-                              </p:par>
-                              <p:par>
-                                <p:cTn id="9" presetID="0" presetClass="path" presetSubtype="0" repeatCount="indefinite" accel="0" decel="0" fill="hold" nodeType="withEffect">
-                                  <p:stCondLst>
-                                    <p:cond delay="110"/>
-                                  </p:stCondLst>
-                                  <p:childTnLst>
-                                    <p:animMotion origin="layout" path="M 0 0 L 0.90997 0 L 0.90997 0.49907 L 0 0.49907 L 0 0 E" pathEditMode="relative" rAng="0" ptsTypes="AAAAA">
-                                      <p:cBhvr>
-                                        <p:cTn id="10" dur="10557" fill="hold"/>
-                                        <p:tgtEl>
-                                          <p:spTgt spid="28"/>
-                                        </p:tgtEl>
-                                        <p:attrNameLst>
-                                          <p:attrName>ppt_x</p:attrName>
-                                          <p:attrName>ppt_y</p:attrName>
-                                        </p:attrNameLst>
-                                      </p:cBhvr>
-                                      <p:rCtr x="0" y="0"/>
-                                    </p:animMotion>
-                                  </p:childTnLst>
-                                </p:cTn>
-                              </p:par>
-                              <p:par>
-                                <p:cTn id="11" presetID="0" presetClass="path" presetSubtype="0" repeatCount="indefinite" accel="0" decel="0" fill="hold" nodeType="withEffect">
-                                  <p:stCondLst>
-                                    <p:cond delay="165"/>
-                                  </p:stCondLst>
-                                  <p:childTnLst>
-                                    <p:animMotion origin="layout" path="M 0 0 L 0.90997 0 L 0.90997 0.49907 L 0 0.49907 L 0 0 E" pathEditMode="relative" rAng="0" ptsTypes="AAAAA">
-                                      <p:cBhvr>
-                                        <p:cTn id="12" dur="10557" fill="hold"/>
-                                        <p:tgtEl>
-                                          <p:spTgt spid="29"/>
-                                        </p:tgtEl>
-                                        <p:attrNameLst>
-                                          <p:attrName>ppt_x</p:attrName>
-                                          <p:attrName>ppt_y</p:attrName>
-                                        </p:attrNameLst>
-                                      </p:cBhvr>
-                                      <p:rCtr x="0" y="0"/>
-                                    </p:animMotion>
-                                  </p:childTnLst>
-                                </p:cTn>
-                              </p:par>
-                              <p:par>
-                                <p:cTn id="13" presetID="0" presetClass="path" presetSubtype="0" repeatCount="indefinite" accel="0" decel="0" fill="hold" nodeType="withEffect">
-                                  <p:stCondLst>
-                                    <p:cond delay="220"/>
-                                  </p:stCondLst>
-                                  <p:childTnLst>
-                                    <p:animMotion origin="layout" path="M 0 0 L 0.90997 0 L 0.90997 0.49907 L 0 0.49907 L 0 0 E" pathEditMode="relative" rAng="0" ptsTypes="AAAAA">
-                                      <p:cBhvr>
-                                        <p:cTn id="14" dur="10557" fill="hold"/>
-                                        <p:tgtEl>
-                                          <p:spTgt spid="30"/>
-                                        </p:tgtEl>
-                                        <p:attrNameLst>
-                                          <p:attrName>ppt_x</p:attrName>
-                                          <p:attrName>ppt_y</p:attrName>
-                                        </p:attrNameLst>
-                                      </p:cBhvr>
-                                      <p:rCtr x="0" y="0"/>
-                                    </p:animMotion>
-                                  </p:childTnLst>
-                                </p:cTn>
-                              </p:par>
-                              <p:par>
-                                <p:cTn id="15" presetID="0" presetClass="path" presetSubtype="0" repeatCount="indefinite" accel="0" decel="0" fill="hold" nodeType="withEffect">
-                                  <p:stCondLst>
-                                    <p:cond delay="275"/>
-                                  </p:stCondLst>
-                                  <p:childTnLst>
-                                    <p:animMotion origin="layout" path="M 0 0 L 0.90997 0 L 0.90997 0.49907 L 0 0.49907 L 0 0 E" pathEditMode="relative" rAng="0" ptsTypes="AAAAA">
-                                      <p:cBhvr>
-                                        <p:cTn id="16" dur="10557" fill="hold"/>
-                                        <p:tgtEl>
-                                          <p:spTgt spid="31"/>
-                                        </p:tgtEl>
-                                        <p:attrNameLst>
-                                          <p:attrName>ppt_x</p:attrName>
-                                          <p:attrName>ppt_y</p:attrName>
-                                        </p:attrNameLst>
-                                      </p:cBhvr>
-                                      <p:rCtr x="0" y="0"/>
-                                    </p:animMotion>
-                                  </p:childTnLst>
-                                </p:cTn>
-                              </p:par>
-                              <p:par>
-                                <p:cTn id="17" presetID="0" presetClass="path" presetSubtype="0" repeatCount="indefinite" accel="0" decel="0" fill="hold" nodeType="withEffect">
-                                  <p:stCondLst>
-                                    <p:cond delay="330"/>
-                                  </p:stCondLst>
-                                  <p:childTnLst>
-                                    <p:animMotion origin="layout" path="M 0 0 L 0.90997 0 L 0.90997 0.49907 L 0 0.49907 L 0 0 E" pathEditMode="relative" rAng="0" ptsTypes="AAAAA">
-                                      <p:cBhvr>
-                                        <p:cTn id="18" dur="10557" fill="hold"/>
-                                        <p:tgtEl>
-                                          <p:spTgt spid="32"/>
-                                        </p:tgtEl>
-                                        <p:attrNameLst>
-                                          <p:attrName>ppt_x</p:attrName>
-                                          <p:attrName>ppt_y</p:attrName>
-                                        </p:attrNameLst>
-                                      </p:cBhvr>
-                                      <p:rCtr x="0" y="0"/>
-                                    </p:animMotion>
-                                  </p:childTnLst>
-                                </p:cTn>
-                              </p:par>
-                              <p:par>
-                                <p:cTn id="19" presetID="0" presetClass="path" presetSubtype="0" repeatCount="indefinite" accel="0" decel="0" fill="hold" nodeType="withEffect">
-                                  <p:stCondLst>
-                                    <p:cond delay="385"/>
-                                  </p:stCondLst>
-                                  <p:childTnLst>
-                                    <p:animMotion origin="layout" path="M 0 0 L 0.90997 0 L 0.90997 0.49907 L 0 0.49907 L 0 0 E" pathEditMode="relative" rAng="0" ptsTypes="AAAAA">
-                                      <p:cBhvr>
-                                        <p:cTn id="20" dur="10557" fill="hold"/>
-                                        <p:tgtEl>
-                                          <p:spTgt spid="33"/>
-                                        </p:tgtEl>
-                                        <p:attrNameLst>
-                                          <p:attrName>ppt_x</p:attrName>
-                                          <p:attrName>ppt_y</p:attrName>
-                                        </p:attrNameLst>
-                                      </p:cBhvr>
-                                      <p:rCtr x="0" y="0"/>
-                                    </p:animMotion>
-                                  </p:childTnLst>
-                                </p:cTn>
-                              </p:par>
-                              <p:par>
-                                <p:cTn id="21" presetID="0" presetClass="path" presetSubtype="0" repeatCount="indefinite" accel="0" decel="0" fill="hold" nodeType="withEffect">
-                                  <p:stCondLst>
-                                    <p:cond delay="0"/>
-                                  </p:stCondLst>
-                                  <p:childTnLst>
-                                    <p:animMotion origin="layout" path="M 0 0 L -0.90997 0 L -0.90997 -0.49907 L 0 -0.49907 L 0 0 E" pathEditMode="relative" rAng="0" ptsTypes="AAAAA">
-                                      <p:cBhvr>
-                                        <p:cTn id="22" dur="10557" fill="hold"/>
-                                        <p:tgtEl>
-                                          <p:spTgt spid="34"/>
-                                        </p:tgtEl>
-                                        <p:attrNameLst>
-                                          <p:attrName>ppt_x</p:attrName>
-                                          <p:attrName>ppt_y</p:attrName>
-                                        </p:attrNameLst>
-                                      </p:cBhvr>
-                                      <p:rCtr x="0" y="0"/>
-                                    </p:animMotion>
-                                  </p:childTnLst>
-                                </p:cTn>
-                              </p:par>
-                              <p:par>
-                                <p:cTn id="23" presetID="0" presetClass="path" presetSubtype="0" repeatCount="indefinite" accel="0" decel="0" fill="hold" nodeType="withEffect">
-                                  <p:stCondLst>
-                                    <p:cond delay="55"/>
-                                  </p:stCondLst>
-                                  <p:childTnLst>
-                                    <p:animMotion origin="layout" path="M 0 0 L -0.90997 0 L -0.90997 -0.49907 L 0 -0.49907 L 0 0 E" pathEditMode="relative" rAng="0" ptsTypes="AAAAA">
-                                      <p:cBhvr>
-                                        <p:cTn id="24" dur="10557" fill="hold"/>
-                                        <p:tgtEl>
-                                          <p:spTgt spid="35"/>
-                                        </p:tgtEl>
-                                        <p:attrNameLst>
-                                          <p:attrName>ppt_x</p:attrName>
-                                          <p:attrName>ppt_y</p:attrName>
-                                        </p:attrNameLst>
-                                      </p:cBhvr>
-                                      <p:rCtr x="0" y="0"/>
-                                    </p:animMotion>
-                                  </p:childTnLst>
-                                </p:cTn>
-                              </p:par>
-                              <p:par>
-                                <p:cTn id="25" presetID="0" presetClass="path" presetSubtype="0" repeatCount="indefinite" accel="0" decel="0" fill="hold" nodeType="withEffect">
-                                  <p:stCondLst>
-                                    <p:cond delay="110"/>
-                                  </p:stCondLst>
-                                  <p:childTnLst>
-                                    <p:animMotion origin="layout" path="M 0 0 L -0.90997 0 L -0.90997 -0.49907 L 0 -0.49907 L 0 0 E" pathEditMode="relative" rAng="0" ptsTypes="AAAAA">
-                                      <p:cBhvr>
-                                        <p:cTn id="26" dur="10557" fill="hold"/>
-                                        <p:tgtEl>
-                                          <p:spTgt spid="36"/>
-                                        </p:tgtEl>
-                                        <p:attrNameLst>
-                                          <p:attrName>ppt_x</p:attrName>
-                                          <p:attrName>ppt_y</p:attrName>
-                                        </p:attrNameLst>
-                                      </p:cBhvr>
-                                      <p:rCtr x="0" y="0"/>
-                                    </p:animMotion>
-                                  </p:childTnLst>
-                                </p:cTn>
-                              </p:par>
-                              <p:par>
-                                <p:cTn id="27" presetID="0" presetClass="path" presetSubtype="0" repeatCount="indefinite" accel="0" decel="0" fill="hold" nodeType="withEffect">
-                                  <p:stCondLst>
-                                    <p:cond delay="165"/>
-                                  </p:stCondLst>
-                                  <p:childTnLst>
-                                    <p:animMotion origin="layout" path="M 0 0 L -0.90997 0 L -0.90997 -0.49907 L 0 -0.49907 L 0 0 E" pathEditMode="relative" rAng="0" ptsTypes="AAAAA">
-                                      <p:cBhvr>
-                                        <p:cTn id="28" dur="10557" fill="hold"/>
-                                        <p:tgtEl>
-                                          <p:spTgt spid="37"/>
-                                        </p:tgtEl>
-                                        <p:attrNameLst>
-                                          <p:attrName>ppt_x</p:attrName>
-                                          <p:attrName>ppt_y</p:attrName>
-                                        </p:attrNameLst>
-                                      </p:cBhvr>
-                                      <p:rCtr x="0" y="0"/>
-                                    </p:animMotion>
-                                  </p:childTnLst>
-                                </p:cTn>
-                              </p:par>
-                              <p:par>
-                                <p:cTn id="29" presetID="0" presetClass="path" presetSubtype="0" repeatCount="indefinite" accel="0" decel="0" fill="hold" nodeType="withEffect">
-                                  <p:stCondLst>
-                                    <p:cond delay="220"/>
-                                  </p:stCondLst>
-                                  <p:childTnLst>
-                                    <p:animMotion origin="layout" path="M 0 0 L -0.90997 0 L -0.90997 -0.49907 L 0 -0.49907 L 0 0 E" pathEditMode="relative" rAng="0" ptsTypes="AAAAA">
-                                      <p:cBhvr>
-                                        <p:cTn id="30" dur="10557" fill="hold"/>
-                                        <p:tgtEl>
-                                          <p:spTgt spid="38"/>
-                                        </p:tgtEl>
-                                        <p:attrNameLst>
-                                          <p:attrName>ppt_x</p:attrName>
-                                          <p:attrName>ppt_y</p:attrName>
-                                        </p:attrNameLst>
-                                      </p:cBhvr>
-                                      <p:rCtr x="0" y="0"/>
-                                    </p:animMotion>
-                                  </p:childTnLst>
-                                </p:cTn>
-                              </p:par>
-                              <p:par>
-                                <p:cTn id="31" presetID="0" presetClass="path" presetSubtype="0" repeatCount="indefinite" accel="0" decel="0" fill="hold" nodeType="withEffect">
-                                  <p:stCondLst>
-                                    <p:cond delay="275"/>
-                                  </p:stCondLst>
-                                  <p:childTnLst>
-                                    <p:animMotion origin="layout" path="M 0 0 L -0.90997 0 L -0.90997 -0.49907 L 0 -0.49907 L 0 0 E" pathEditMode="relative" rAng="0" ptsTypes="AAAAA">
-                                      <p:cBhvr>
-                                        <p:cTn id="32" dur="10557" fill="hold"/>
-                                        <p:tgtEl>
-                                          <p:spTgt spid="39"/>
-                                        </p:tgtEl>
-                                        <p:attrNameLst>
-                                          <p:attrName>ppt_x</p:attrName>
-                                          <p:attrName>ppt_y</p:attrName>
-                                        </p:attrNameLst>
-                                      </p:cBhvr>
-                                      <p:rCtr x="0" y="0"/>
-                                    </p:animMotion>
-                                  </p:childTnLst>
-                                </p:cTn>
-                              </p:par>
-                              <p:par>
-                                <p:cTn id="33" presetID="0" presetClass="path" presetSubtype="0" repeatCount="indefinite" accel="0" decel="0" fill="hold" nodeType="withEffect">
-                                  <p:stCondLst>
-                                    <p:cond delay="330"/>
-                                  </p:stCondLst>
-                                  <p:childTnLst>
-                                    <p:animMotion origin="layout" path="M 0 0 L -0.90997 0 L -0.90997 -0.49907 L 0 -0.49907 L 0 0 E" pathEditMode="relative" rAng="0" ptsTypes="AAAAA">
-                                      <p:cBhvr>
-                                        <p:cTn id="34" dur="10557" fill="hold"/>
-                                        <p:tgtEl>
-                                          <p:spTgt spid="40"/>
-                                        </p:tgtEl>
-                                        <p:attrNameLst>
-                                          <p:attrName>ppt_x</p:attrName>
-                                          <p:attrName>ppt_y</p:attrName>
-                                        </p:attrNameLst>
-                                      </p:cBhvr>
-                                      <p:rCtr x="0" y="0"/>
-                                    </p:animMotion>
-                                  </p:childTnLst>
-                                </p:cTn>
-                              </p:par>
-                              <p:par>
-                                <p:cTn id="35" presetID="0" presetClass="path" presetSubtype="0" repeatCount="indefinite" accel="0" decel="0" fill="hold" nodeType="withEffect">
-                                  <p:stCondLst>
-                                    <p:cond delay="385"/>
-                                  </p:stCondLst>
-                                  <p:childTnLst>
-                                    <p:animMotion origin="layout" path="M 0 0 L -0.90997 0 L -0.90997 -0.49907 L 0 -0.49907 L 0 0 E" pathEditMode="relative" rAng="0" ptsTypes="AAAAA">
-                                      <p:cBhvr>
-                                        <p:cTn id="36" dur="10557" fill="hold"/>
-                                        <p:tgtEl>
-                                          <p:spTgt spid="41"/>
-                                        </p:tgtEl>
-                                        <p:attrNameLst>
-                                          <p:attrName>ppt_x</p:attrName>
-                                          <p:attrName>ppt_y</p:attrName>
-                                        </p:attrNameLst>
-                                      </p:cBhvr>
-                                      <p:rCtr x="0" y="0"/>
-                                    </p:animMotion>
-                                  </p:childTnLst>
-                                </p:cTn>
-                              </p:par>
-                            </p:childTnLst>
-                          </p:cTn>
-                        </p:par>
-                      </p:childTnLst>
-                    </p:cTn>
-                  </p:par>
-                </p:childTnLst>
-              </p:cTn>
-              <p:prevCondLst>
-                <p:cond evt="onPrev" delay="0">
-                  <p:tgtEl>
-                    <p:sldTgt/>
-                  </p:tgtEl>
-                </p:cond>
-              </p:prevCondLst>
-              <p:nextCondLst>
-                <p:cond evt="onNext" delay="0">
-                  <p:tgtEl>
-                    <p:sldTgt/>
-                  </p:tgtEl>
-                </p:cond>
-              </p:nextCondLst>
-            </p:seq>
-          </p:childTnLst>
-        </p:cTn>
-      </p:par>
-    </p:tnLst>
-  </p:timing>
 </p:sld>
 </file>
 
@@ -9626,502 +6929,6 @@
       </p:sp>
       <p:sp>
         <p:nvSpPr>
-          <p:cNvPr id="51" name="Світло рамки 2.8"/>
-          <p:cNvSpPr/>
-          <p:nvPr/>
-        </p:nvSpPr>
-        <p:spPr>
-          <a:xfrm>
-            <a:off x="11624767" y="6108192"/>
-            <a:ext cx="36576" cy="36576"/>
-          </a:xfrm>
-          <a:prstGeom prst="ellipse">
-            <a:avLst/>
-          </a:prstGeom>
-          <a:solidFill>
-            <a:srgbClr val="58F268">
-              <a:alpha val="20000"/>
-            </a:srgbClr>
-          </a:solidFill>
-          <a:ln>
-            <a:noFill/>
-          </a:ln>
-          <a:effectLst>
-            <a:glow rad="63500">
-              <a:srgbClr val="58F268">
-                <a:alpha val="12000"/>
-              </a:srgbClr>
-            </a:glow>
-          </a:effectLst>
-        </p:spPr>
-      </p:sp>
-      <p:sp>
-        <p:nvSpPr>
-          <p:cNvPr id="50" name="Світло рамки 2.7"/>
-          <p:cNvSpPr/>
-          <p:nvPr/>
-        </p:nvSpPr>
-        <p:spPr>
-          <a:xfrm>
-            <a:off x="11618889" y="6102314"/>
-            <a:ext cx="48332" cy="48332"/>
-          </a:xfrm>
-          <a:prstGeom prst="ellipse">
-            <a:avLst/>
-          </a:prstGeom>
-          <a:solidFill>
-            <a:srgbClr val="58F268">
-              <a:alpha val="31428"/>
-            </a:srgbClr>
-          </a:solidFill>
-          <a:ln>
-            <a:noFill/>
-          </a:ln>
-          <a:effectLst>
-            <a:glow rad="63500">
-              <a:srgbClr val="58F268">
-                <a:alpha val="18856"/>
-              </a:srgbClr>
-            </a:glow>
-          </a:effectLst>
-        </p:spPr>
-      </p:sp>
-      <p:sp>
-        <p:nvSpPr>
-          <p:cNvPr id="49" name="Світло рамки 2.6"/>
-          <p:cNvSpPr/>
-          <p:nvPr/>
-        </p:nvSpPr>
-        <p:spPr>
-          <a:xfrm>
-            <a:off x="11613011" y="6096436"/>
-            <a:ext cx="60089" cy="60089"/>
-          </a:xfrm>
-          <a:prstGeom prst="ellipse">
-            <a:avLst/>
-          </a:prstGeom>
-          <a:solidFill>
-            <a:srgbClr val="58F268">
-              <a:alpha val="42857"/>
-            </a:srgbClr>
-          </a:solidFill>
-          <a:ln>
-            <a:noFill/>
-          </a:ln>
-          <a:effectLst>
-            <a:glow rad="63500">
-              <a:srgbClr val="58F268">
-                <a:alpha val="25714"/>
-              </a:srgbClr>
-            </a:glow>
-          </a:effectLst>
-        </p:spPr>
-      </p:sp>
-      <p:sp>
-        <p:nvSpPr>
-          <p:cNvPr id="48" name="Світло рамки 2.5"/>
-          <p:cNvSpPr/>
-          <p:nvPr/>
-        </p:nvSpPr>
-        <p:spPr>
-          <a:xfrm>
-            <a:off x="11607133" y="6090558"/>
-            <a:ext cx="71845" cy="71845"/>
-          </a:xfrm>
-          <a:prstGeom prst="ellipse">
-            <a:avLst/>
-          </a:prstGeom>
-          <a:solidFill>
-            <a:srgbClr val="58F268">
-              <a:alpha val="54285"/>
-            </a:srgbClr>
-          </a:solidFill>
-          <a:ln>
-            <a:noFill/>
-          </a:ln>
-          <a:effectLst>
-            <a:glow rad="63500">
-              <a:srgbClr val="58F268">
-                <a:alpha val="32571"/>
-              </a:srgbClr>
-            </a:glow>
-          </a:effectLst>
-        </p:spPr>
-      </p:sp>
-      <p:sp>
-        <p:nvSpPr>
-          <p:cNvPr id="47" name="Світло рамки 2.4"/>
-          <p:cNvSpPr/>
-          <p:nvPr/>
-        </p:nvSpPr>
-        <p:spPr>
-          <a:xfrm>
-            <a:off x="11601254" y="6084679"/>
-            <a:ext cx="83602" cy="83602"/>
-          </a:xfrm>
-          <a:prstGeom prst="ellipse">
-            <a:avLst/>
-          </a:prstGeom>
-          <a:solidFill>
-            <a:srgbClr val="58F268">
-              <a:alpha val="65714"/>
-            </a:srgbClr>
-          </a:solidFill>
-          <a:ln>
-            <a:noFill/>
-          </a:ln>
-          <a:effectLst>
-            <a:glow rad="63500">
-              <a:srgbClr val="58F268">
-                <a:alpha val="39428"/>
-              </a:srgbClr>
-            </a:glow>
-          </a:effectLst>
-        </p:spPr>
-      </p:sp>
-      <p:sp>
-        <p:nvSpPr>
-          <p:cNvPr id="46" name="Світло рамки 2.3"/>
-          <p:cNvSpPr/>
-          <p:nvPr/>
-        </p:nvSpPr>
-        <p:spPr>
-          <a:xfrm>
-            <a:off x="11595376" y="6078801"/>
-            <a:ext cx="95358" cy="95358"/>
-          </a:xfrm>
-          <a:prstGeom prst="ellipse">
-            <a:avLst/>
-          </a:prstGeom>
-          <a:solidFill>
-            <a:srgbClr val="58F268">
-              <a:alpha val="77142"/>
-            </a:srgbClr>
-          </a:solidFill>
-          <a:ln>
-            <a:noFill/>
-          </a:ln>
-          <a:effectLst>
-            <a:glow rad="63500">
-              <a:srgbClr val="58F268">
-                <a:alpha val="46285"/>
-              </a:srgbClr>
-            </a:glow>
-          </a:effectLst>
-        </p:spPr>
-      </p:sp>
-      <p:sp>
-        <p:nvSpPr>
-          <p:cNvPr id="45" name="Світло рамки 2.2"/>
-          <p:cNvSpPr/>
-          <p:nvPr/>
-        </p:nvSpPr>
-        <p:spPr>
-          <a:xfrm>
-            <a:off x="11589498" y="6072923"/>
-            <a:ext cx="107115" cy="107115"/>
-          </a:xfrm>
-          <a:prstGeom prst="ellipse">
-            <a:avLst/>
-          </a:prstGeom>
-          <a:solidFill>
-            <a:srgbClr val="58F268">
-              <a:alpha val="88571"/>
-            </a:srgbClr>
-          </a:solidFill>
-          <a:ln>
-            <a:noFill/>
-          </a:ln>
-          <a:effectLst>
-            <a:glow rad="63500">
-              <a:srgbClr val="58F268">
-                <a:alpha val="53142"/>
-              </a:srgbClr>
-            </a:glow>
-          </a:effectLst>
-        </p:spPr>
-      </p:sp>
-      <p:sp>
-        <p:nvSpPr>
-          <p:cNvPr id="44" name="Світло рамки 2.1"/>
-          <p:cNvSpPr/>
-          <p:nvPr/>
-        </p:nvSpPr>
-        <p:spPr>
-          <a:xfrm>
-            <a:off x="11583619" y="6067044"/>
-            <a:ext cx="118872" cy="118872"/>
-          </a:xfrm>
-          <a:prstGeom prst="ellipse">
-            <a:avLst/>
-          </a:prstGeom>
-          <a:solidFill>
-            <a:srgbClr val="F2FFF3">
-              <a:alpha val="100000"/>
-            </a:srgbClr>
-          </a:solidFill>
-          <a:ln>
-            <a:noFill/>
-          </a:ln>
-          <a:effectLst>
-            <a:glow rad="101600">
-              <a:srgbClr val="58F268">
-                <a:alpha val="60000"/>
-              </a:srgbClr>
-            </a:glow>
-          </a:effectLst>
-        </p:spPr>
-      </p:sp>
-      <p:sp>
-        <p:nvSpPr>
-          <p:cNvPr id="43" name="Світло рамки 1.8"/>
-          <p:cNvSpPr/>
-          <p:nvPr/>
-        </p:nvSpPr>
-        <p:spPr>
-          <a:xfrm>
-            <a:off x="7281367" y="1764792"/>
-            <a:ext cx="36576" cy="36576"/>
-          </a:xfrm>
-          <a:prstGeom prst="ellipse">
-            <a:avLst/>
-          </a:prstGeom>
-          <a:solidFill>
-            <a:srgbClr val="58F268">
-              <a:alpha val="20000"/>
-            </a:srgbClr>
-          </a:solidFill>
-          <a:ln>
-            <a:noFill/>
-          </a:ln>
-          <a:effectLst>
-            <a:glow rad="63500">
-              <a:srgbClr val="58F268">
-                <a:alpha val="12000"/>
-              </a:srgbClr>
-            </a:glow>
-          </a:effectLst>
-        </p:spPr>
-      </p:sp>
-      <p:sp>
-        <p:nvSpPr>
-          <p:cNvPr id="42" name="Світло рамки 1.7"/>
-          <p:cNvSpPr/>
-          <p:nvPr/>
-        </p:nvSpPr>
-        <p:spPr>
-          <a:xfrm>
-            <a:off x="7275489" y="1758914"/>
-            <a:ext cx="48332" cy="48332"/>
-          </a:xfrm>
-          <a:prstGeom prst="ellipse">
-            <a:avLst/>
-          </a:prstGeom>
-          <a:solidFill>
-            <a:srgbClr val="58F268">
-              <a:alpha val="31428"/>
-            </a:srgbClr>
-          </a:solidFill>
-          <a:ln>
-            <a:noFill/>
-          </a:ln>
-          <a:effectLst>
-            <a:glow rad="63500">
-              <a:srgbClr val="58F268">
-                <a:alpha val="18856"/>
-              </a:srgbClr>
-            </a:glow>
-          </a:effectLst>
-        </p:spPr>
-      </p:sp>
-      <p:sp>
-        <p:nvSpPr>
-          <p:cNvPr id="41" name="Світло рамки 1.6"/>
-          <p:cNvSpPr/>
-          <p:nvPr/>
-        </p:nvSpPr>
-        <p:spPr>
-          <a:xfrm>
-            <a:off x="7269611" y="1753036"/>
-            <a:ext cx="60089" cy="60089"/>
-          </a:xfrm>
-          <a:prstGeom prst="ellipse">
-            <a:avLst/>
-          </a:prstGeom>
-          <a:solidFill>
-            <a:srgbClr val="58F268">
-              <a:alpha val="42857"/>
-            </a:srgbClr>
-          </a:solidFill>
-          <a:ln>
-            <a:noFill/>
-          </a:ln>
-          <a:effectLst>
-            <a:glow rad="63500">
-              <a:srgbClr val="58F268">
-                <a:alpha val="25714"/>
-              </a:srgbClr>
-            </a:glow>
-          </a:effectLst>
-        </p:spPr>
-      </p:sp>
-      <p:sp>
-        <p:nvSpPr>
-          <p:cNvPr id="40" name="Світло рамки 1.5"/>
-          <p:cNvSpPr/>
-          <p:nvPr/>
-        </p:nvSpPr>
-        <p:spPr>
-          <a:xfrm>
-            <a:off x="7263733" y="1747158"/>
-            <a:ext cx="71845" cy="71845"/>
-          </a:xfrm>
-          <a:prstGeom prst="ellipse">
-            <a:avLst/>
-          </a:prstGeom>
-          <a:solidFill>
-            <a:srgbClr val="58F268">
-              <a:alpha val="54285"/>
-            </a:srgbClr>
-          </a:solidFill>
-          <a:ln>
-            <a:noFill/>
-          </a:ln>
-          <a:effectLst>
-            <a:glow rad="63500">
-              <a:srgbClr val="58F268">
-                <a:alpha val="32571"/>
-              </a:srgbClr>
-            </a:glow>
-          </a:effectLst>
-        </p:spPr>
-      </p:sp>
-      <p:sp>
-        <p:nvSpPr>
-          <p:cNvPr id="39" name="Світло рамки 1.4"/>
-          <p:cNvSpPr/>
-          <p:nvPr/>
-        </p:nvSpPr>
-        <p:spPr>
-          <a:xfrm>
-            <a:off x="7257854" y="1741279"/>
-            <a:ext cx="83602" cy="83602"/>
-          </a:xfrm>
-          <a:prstGeom prst="ellipse">
-            <a:avLst/>
-          </a:prstGeom>
-          <a:solidFill>
-            <a:srgbClr val="58F268">
-              <a:alpha val="65714"/>
-            </a:srgbClr>
-          </a:solidFill>
-          <a:ln>
-            <a:noFill/>
-          </a:ln>
-          <a:effectLst>
-            <a:glow rad="63500">
-              <a:srgbClr val="58F268">
-                <a:alpha val="39428"/>
-              </a:srgbClr>
-            </a:glow>
-          </a:effectLst>
-        </p:spPr>
-      </p:sp>
-      <p:sp>
-        <p:nvSpPr>
-          <p:cNvPr id="38" name="Світло рамки 1.3"/>
-          <p:cNvSpPr/>
-          <p:nvPr/>
-        </p:nvSpPr>
-        <p:spPr>
-          <a:xfrm>
-            <a:off x="7251976" y="1735401"/>
-            <a:ext cx="95358" cy="95358"/>
-          </a:xfrm>
-          <a:prstGeom prst="ellipse">
-            <a:avLst/>
-          </a:prstGeom>
-          <a:solidFill>
-            <a:srgbClr val="58F268">
-              <a:alpha val="77142"/>
-            </a:srgbClr>
-          </a:solidFill>
-          <a:ln>
-            <a:noFill/>
-          </a:ln>
-          <a:effectLst>
-            <a:glow rad="63500">
-              <a:srgbClr val="58F268">
-                <a:alpha val="46285"/>
-              </a:srgbClr>
-            </a:glow>
-          </a:effectLst>
-        </p:spPr>
-      </p:sp>
-      <p:sp>
-        <p:nvSpPr>
-          <p:cNvPr id="37" name="Світло рамки 1.2"/>
-          <p:cNvSpPr/>
-          <p:nvPr/>
-        </p:nvSpPr>
-        <p:spPr>
-          <a:xfrm>
-            <a:off x="7246098" y="1729523"/>
-            <a:ext cx="107115" cy="107115"/>
-          </a:xfrm>
-          <a:prstGeom prst="ellipse">
-            <a:avLst/>
-          </a:prstGeom>
-          <a:solidFill>
-            <a:srgbClr val="58F268">
-              <a:alpha val="88571"/>
-            </a:srgbClr>
-          </a:solidFill>
-          <a:ln>
-            <a:noFill/>
-          </a:ln>
-          <a:effectLst>
-            <a:glow rad="63500">
-              <a:srgbClr val="58F268">
-                <a:alpha val="53142"/>
-              </a:srgbClr>
-            </a:glow>
-          </a:effectLst>
-        </p:spPr>
-      </p:sp>
-      <p:sp>
-        <p:nvSpPr>
-          <p:cNvPr id="36" name="Світло рамки 1.1"/>
-          <p:cNvSpPr/>
-          <p:nvPr/>
-        </p:nvSpPr>
-        <p:spPr>
-          <a:xfrm>
-            <a:off x="7240219" y="1723644"/>
-            <a:ext cx="118872" cy="118872"/>
-          </a:xfrm>
-          <a:prstGeom prst="ellipse">
-            <a:avLst/>
-          </a:prstGeom>
-          <a:solidFill>
-            <a:srgbClr val="F2FFF3">
-              <a:alpha val="100000"/>
-            </a:srgbClr>
-          </a:solidFill>
-          <a:ln>
-            <a:noFill/>
-          </a:ln>
-          <a:effectLst>
-            <a:glow rad="101600">
-              <a:srgbClr val="58F268">
-                <a:alpha val="60000"/>
-              </a:srgbClr>
-            </a:glow>
-          </a:effectLst>
-        </p:spPr>
-      </p:sp>
-      <p:sp>
-        <p:nvSpPr>
           <p:cNvPr id="6" name="Кути коміксу 04 кут 1"/>
           <p:cNvSpPr/>
           <p:nvPr/>
@@ -11208,409 +8015,6 @@
   <p:clrMapOvr>
     <a:masterClrMapping/>
   </p:clrMapOvr>
-  <p:timing>
-    <p:tnLst>
-      <p:par>
-        <p:cTn id="1" dur="indefinite" restart="never" nodeType="tmRoot">
-          <p:childTnLst>
-            <p:seq concurrent="1" nextAc="seek">
-              <p:cTn id="2" dur="indefinite" nodeType="mainSeq">
-                <p:childTnLst>
-                  <p:par>
-                    <p:cTn id="3" fill="hold">
-                      <p:stCondLst>
-                        <p:cond delay="indefinite"/>
-                        <p:cond evt="onBegin" delay="0">
-                          <p:tn val="2"/>
-                        </p:cond>
-                      </p:stCondLst>
-                      <p:childTnLst>
-                        <p:par>
-                          <p:cTn id="4" fill="hold">
-                            <p:stCondLst>
-                              <p:cond delay="0"/>
-                            </p:stCondLst>
-                            <p:childTnLst>
-                              <p:par>
-                                <p:cTn id="5" presetID="0" presetClass="path" presetSubtype="0" repeatCount="indefinite" accel="0" decel="0" fill="hold" nodeType="withEffect">
-                                  <p:stCondLst>
-                                    <p:cond delay="0"/>
-                                  </p:stCondLst>
-                                  <p:childTnLst>
-                                    <p:animMotion origin="layout" path="M 0 0 L 0.35625 0 L 0.35625 0.63333 L 0 0.63333 L 0 0 E" pathEditMode="relative" rAng="0" ptsTypes="AAAAA">
-                                      <p:cBhvr>
-                                        <p:cTn id="6" dur="6317" fill="hold"/>
-                                        <p:tgtEl>
-                                          <p:spTgt spid="36"/>
-                                        </p:tgtEl>
-                                        <p:attrNameLst>
-                                          <p:attrName>ppt_x</p:attrName>
-                                          <p:attrName>ppt_y</p:attrName>
-                                        </p:attrNameLst>
-                                      </p:cBhvr>
-                                      <p:rCtr x="0" y="0"/>
-                                    </p:animMotion>
-                                  </p:childTnLst>
-                                </p:cTn>
-                              </p:par>
-                              <p:par>
-                                <p:cTn id="7" presetID="0" presetClass="path" presetSubtype="0" repeatCount="indefinite" accel="0" decel="0" fill="hold" nodeType="withEffect">
-                                  <p:stCondLst>
-                                    <p:cond delay="55"/>
-                                  </p:stCondLst>
-                                  <p:childTnLst>
-                                    <p:animMotion origin="layout" path="M 0 0 L 0.35625 0 L 0.35625 0.63333 L 0 0.63333 L 0 0 E" pathEditMode="relative" rAng="0" ptsTypes="AAAAA">
-                                      <p:cBhvr>
-                                        <p:cTn id="8" dur="6317" fill="hold"/>
-                                        <p:tgtEl>
-                                          <p:spTgt spid="37"/>
-                                        </p:tgtEl>
-                                        <p:attrNameLst>
-                                          <p:attrName>ppt_x</p:attrName>
-                                          <p:attrName>ppt_y</p:attrName>
-                                        </p:attrNameLst>
-                                      </p:cBhvr>
-                                      <p:rCtr x="0" y="0"/>
-                                    </p:animMotion>
-                                  </p:childTnLst>
-                                </p:cTn>
-                              </p:par>
-                              <p:par>
-                                <p:cTn id="9" presetID="0" presetClass="path" presetSubtype="0" repeatCount="indefinite" accel="0" decel="0" fill="hold" nodeType="withEffect">
-                                  <p:stCondLst>
-                                    <p:cond delay="110"/>
-                                  </p:stCondLst>
-                                  <p:childTnLst>
-                                    <p:animMotion origin="layout" path="M 0 0 L 0.35625 0 L 0.35625 0.63333 L 0 0.63333 L 0 0 E" pathEditMode="relative" rAng="0" ptsTypes="AAAAA">
-                                      <p:cBhvr>
-                                        <p:cTn id="10" dur="6317" fill="hold"/>
-                                        <p:tgtEl>
-                                          <p:spTgt spid="38"/>
-                                        </p:tgtEl>
-                                        <p:attrNameLst>
-                                          <p:attrName>ppt_x</p:attrName>
-                                          <p:attrName>ppt_y</p:attrName>
-                                        </p:attrNameLst>
-                                      </p:cBhvr>
-                                      <p:rCtr x="0" y="0"/>
-                                    </p:animMotion>
-                                  </p:childTnLst>
-                                </p:cTn>
-                              </p:par>
-                              <p:par>
-                                <p:cTn id="11" presetID="0" presetClass="path" presetSubtype="0" repeatCount="indefinite" accel="0" decel="0" fill="hold" nodeType="withEffect">
-                                  <p:stCondLst>
-                                    <p:cond delay="165"/>
-                                  </p:stCondLst>
-                                  <p:childTnLst>
-                                    <p:animMotion origin="layout" path="M 0 0 L 0.35625 0 L 0.35625 0.63333 L 0 0.63333 L 0 0 E" pathEditMode="relative" rAng="0" ptsTypes="AAAAA">
-                                      <p:cBhvr>
-                                        <p:cTn id="12" dur="6317" fill="hold"/>
-                                        <p:tgtEl>
-                                          <p:spTgt spid="39"/>
-                                        </p:tgtEl>
-                                        <p:attrNameLst>
-                                          <p:attrName>ppt_x</p:attrName>
-                                          <p:attrName>ppt_y</p:attrName>
-                                        </p:attrNameLst>
-                                      </p:cBhvr>
-                                      <p:rCtr x="0" y="0"/>
-                                    </p:animMotion>
-                                  </p:childTnLst>
-                                </p:cTn>
-                              </p:par>
-                              <p:par>
-                                <p:cTn id="13" presetID="0" presetClass="path" presetSubtype="0" repeatCount="indefinite" accel="0" decel="0" fill="hold" nodeType="withEffect">
-                                  <p:stCondLst>
-                                    <p:cond delay="220"/>
-                                  </p:stCondLst>
-                                  <p:childTnLst>
-                                    <p:animMotion origin="layout" path="M 0 0 L 0.35625 0 L 0.35625 0.63333 L 0 0.63333 L 0 0 E" pathEditMode="relative" rAng="0" ptsTypes="AAAAA">
-                                      <p:cBhvr>
-                                        <p:cTn id="14" dur="6317" fill="hold"/>
-                                        <p:tgtEl>
-                                          <p:spTgt spid="40"/>
-                                        </p:tgtEl>
-                                        <p:attrNameLst>
-                                          <p:attrName>ppt_x</p:attrName>
-                                          <p:attrName>ppt_y</p:attrName>
-                                        </p:attrNameLst>
-                                      </p:cBhvr>
-                                      <p:rCtr x="0" y="0"/>
-                                    </p:animMotion>
-                                  </p:childTnLst>
-                                </p:cTn>
-                              </p:par>
-                              <p:par>
-                                <p:cTn id="15" presetID="0" presetClass="path" presetSubtype="0" repeatCount="indefinite" accel="0" decel="0" fill="hold" nodeType="withEffect">
-                                  <p:stCondLst>
-                                    <p:cond delay="275"/>
-                                  </p:stCondLst>
-                                  <p:childTnLst>
-                                    <p:animMotion origin="layout" path="M 0 0 L 0.35625 0 L 0.35625 0.63333 L 0 0.63333 L 0 0 E" pathEditMode="relative" rAng="0" ptsTypes="AAAAA">
-                                      <p:cBhvr>
-                                        <p:cTn id="16" dur="6317" fill="hold"/>
-                                        <p:tgtEl>
-                                          <p:spTgt spid="41"/>
-                                        </p:tgtEl>
-                                        <p:attrNameLst>
-                                          <p:attrName>ppt_x</p:attrName>
-                                          <p:attrName>ppt_y</p:attrName>
-                                        </p:attrNameLst>
-                                      </p:cBhvr>
-                                      <p:rCtr x="0" y="0"/>
-                                    </p:animMotion>
-                                  </p:childTnLst>
-                                </p:cTn>
-                              </p:par>
-                              <p:par>
-                                <p:cTn id="17" presetID="0" presetClass="path" presetSubtype="0" repeatCount="indefinite" accel="0" decel="0" fill="hold" nodeType="withEffect">
-                                  <p:stCondLst>
-                                    <p:cond delay="330"/>
-                                  </p:stCondLst>
-                                  <p:childTnLst>
-                                    <p:animMotion origin="layout" path="M 0 0 L 0.35625 0 L 0.35625 0.63333 L 0 0.63333 L 0 0 E" pathEditMode="relative" rAng="0" ptsTypes="AAAAA">
-                                      <p:cBhvr>
-                                        <p:cTn id="18" dur="6317" fill="hold"/>
-                                        <p:tgtEl>
-                                          <p:spTgt spid="42"/>
-                                        </p:tgtEl>
-                                        <p:attrNameLst>
-                                          <p:attrName>ppt_x</p:attrName>
-                                          <p:attrName>ppt_y</p:attrName>
-                                        </p:attrNameLst>
-                                      </p:cBhvr>
-                                      <p:rCtr x="0" y="0"/>
-                                    </p:animMotion>
-                                  </p:childTnLst>
-                                </p:cTn>
-                              </p:par>
-                              <p:par>
-                                <p:cTn id="19" presetID="0" presetClass="path" presetSubtype="0" repeatCount="indefinite" accel="0" decel="0" fill="hold" nodeType="withEffect">
-                                  <p:stCondLst>
-                                    <p:cond delay="385"/>
-                                  </p:stCondLst>
-                                  <p:childTnLst>
-                                    <p:animMotion origin="layout" path="M 0 0 L 0.35625 0 L 0.35625 0.63333 L 0 0.63333 L 0 0 E" pathEditMode="relative" rAng="0" ptsTypes="AAAAA">
-                                      <p:cBhvr>
-                                        <p:cTn id="20" dur="6317" fill="hold"/>
-                                        <p:tgtEl>
-                                          <p:spTgt spid="43"/>
-                                        </p:tgtEl>
-                                        <p:attrNameLst>
-                                          <p:attrName>ppt_x</p:attrName>
-                                          <p:attrName>ppt_y</p:attrName>
-                                        </p:attrNameLst>
-                                      </p:cBhvr>
-                                      <p:rCtr x="0" y="0"/>
-                                    </p:animMotion>
-                                  </p:childTnLst>
-                                </p:cTn>
-                              </p:par>
-                              <p:par>
-                                <p:cTn id="21" presetID="0" presetClass="path" presetSubtype="0" repeatCount="indefinite" accel="0" decel="0" fill="hold" nodeType="withEffect">
-                                  <p:stCondLst>
-                                    <p:cond delay="0"/>
-                                  </p:stCondLst>
-                                  <p:childTnLst>
-                                    <p:animMotion origin="layout" path="M 0 0 L -0.35625 0 L -0.35625 -0.63333 L 0 -0.63333 L 0 0 E" pathEditMode="relative" rAng="0" ptsTypes="AAAAA">
-                                      <p:cBhvr>
-                                        <p:cTn id="22" dur="6317" fill="hold"/>
-                                        <p:tgtEl>
-                                          <p:spTgt spid="44"/>
-                                        </p:tgtEl>
-                                        <p:attrNameLst>
-                                          <p:attrName>ppt_x</p:attrName>
-                                          <p:attrName>ppt_y</p:attrName>
-                                        </p:attrNameLst>
-                                      </p:cBhvr>
-                                      <p:rCtr x="0" y="0"/>
-                                    </p:animMotion>
-                                  </p:childTnLst>
-                                </p:cTn>
-                              </p:par>
-                              <p:par>
-                                <p:cTn id="23" presetID="0" presetClass="path" presetSubtype="0" repeatCount="indefinite" accel="0" decel="0" fill="hold" nodeType="withEffect">
-                                  <p:stCondLst>
-                                    <p:cond delay="55"/>
-                                  </p:stCondLst>
-                                  <p:childTnLst>
-                                    <p:animMotion origin="layout" path="M 0 0 L -0.35625 0 L -0.35625 -0.63333 L 0 -0.63333 L 0 0 E" pathEditMode="relative" rAng="0" ptsTypes="AAAAA">
-                                      <p:cBhvr>
-                                        <p:cTn id="24" dur="6317" fill="hold"/>
-                                        <p:tgtEl>
-                                          <p:spTgt spid="45"/>
-                                        </p:tgtEl>
-                                        <p:attrNameLst>
-                                          <p:attrName>ppt_x</p:attrName>
-                                          <p:attrName>ppt_y</p:attrName>
-                                        </p:attrNameLst>
-                                      </p:cBhvr>
-                                      <p:rCtr x="0" y="0"/>
-                                    </p:animMotion>
-                                  </p:childTnLst>
-                                </p:cTn>
-                              </p:par>
-                              <p:par>
-                                <p:cTn id="25" presetID="0" presetClass="path" presetSubtype="0" repeatCount="indefinite" accel="0" decel="0" fill="hold" nodeType="withEffect">
-                                  <p:stCondLst>
-                                    <p:cond delay="110"/>
-                                  </p:stCondLst>
-                                  <p:childTnLst>
-                                    <p:animMotion origin="layout" path="M 0 0 L -0.35625 0 L -0.35625 -0.63333 L 0 -0.63333 L 0 0 E" pathEditMode="relative" rAng="0" ptsTypes="AAAAA">
-                                      <p:cBhvr>
-                                        <p:cTn id="26" dur="6317" fill="hold"/>
-                                        <p:tgtEl>
-                                          <p:spTgt spid="46"/>
-                                        </p:tgtEl>
-                                        <p:attrNameLst>
-                                          <p:attrName>ppt_x</p:attrName>
-                                          <p:attrName>ppt_y</p:attrName>
-                                        </p:attrNameLst>
-                                      </p:cBhvr>
-                                      <p:rCtr x="0" y="0"/>
-                                    </p:animMotion>
-                                  </p:childTnLst>
-                                </p:cTn>
-                              </p:par>
-                              <p:par>
-                                <p:cTn id="27" presetID="0" presetClass="path" presetSubtype="0" repeatCount="indefinite" accel="0" decel="0" fill="hold" nodeType="withEffect">
-                                  <p:stCondLst>
-                                    <p:cond delay="165"/>
-                                  </p:stCondLst>
-                                  <p:childTnLst>
-                                    <p:animMotion origin="layout" path="M 0 0 L -0.35625 0 L -0.35625 -0.63333 L 0 -0.63333 L 0 0 E" pathEditMode="relative" rAng="0" ptsTypes="AAAAA">
-                                      <p:cBhvr>
-                                        <p:cTn id="28" dur="6317" fill="hold"/>
-                                        <p:tgtEl>
-                                          <p:spTgt spid="47"/>
-                                        </p:tgtEl>
-                                        <p:attrNameLst>
-                                          <p:attrName>ppt_x</p:attrName>
-                                          <p:attrName>ppt_y</p:attrName>
-                                        </p:attrNameLst>
-                                      </p:cBhvr>
-                                      <p:rCtr x="0" y="0"/>
-                                    </p:animMotion>
-                                  </p:childTnLst>
-                                </p:cTn>
-                              </p:par>
-                              <p:par>
-                                <p:cTn id="29" presetID="0" presetClass="path" presetSubtype="0" repeatCount="indefinite" accel="0" decel="0" fill="hold" nodeType="withEffect">
-                                  <p:stCondLst>
-                                    <p:cond delay="220"/>
-                                  </p:stCondLst>
-                                  <p:childTnLst>
-                                    <p:animMotion origin="layout" path="M 0 0 L -0.35625 0 L -0.35625 -0.63333 L 0 -0.63333 L 0 0 E" pathEditMode="relative" rAng="0" ptsTypes="AAAAA">
-                                      <p:cBhvr>
-                                        <p:cTn id="30" dur="6317" fill="hold"/>
-                                        <p:tgtEl>
-                                          <p:spTgt spid="48"/>
-                                        </p:tgtEl>
-                                        <p:attrNameLst>
-                                          <p:attrName>ppt_x</p:attrName>
-                                          <p:attrName>ppt_y</p:attrName>
-                                        </p:attrNameLst>
-                                      </p:cBhvr>
-                                      <p:rCtr x="0" y="0"/>
-                                    </p:animMotion>
-                                  </p:childTnLst>
-                                </p:cTn>
-                              </p:par>
-                              <p:par>
-                                <p:cTn id="31" presetID="0" presetClass="path" presetSubtype="0" repeatCount="indefinite" accel="0" decel="0" fill="hold" nodeType="withEffect">
-                                  <p:stCondLst>
-                                    <p:cond delay="275"/>
-                                  </p:stCondLst>
-                                  <p:childTnLst>
-                                    <p:animMotion origin="layout" path="M 0 0 L -0.35625 0 L -0.35625 -0.63333 L 0 -0.63333 L 0 0 E" pathEditMode="relative" rAng="0" ptsTypes="AAAAA">
-                                      <p:cBhvr>
-                                        <p:cTn id="32" dur="6317" fill="hold"/>
-                                        <p:tgtEl>
-                                          <p:spTgt spid="49"/>
-                                        </p:tgtEl>
-                                        <p:attrNameLst>
-                                          <p:attrName>ppt_x</p:attrName>
-                                          <p:attrName>ppt_y</p:attrName>
-                                        </p:attrNameLst>
-                                      </p:cBhvr>
-                                      <p:rCtr x="0" y="0"/>
-                                    </p:animMotion>
-                                  </p:childTnLst>
-                                </p:cTn>
-                              </p:par>
-                              <p:par>
-                                <p:cTn id="33" presetID="0" presetClass="path" presetSubtype="0" repeatCount="indefinite" accel="0" decel="0" fill="hold" nodeType="withEffect">
-                                  <p:stCondLst>
-                                    <p:cond delay="330"/>
-                                  </p:stCondLst>
-                                  <p:childTnLst>
-                                    <p:animMotion origin="layout" path="M 0 0 L -0.35625 0 L -0.35625 -0.63333 L 0 -0.63333 L 0 0 E" pathEditMode="relative" rAng="0" ptsTypes="AAAAA">
-                                      <p:cBhvr>
-                                        <p:cTn id="34" dur="6317" fill="hold"/>
-                                        <p:tgtEl>
-                                          <p:spTgt spid="50"/>
-                                        </p:tgtEl>
-                                        <p:attrNameLst>
-                                          <p:attrName>ppt_x</p:attrName>
-                                          <p:attrName>ppt_y</p:attrName>
-                                        </p:attrNameLst>
-                                      </p:cBhvr>
-                                      <p:rCtr x="0" y="0"/>
-                                    </p:animMotion>
-                                  </p:childTnLst>
-                                </p:cTn>
-                              </p:par>
-                              <p:par>
-                                <p:cTn id="35" presetID="0" presetClass="path" presetSubtype="0" repeatCount="indefinite" accel="0" decel="0" fill="hold" nodeType="withEffect">
-                                  <p:stCondLst>
-                                    <p:cond delay="385"/>
-                                  </p:stCondLst>
-                                  <p:childTnLst>
-                                    <p:animMotion origin="layout" path="M 0 0 L -0.35625 0 L -0.35625 -0.63333 L 0 -0.63333 L 0 0 E" pathEditMode="relative" rAng="0" ptsTypes="AAAAA">
-                                      <p:cBhvr>
-                                        <p:cTn id="36" dur="6317" fill="hold"/>
-                                        <p:tgtEl>
-                                          <p:spTgt spid="51"/>
-                                        </p:tgtEl>
-                                        <p:attrNameLst>
-                                          <p:attrName>ppt_x</p:attrName>
-                                          <p:attrName>ppt_y</p:attrName>
-                                        </p:attrNameLst>
-                                      </p:cBhvr>
-                                      <p:rCtr x="0" y="0"/>
-                                    </p:animMotion>
-                                  </p:childTnLst>
-                                </p:cTn>
-                              </p:par>
-                            </p:childTnLst>
-                          </p:cTn>
-                        </p:par>
-                      </p:childTnLst>
-                    </p:cTn>
-                  </p:par>
-                </p:childTnLst>
-              </p:cTn>
-              <p:prevCondLst>
-                <p:cond evt="onPrev" delay="0">
-                  <p:tgtEl>
-                    <p:sldTgt/>
-                  </p:tgtEl>
-                </p:cond>
-              </p:prevCondLst>
-              <p:nextCondLst>
-                <p:cond evt="onNext" delay="0">
-                  <p:tgtEl>
-                    <p:sldTgt/>
-                  </p:tgtEl>
-                </p:cond>
-              </p:nextCondLst>
-            </p:seq>
-          </p:childTnLst>
-        </p:cTn>
-      </p:par>
-    </p:tnLst>
-  </p:timing>
 </p:sld>
 </file>
 
@@ -13148,502 +9552,6 @@
       </p:sp>
       <p:sp>
         <p:nvSpPr>
-          <p:cNvPr id="44" name="Світло рамки 2.8"/>
-          <p:cNvSpPr/>
-          <p:nvPr/>
-        </p:nvSpPr>
-        <p:spPr>
-          <a:xfrm>
-            <a:off x="11624767" y="6108192"/>
-            <a:ext cx="36576" cy="36576"/>
-          </a:xfrm>
-          <a:prstGeom prst="ellipse">
-            <a:avLst/>
-          </a:prstGeom>
-          <a:solidFill>
-            <a:srgbClr val="58F268">
-              <a:alpha val="20000"/>
-            </a:srgbClr>
-          </a:solidFill>
-          <a:ln>
-            <a:noFill/>
-          </a:ln>
-          <a:effectLst>
-            <a:glow rad="63500">
-              <a:srgbClr val="58F268">
-                <a:alpha val="12000"/>
-              </a:srgbClr>
-            </a:glow>
-          </a:effectLst>
-        </p:spPr>
-      </p:sp>
-      <p:sp>
-        <p:nvSpPr>
-          <p:cNvPr id="43" name="Світло рамки 2.7"/>
-          <p:cNvSpPr/>
-          <p:nvPr/>
-        </p:nvSpPr>
-        <p:spPr>
-          <a:xfrm>
-            <a:off x="11618889" y="6102314"/>
-            <a:ext cx="48332" cy="48332"/>
-          </a:xfrm>
-          <a:prstGeom prst="ellipse">
-            <a:avLst/>
-          </a:prstGeom>
-          <a:solidFill>
-            <a:srgbClr val="58F268">
-              <a:alpha val="31428"/>
-            </a:srgbClr>
-          </a:solidFill>
-          <a:ln>
-            <a:noFill/>
-          </a:ln>
-          <a:effectLst>
-            <a:glow rad="63500">
-              <a:srgbClr val="58F268">
-                <a:alpha val="18856"/>
-              </a:srgbClr>
-            </a:glow>
-          </a:effectLst>
-        </p:spPr>
-      </p:sp>
-      <p:sp>
-        <p:nvSpPr>
-          <p:cNvPr id="42" name="Світло рамки 2.6"/>
-          <p:cNvSpPr/>
-          <p:nvPr/>
-        </p:nvSpPr>
-        <p:spPr>
-          <a:xfrm>
-            <a:off x="11613011" y="6096436"/>
-            <a:ext cx="60089" cy="60089"/>
-          </a:xfrm>
-          <a:prstGeom prst="ellipse">
-            <a:avLst/>
-          </a:prstGeom>
-          <a:solidFill>
-            <a:srgbClr val="58F268">
-              <a:alpha val="42857"/>
-            </a:srgbClr>
-          </a:solidFill>
-          <a:ln>
-            <a:noFill/>
-          </a:ln>
-          <a:effectLst>
-            <a:glow rad="63500">
-              <a:srgbClr val="58F268">
-                <a:alpha val="25714"/>
-              </a:srgbClr>
-            </a:glow>
-          </a:effectLst>
-        </p:spPr>
-      </p:sp>
-      <p:sp>
-        <p:nvSpPr>
-          <p:cNvPr id="41" name="Світло рамки 2.5"/>
-          <p:cNvSpPr/>
-          <p:nvPr/>
-        </p:nvSpPr>
-        <p:spPr>
-          <a:xfrm>
-            <a:off x="11607133" y="6090558"/>
-            <a:ext cx="71845" cy="71845"/>
-          </a:xfrm>
-          <a:prstGeom prst="ellipse">
-            <a:avLst/>
-          </a:prstGeom>
-          <a:solidFill>
-            <a:srgbClr val="58F268">
-              <a:alpha val="54285"/>
-            </a:srgbClr>
-          </a:solidFill>
-          <a:ln>
-            <a:noFill/>
-          </a:ln>
-          <a:effectLst>
-            <a:glow rad="63500">
-              <a:srgbClr val="58F268">
-                <a:alpha val="32571"/>
-              </a:srgbClr>
-            </a:glow>
-          </a:effectLst>
-        </p:spPr>
-      </p:sp>
-      <p:sp>
-        <p:nvSpPr>
-          <p:cNvPr id="40" name="Світло рамки 2.4"/>
-          <p:cNvSpPr/>
-          <p:nvPr/>
-        </p:nvSpPr>
-        <p:spPr>
-          <a:xfrm>
-            <a:off x="11601254" y="6084679"/>
-            <a:ext cx="83602" cy="83602"/>
-          </a:xfrm>
-          <a:prstGeom prst="ellipse">
-            <a:avLst/>
-          </a:prstGeom>
-          <a:solidFill>
-            <a:srgbClr val="58F268">
-              <a:alpha val="65714"/>
-            </a:srgbClr>
-          </a:solidFill>
-          <a:ln>
-            <a:noFill/>
-          </a:ln>
-          <a:effectLst>
-            <a:glow rad="63500">
-              <a:srgbClr val="58F268">
-                <a:alpha val="39428"/>
-              </a:srgbClr>
-            </a:glow>
-          </a:effectLst>
-        </p:spPr>
-      </p:sp>
-      <p:sp>
-        <p:nvSpPr>
-          <p:cNvPr id="39" name="Світло рамки 2.3"/>
-          <p:cNvSpPr/>
-          <p:nvPr/>
-        </p:nvSpPr>
-        <p:spPr>
-          <a:xfrm>
-            <a:off x="11595376" y="6078801"/>
-            <a:ext cx="95358" cy="95358"/>
-          </a:xfrm>
-          <a:prstGeom prst="ellipse">
-            <a:avLst/>
-          </a:prstGeom>
-          <a:solidFill>
-            <a:srgbClr val="58F268">
-              <a:alpha val="77142"/>
-            </a:srgbClr>
-          </a:solidFill>
-          <a:ln>
-            <a:noFill/>
-          </a:ln>
-          <a:effectLst>
-            <a:glow rad="63500">
-              <a:srgbClr val="58F268">
-                <a:alpha val="46285"/>
-              </a:srgbClr>
-            </a:glow>
-          </a:effectLst>
-        </p:spPr>
-      </p:sp>
-      <p:sp>
-        <p:nvSpPr>
-          <p:cNvPr id="38" name="Світло рамки 2.2"/>
-          <p:cNvSpPr/>
-          <p:nvPr/>
-        </p:nvSpPr>
-        <p:spPr>
-          <a:xfrm>
-            <a:off x="11589498" y="6072923"/>
-            <a:ext cx="107115" cy="107115"/>
-          </a:xfrm>
-          <a:prstGeom prst="ellipse">
-            <a:avLst/>
-          </a:prstGeom>
-          <a:solidFill>
-            <a:srgbClr val="58F268">
-              <a:alpha val="88571"/>
-            </a:srgbClr>
-          </a:solidFill>
-          <a:ln>
-            <a:noFill/>
-          </a:ln>
-          <a:effectLst>
-            <a:glow rad="63500">
-              <a:srgbClr val="58F268">
-                <a:alpha val="53142"/>
-              </a:srgbClr>
-            </a:glow>
-          </a:effectLst>
-        </p:spPr>
-      </p:sp>
-      <p:sp>
-        <p:nvSpPr>
-          <p:cNvPr id="37" name="Світло рамки 2.1"/>
-          <p:cNvSpPr/>
-          <p:nvPr/>
-        </p:nvSpPr>
-        <p:spPr>
-          <a:xfrm>
-            <a:off x="11583619" y="6067044"/>
-            <a:ext cx="118872" cy="118872"/>
-          </a:xfrm>
-          <a:prstGeom prst="ellipse">
-            <a:avLst/>
-          </a:prstGeom>
-          <a:solidFill>
-            <a:srgbClr val="F2FFF3">
-              <a:alpha val="100000"/>
-            </a:srgbClr>
-          </a:solidFill>
-          <a:ln>
-            <a:noFill/>
-          </a:ln>
-          <a:effectLst>
-            <a:glow rad="101600">
-              <a:srgbClr val="58F268">
-                <a:alpha val="60000"/>
-              </a:srgbClr>
-            </a:glow>
-          </a:effectLst>
-        </p:spPr>
-      </p:sp>
-      <p:sp>
-        <p:nvSpPr>
-          <p:cNvPr id="36" name="Світло рамки 1.8"/>
-          <p:cNvSpPr/>
-          <p:nvPr/>
-        </p:nvSpPr>
-        <p:spPr>
-          <a:xfrm>
-            <a:off x="8401507" y="1764792"/>
-            <a:ext cx="36576" cy="36576"/>
-          </a:xfrm>
-          <a:prstGeom prst="ellipse">
-            <a:avLst/>
-          </a:prstGeom>
-          <a:solidFill>
-            <a:srgbClr val="58F268">
-              <a:alpha val="20000"/>
-            </a:srgbClr>
-          </a:solidFill>
-          <a:ln>
-            <a:noFill/>
-          </a:ln>
-          <a:effectLst>
-            <a:glow rad="63500">
-              <a:srgbClr val="58F268">
-                <a:alpha val="12000"/>
-              </a:srgbClr>
-            </a:glow>
-          </a:effectLst>
-        </p:spPr>
-      </p:sp>
-      <p:sp>
-        <p:nvSpPr>
-          <p:cNvPr id="35" name="Світло рамки 1.7"/>
-          <p:cNvSpPr/>
-          <p:nvPr/>
-        </p:nvSpPr>
-        <p:spPr>
-          <a:xfrm>
-            <a:off x="8395629" y="1758914"/>
-            <a:ext cx="48332" cy="48332"/>
-          </a:xfrm>
-          <a:prstGeom prst="ellipse">
-            <a:avLst/>
-          </a:prstGeom>
-          <a:solidFill>
-            <a:srgbClr val="58F268">
-              <a:alpha val="31428"/>
-            </a:srgbClr>
-          </a:solidFill>
-          <a:ln>
-            <a:noFill/>
-          </a:ln>
-          <a:effectLst>
-            <a:glow rad="63500">
-              <a:srgbClr val="58F268">
-                <a:alpha val="18856"/>
-              </a:srgbClr>
-            </a:glow>
-          </a:effectLst>
-        </p:spPr>
-      </p:sp>
-      <p:sp>
-        <p:nvSpPr>
-          <p:cNvPr id="34" name="Світло рамки 1.6"/>
-          <p:cNvSpPr/>
-          <p:nvPr/>
-        </p:nvSpPr>
-        <p:spPr>
-          <a:xfrm>
-            <a:off x="8389751" y="1753036"/>
-            <a:ext cx="60089" cy="60089"/>
-          </a:xfrm>
-          <a:prstGeom prst="ellipse">
-            <a:avLst/>
-          </a:prstGeom>
-          <a:solidFill>
-            <a:srgbClr val="58F268">
-              <a:alpha val="42857"/>
-            </a:srgbClr>
-          </a:solidFill>
-          <a:ln>
-            <a:noFill/>
-          </a:ln>
-          <a:effectLst>
-            <a:glow rad="63500">
-              <a:srgbClr val="58F268">
-                <a:alpha val="25714"/>
-              </a:srgbClr>
-            </a:glow>
-          </a:effectLst>
-        </p:spPr>
-      </p:sp>
-      <p:sp>
-        <p:nvSpPr>
-          <p:cNvPr id="33" name="Світло рамки 1.5"/>
-          <p:cNvSpPr/>
-          <p:nvPr/>
-        </p:nvSpPr>
-        <p:spPr>
-          <a:xfrm>
-            <a:off x="8383873" y="1747158"/>
-            <a:ext cx="71845" cy="71845"/>
-          </a:xfrm>
-          <a:prstGeom prst="ellipse">
-            <a:avLst/>
-          </a:prstGeom>
-          <a:solidFill>
-            <a:srgbClr val="58F268">
-              <a:alpha val="54285"/>
-            </a:srgbClr>
-          </a:solidFill>
-          <a:ln>
-            <a:noFill/>
-          </a:ln>
-          <a:effectLst>
-            <a:glow rad="63500">
-              <a:srgbClr val="58F268">
-                <a:alpha val="32571"/>
-              </a:srgbClr>
-            </a:glow>
-          </a:effectLst>
-        </p:spPr>
-      </p:sp>
-      <p:sp>
-        <p:nvSpPr>
-          <p:cNvPr id="32" name="Світло рамки 1.4"/>
-          <p:cNvSpPr/>
-          <p:nvPr/>
-        </p:nvSpPr>
-        <p:spPr>
-          <a:xfrm>
-            <a:off x="8377994" y="1741279"/>
-            <a:ext cx="83602" cy="83602"/>
-          </a:xfrm>
-          <a:prstGeom prst="ellipse">
-            <a:avLst/>
-          </a:prstGeom>
-          <a:solidFill>
-            <a:srgbClr val="58F268">
-              <a:alpha val="65714"/>
-            </a:srgbClr>
-          </a:solidFill>
-          <a:ln>
-            <a:noFill/>
-          </a:ln>
-          <a:effectLst>
-            <a:glow rad="63500">
-              <a:srgbClr val="58F268">
-                <a:alpha val="39428"/>
-              </a:srgbClr>
-            </a:glow>
-          </a:effectLst>
-        </p:spPr>
-      </p:sp>
-      <p:sp>
-        <p:nvSpPr>
-          <p:cNvPr id="31" name="Світло рамки 1.3"/>
-          <p:cNvSpPr/>
-          <p:nvPr/>
-        </p:nvSpPr>
-        <p:spPr>
-          <a:xfrm>
-            <a:off x="8372116" y="1735401"/>
-            <a:ext cx="95358" cy="95358"/>
-          </a:xfrm>
-          <a:prstGeom prst="ellipse">
-            <a:avLst/>
-          </a:prstGeom>
-          <a:solidFill>
-            <a:srgbClr val="58F268">
-              <a:alpha val="77142"/>
-            </a:srgbClr>
-          </a:solidFill>
-          <a:ln>
-            <a:noFill/>
-          </a:ln>
-          <a:effectLst>
-            <a:glow rad="63500">
-              <a:srgbClr val="58F268">
-                <a:alpha val="46285"/>
-              </a:srgbClr>
-            </a:glow>
-          </a:effectLst>
-        </p:spPr>
-      </p:sp>
-      <p:sp>
-        <p:nvSpPr>
-          <p:cNvPr id="30" name="Світло рамки 1.2"/>
-          <p:cNvSpPr/>
-          <p:nvPr/>
-        </p:nvSpPr>
-        <p:spPr>
-          <a:xfrm>
-            <a:off x="8366238" y="1729523"/>
-            <a:ext cx="107115" cy="107115"/>
-          </a:xfrm>
-          <a:prstGeom prst="ellipse">
-            <a:avLst/>
-          </a:prstGeom>
-          <a:solidFill>
-            <a:srgbClr val="58F268">
-              <a:alpha val="88571"/>
-            </a:srgbClr>
-          </a:solidFill>
-          <a:ln>
-            <a:noFill/>
-          </a:ln>
-          <a:effectLst>
-            <a:glow rad="63500">
-              <a:srgbClr val="58F268">
-                <a:alpha val="53142"/>
-              </a:srgbClr>
-            </a:glow>
-          </a:effectLst>
-        </p:spPr>
-      </p:sp>
-      <p:sp>
-        <p:nvSpPr>
-          <p:cNvPr id="29" name="Світло рамки 1.1"/>
-          <p:cNvSpPr/>
-          <p:nvPr/>
-        </p:nvSpPr>
-        <p:spPr>
-          <a:xfrm>
-            <a:off x="8360359" y="1723644"/>
-            <a:ext cx="118872" cy="118872"/>
-          </a:xfrm>
-          <a:prstGeom prst="ellipse">
-            <a:avLst/>
-          </a:prstGeom>
-          <a:solidFill>
-            <a:srgbClr val="F2FFF3">
-              <a:alpha val="100000"/>
-            </a:srgbClr>
-          </a:solidFill>
-          <a:ln>
-            <a:noFill/>
-          </a:ln>
-          <a:effectLst>
-            <a:glow rad="101600">
-              <a:srgbClr val="58F268">
-                <a:alpha val="60000"/>
-              </a:srgbClr>
-            </a:glow>
-          </a:effectLst>
-        </p:spPr>
-      </p:sp>
-      <p:sp>
-        <p:nvSpPr>
           <p:cNvPr id="19" name="Кути коміксу 05 кут 1"/>
           <p:cNvSpPr/>
           <p:nvPr/>
@@ -14008,409 +9916,6 @@
   <p:clrMapOvr>
     <a:masterClrMapping/>
   </p:clrMapOvr>
-  <p:timing>
-    <p:tnLst>
-      <p:par>
-        <p:cTn id="1" dur="indefinite" restart="never" nodeType="tmRoot">
-          <p:childTnLst>
-            <p:seq concurrent="1" nextAc="seek">
-              <p:cTn id="2" dur="indefinite" nodeType="mainSeq">
-                <p:childTnLst>
-                  <p:par>
-                    <p:cTn id="3" fill="hold">
-                      <p:stCondLst>
-                        <p:cond delay="indefinite"/>
-                        <p:cond evt="onBegin" delay="0">
-                          <p:tn val="2"/>
-                        </p:cond>
-                      </p:stCondLst>
-                      <p:childTnLst>
-                        <p:par>
-                          <p:cTn id="4" fill="hold">
-                            <p:stCondLst>
-                              <p:cond delay="0"/>
-                            </p:stCondLst>
-                            <p:childTnLst>
-                              <p:par>
-                                <p:cTn id="5" presetID="0" presetClass="path" presetSubtype="0" repeatCount="indefinite" accel="0" decel="0" fill="hold" nodeType="withEffect">
-                                  <p:stCondLst>
-                                    <p:cond delay="0"/>
-                                  </p:stCondLst>
-                                  <p:childTnLst>
-                                    <p:animMotion origin="layout" path="M 0 0 L 0.26438 0 L 0.26438 0.63333 L 0 0.63333 L 0 0 E" pathEditMode="relative" rAng="0" ptsTypes="AAAAA">
-                                      <p:cBhvr>
-                                        <p:cTn id="6" dur="5503" fill="hold"/>
-                                        <p:tgtEl>
-                                          <p:spTgt spid="29"/>
-                                        </p:tgtEl>
-                                        <p:attrNameLst>
-                                          <p:attrName>ppt_x</p:attrName>
-                                          <p:attrName>ppt_y</p:attrName>
-                                        </p:attrNameLst>
-                                      </p:cBhvr>
-                                      <p:rCtr x="0" y="0"/>
-                                    </p:animMotion>
-                                  </p:childTnLst>
-                                </p:cTn>
-                              </p:par>
-                              <p:par>
-                                <p:cTn id="7" presetID="0" presetClass="path" presetSubtype="0" repeatCount="indefinite" accel="0" decel="0" fill="hold" nodeType="withEffect">
-                                  <p:stCondLst>
-                                    <p:cond delay="55"/>
-                                  </p:stCondLst>
-                                  <p:childTnLst>
-                                    <p:animMotion origin="layout" path="M 0 0 L 0.26438 0 L 0.26438 0.63333 L 0 0.63333 L 0 0 E" pathEditMode="relative" rAng="0" ptsTypes="AAAAA">
-                                      <p:cBhvr>
-                                        <p:cTn id="8" dur="5503" fill="hold"/>
-                                        <p:tgtEl>
-                                          <p:spTgt spid="30"/>
-                                        </p:tgtEl>
-                                        <p:attrNameLst>
-                                          <p:attrName>ppt_x</p:attrName>
-                                          <p:attrName>ppt_y</p:attrName>
-                                        </p:attrNameLst>
-                                      </p:cBhvr>
-                                      <p:rCtr x="0" y="0"/>
-                                    </p:animMotion>
-                                  </p:childTnLst>
-                                </p:cTn>
-                              </p:par>
-                              <p:par>
-                                <p:cTn id="9" presetID="0" presetClass="path" presetSubtype="0" repeatCount="indefinite" accel="0" decel="0" fill="hold" nodeType="withEffect">
-                                  <p:stCondLst>
-                                    <p:cond delay="110"/>
-                                  </p:stCondLst>
-                                  <p:childTnLst>
-                                    <p:animMotion origin="layout" path="M 0 0 L 0.26438 0 L 0.26438 0.63333 L 0 0.63333 L 0 0 E" pathEditMode="relative" rAng="0" ptsTypes="AAAAA">
-                                      <p:cBhvr>
-                                        <p:cTn id="10" dur="5503" fill="hold"/>
-                                        <p:tgtEl>
-                                          <p:spTgt spid="31"/>
-                                        </p:tgtEl>
-                                        <p:attrNameLst>
-                                          <p:attrName>ppt_x</p:attrName>
-                                          <p:attrName>ppt_y</p:attrName>
-                                        </p:attrNameLst>
-                                      </p:cBhvr>
-                                      <p:rCtr x="0" y="0"/>
-                                    </p:animMotion>
-                                  </p:childTnLst>
-                                </p:cTn>
-                              </p:par>
-                              <p:par>
-                                <p:cTn id="11" presetID="0" presetClass="path" presetSubtype="0" repeatCount="indefinite" accel="0" decel="0" fill="hold" nodeType="withEffect">
-                                  <p:stCondLst>
-                                    <p:cond delay="165"/>
-                                  </p:stCondLst>
-                                  <p:childTnLst>
-                                    <p:animMotion origin="layout" path="M 0 0 L 0.26438 0 L 0.26438 0.63333 L 0 0.63333 L 0 0 E" pathEditMode="relative" rAng="0" ptsTypes="AAAAA">
-                                      <p:cBhvr>
-                                        <p:cTn id="12" dur="5503" fill="hold"/>
-                                        <p:tgtEl>
-                                          <p:spTgt spid="32"/>
-                                        </p:tgtEl>
-                                        <p:attrNameLst>
-                                          <p:attrName>ppt_x</p:attrName>
-                                          <p:attrName>ppt_y</p:attrName>
-                                        </p:attrNameLst>
-                                      </p:cBhvr>
-                                      <p:rCtr x="0" y="0"/>
-                                    </p:animMotion>
-                                  </p:childTnLst>
-                                </p:cTn>
-                              </p:par>
-                              <p:par>
-                                <p:cTn id="13" presetID="0" presetClass="path" presetSubtype="0" repeatCount="indefinite" accel="0" decel="0" fill="hold" nodeType="withEffect">
-                                  <p:stCondLst>
-                                    <p:cond delay="220"/>
-                                  </p:stCondLst>
-                                  <p:childTnLst>
-                                    <p:animMotion origin="layout" path="M 0 0 L 0.26438 0 L 0.26438 0.63333 L 0 0.63333 L 0 0 E" pathEditMode="relative" rAng="0" ptsTypes="AAAAA">
-                                      <p:cBhvr>
-                                        <p:cTn id="14" dur="5503" fill="hold"/>
-                                        <p:tgtEl>
-                                          <p:spTgt spid="33"/>
-                                        </p:tgtEl>
-                                        <p:attrNameLst>
-                                          <p:attrName>ppt_x</p:attrName>
-                                          <p:attrName>ppt_y</p:attrName>
-                                        </p:attrNameLst>
-                                      </p:cBhvr>
-                                      <p:rCtr x="0" y="0"/>
-                                    </p:animMotion>
-                                  </p:childTnLst>
-                                </p:cTn>
-                              </p:par>
-                              <p:par>
-                                <p:cTn id="15" presetID="0" presetClass="path" presetSubtype="0" repeatCount="indefinite" accel="0" decel="0" fill="hold" nodeType="withEffect">
-                                  <p:stCondLst>
-                                    <p:cond delay="275"/>
-                                  </p:stCondLst>
-                                  <p:childTnLst>
-                                    <p:animMotion origin="layout" path="M 0 0 L 0.26438 0 L 0.26438 0.63333 L 0 0.63333 L 0 0 E" pathEditMode="relative" rAng="0" ptsTypes="AAAAA">
-                                      <p:cBhvr>
-                                        <p:cTn id="16" dur="5503" fill="hold"/>
-                                        <p:tgtEl>
-                                          <p:spTgt spid="34"/>
-                                        </p:tgtEl>
-                                        <p:attrNameLst>
-                                          <p:attrName>ppt_x</p:attrName>
-                                          <p:attrName>ppt_y</p:attrName>
-                                        </p:attrNameLst>
-                                      </p:cBhvr>
-                                      <p:rCtr x="0" y="0"/>
-                                    </p:animMotion>
-                                  </p:childTnLst>
-                                </p:cTn>
-                              </p:par>
-                              <p:par>
-                                <p:cTn id="17" presetID="0" presetClass="path" presetSubtype="0" repeatCount="indefinite" accel="0" decel="0" fill="hold" nodeType="withEffect">
-                                  <p:stCondLst>
-                                    <p:cond delay="330"/>
-                                  </p:stCondLst>
-                                  <p:childTnLst>
-                                    <p:animMotion origin="layout" path="M 0 0 L 0.26438 0 L 0.26438 0.63333 L 0 0.63333 L 0 0 E" pathEditMode="relative" rAng="0" ptsTypes="AAAAA">
-                                      <p:cBhvr>
-                                        <p:cTn id="18" dur="5503" fill="hold"/>
-                                        <p:tgtEl>
-                                          <p:spTgt spid="35"/>
-                                        </p:tgtEl>
-                                        <p:attrNameLst>
-                                          <p:attrName>ppt_x</p:attrName>
-                                          <p:attrName>ppt_y</p:attrName>
-                                        </p:attrNameLst>
-                                      </p:cBhvr>
-                                      <p:rCtr x="0" y="0"/>
-                                    </p:animMotion>
-                                  </p:childTnLst>
-                                </p:cTn>
-                              </p:par>
-                              <p:par>
-                                <p:cTn id="19" presetID="0" presetClass="path" presetSubtype="0" repeatCount="indefinite" accel="0" decel="0" fill="hold" nodeType="withEffect">
-                                  <p:stCondLst>
-                                    <p:cond delay="385"/>
-                                  </p:stCondLst>
-                                  <p:childTnLst>
-                                    <p:animMotion origin="layout" path="M 0 0 L 0.26438 0 L 0.26438 0.63333 L 0 0.63333 L 0 0 E" pathEditMode="relative" rAng="0" ptsTypes="AAAAA">
-                                      <p:cBhvr>
-                                        <p:cTn id="20" dur="5503" fill="hold"/>
-                                        <p:tgtEl>
-                                          <p:spTgt spid="36"/>
-                                        </p:tgtEl>
-                                        <p:attrNameLst>
-                                          <p:attrName>ppt_x</p:attrName>
-                                          <p:attrName>ppt_y</p:attrName>
-                                        </p:attrNameLst>
-                                      </p:cBhvr>
-                                      <p:rCtr x="0" y="0"/>
-                                    </p:animMotion>
-                                  </p:childTnLst>
-                                </p:cTn>
-                              </p:par>
-                              <p:par>
-                                <p:cTn id="21" presetID="0" presetClass="path" presetSubtype="0" repeatCount="indefinite" accel="0" decel="0" fill="hold" nodeType="withEffect">
-                                  <p:stCondLst>
-                                    <p:cond delay="0"/>
-                                  </p:stCondLst>
-                                  <p:childTnLst>
-                                    <p:animMotion origin="layout" path="M 0 0 L -0.26438 0 L -0.26438 -0.63333 L 0 -0.63333 L 0 0 E" pathEditMode="relative" rAng="0" ptsTypes="AAAAA">
-                                      <p:cBhvr>
-                                        <p:cTn id="22" dur="5503" fill="hold"/>
-                                        <p:tgtEl>
-                                          <p:spTgt spid="37"/>
-                                        </p:tgtEl>
-                                        <p:attrNameLst>
-                                          <p:attrName>ppt_x</p:attrName>
-                                          <p:attrName>ppt_y</p:attrName>
-                                        </p:attrNameLst>
-                                      </p:cBhvr>
-                                      <p:rCtr x="0" y="0"/>
-                                    </p:animMotion>
-                                  </p:childTnLst>
-                                </p:cTn>
-                              </p:par>
-                              <p:par>
-                                <p:cTn id="23" presetID="0" presetClass="path" presetSubtype="0" repeatCount="indefinite" accel="0" decel="0" fill="hold" nodeType="withEffect">
-                                  <p:stCondLst>
-                                    <p:cond delay="55"/>
-                                  </p:stCondLst>
-                                  <p:childTnLst>
-                                    <p:animMotion origin="layout" path="M 0 0 L -0.26438 0 L -0.26438 -0.63333 L 0 -0.63333 L 0 0 E" pathEditMode="relative" rAng="0" ptsTypes="AAAAA">
-                                      <p:cBhvr>
-                                        <p:cTn id="24" dur="5503" fill="hold"/>
-                                        <p:tgtEl>
-                                          <p:spTgt spid="38"/>
-                                        </p:tgtEl>
-                                        <p:attrNameLst>
-                                          <p:attrName>ppt_x</p:attrName>
-                                          <p:attrName>ppt_y</p:attrName>
-                                        </p:attrNameLst>
-                                      </p:cBhvr>
-                                      <p:rCtr x="0" y="0"/>
-                                    </p:animMotion>
-                                  </p:childTnLst>
-                                </p:cTn>
-                              </p:par>
-                              <p:par>
-                                <p:cTn id="25" presetID="0" presetClass="path" presetSubtype="0" repeatCount="indefinite" accel="0" decel="0" fill="hold" nodeType="withEffect">
-                                  <p:stCondLst>
-                                    <p:cond delay="110"/>
-                                  </p:stCondLst>
-                                  <p:childTnLst>
-                                    <p:animMotion origin="layout" path="M 0 0 L -0.26438 0 L -0.26438 -0.63333 L 0 -0.63333 L 0 0 E" pathEditMode="relative" rAng="0" ptsTypes="AAAAA">
-                                      <p:cBhvr>
-                                        <p:cTn id="26" dur="5503" fill="hold"/>
-                                        <p:tgtEl>
-                                          <p:spTgt spid="39"/>
-                                        </p:tgtEl>
-                                        <p:attrNameLst>
-                                          <p:attrName>ppt_x</p:attrName>
-                                          <p:attrName>ppt_y</p:attrName>
-                                        </p:attrNameLst>
-                                      </p:cBhvr>
-                                      <p:rCtr x="0" y="0"/>
-                                    </p:animMotion>
-                                  </p:childTnLst>
-                                </p:cTn>
-                              </p:par>
-                              <p:par>
-                                <p:cTn id="27" presetID="0" presetClass="path" presetSubtype="0" repeatCount="indefinite" accel="0" decel="0" fill="hold" nodeType="withEffect">
-                                  <p:stCondLst>
-                                    <p:cond delay="165"/>
-                                  </p:stCondLst>
-                                  <p:childTnLst>
-                                    <p:animMotion origin="layout" path="M 0 0 L -0.26438 0 L -0.26438 -0.63333 L 0 -0.63333 L 0 0 E" pathEditMode="relative" rAng="0" ptsTypes="AAAAA">
-                                      <p:cBhvr>
-                                        <p:cTn id="28" dur="5503" fill="hold"/>
-                                        <p:tgtEl>
-                                          <p:spTgt spid="40"/>
-                                        </p:tgtEl>
-                                        <p:attrNameLst>
-                                          <p:attrName>ppt_x</p:attrName>
-                                          <p:attrName>ppt_y</p:attrName>
-                                        </p:attrNameLst>
-                                      </p:cBhvr>
-                                      <p:rCtr x="0" y="0"/>
-                                    </p:animMotion>
-                                  </p:childTnLst>
-                                </p:cTn>
-                              </p:par>
-                              <p:par>
-                                <p:cTn id="29" presetID="0" presetClass="path" presetSubtype="0" repeatCount="indefinite" accel="0" decel="0" fill="hold" nodeType="withEffect">
-                                  <p:stCondLst>
-                                    <p:cond delay="220"/>
-                                  </p:stCondLst>
-                                  <p:childTnLst>
-                                    <p:animMotion origin="layout" path="M 0 0 L -0.26438 0 L -0.26438 -0.63333 L 0 -0.63333 L 0 0 E" pathEditMode="relative" rAng="0" ptsTypes="AAAAA">
-                                      <p:cBhvr>
-                                        <p:cTn id="30" dur="5503" fill="hold"/>
-                                        <p:tgtEl>
-                                          <p:spTgt spid="41"/>
-                                        </p:tgtEl>
-                                        <p:attrNameLst>
-                                          <p:attrName>ppt_x</p:attrName>
-                                          <p:attrName>ppt_y</p:attrName>
-                                        </p:attrNameLst>
-                                      </p:cBhvr>
-                                      <p:rCtr x="0" y="0"/>
-                                    </p:animMotion>
-                                  </p:childTnLst>
-                                </p:cTn>
-                              </p:par>
-                              <p:par>
-                                <p:cTn id="31" presetID="0" presetClass="path" presetSubtype="0" repeatCount="indefinite" accel="0" decel="0" fill="hold" nodeType="withEffect">
-                                  <p:stCondLst>
-                                    <p:cond delay="275"/>
-                                  </p:stCondLst>
-                                  <p:childTnLst>
-                                    <p:animMotion origin="layout" path="M 0 0 L -0.26438 0 L -0.26438 -0.63333 L 0 -0.63333 L 0 0 E" pathEditMode="relative" rAng="0" ptsTypes="AAAAA">
-                                      <p:cBhvr>
-                                        <p:cTn id="32" dur="5503" fill="hold"/>
-                                        <p:tgtEl>
-                                          <p:spTgt spid="42"/>
-                                        </p:tgtEl>
-                                        <p:attrNameLst>
-                                          <p:attrName>ppt_x</p:attrName>
-                                          <p:attrName>ppt_y</p:attrName>
-                                        </p:attrNameLst>
-                                      </p:cBhvr>
-                                      <p:rCtr x="0" y="0"/>
-                                    </p:animMotion>
-                                  </p:childTnLst>
-                                </p:cTn>
-                              </p:par>
-                              <p:par>
-                                <p:cTn id="33" presetID="0" presetClass="path" presetSubtype="0" repeatCount="indefinite" accel="0" decel="0" fill="hold" nodeType="withEffect">
-                                  <p:stCondLst>
-                                    <p:cond delay="330"/>
-                                  </p:stCondLst>
-                                  <p:childTnLst>
-                                    <p:animMotion origin="layout" path="M 0 0 L -0.26438 0 L -0.26438 -0.63333 L 0 -0.63333 L 0 0 E" pathEditMode="relative" rAng="0" ptsTypes="AAAAA">
-                                      <p:cBhvr>
-                                        <p:cTn id="34" dur="5503" fill="hold"/>
-                                        <p:tgtEl>
-                                          <p:spTgt spid="43"/>
-                                        </p:tgtEl>
-                                        <p:attrNameLst>
-                                          <p:attrName>ppt_x</p:attrName>
-                                          <p:attrName>ppt_y</p:attrName>
-                                        </p:attrNameLst>
-                                      </p:cBhvr>
-                                      <p:rCtr x="0" y="0"/>
-                                    </p:animMotion>
-                                  </p:childTnLst>
-                                </p:cTn>
-                              </p:par>
-                              <p:par>
-                                <p:cTn id="35" presetID="0" presetClass="path" presetSubtype="0" repeatCount="indefinite" accel="0" decel="0" fill="hold" nodeType="withEffect">
-                                  <p:stCondLst>
-                                    <p:cond delay="385"/>
-                                  </p:stCondLst>
-                                  <p:childTnLst>
-                                    <p:animMotion origin="layout" path="M 0 0 L -0.26438 0 L -0.26438 -0.63333 L 0 -0.63333 L 0 0 E" pathEditMode="relative" rAng="0" ptsTypes="AAAAA">
-                                      <p:cBhvr>
-                                        <p:cTn id="36" dur="5503" fill="hold"/>
-                                        <p:tgtEl>
-                                          <p:spTgt spid="44"/>
-                                        </p:tgtEl>
-                                        <p:attrNameLst>
-                                          <p:attrName>ppt_x</p:attrName>
-                                          <p:attrName>ppt_y</p:attrName>
-                                        </p:attrNameLst>
-                                      </p:cBhvr>
-                                      <p:rCtr x="0" y="0"/>
-                                    </p:animMotion>
-                                  </p:childTnLst>
-                                </p:cTn>
-                              </p:par>
-                            </p:childTnLst>
-                          </p:cTn>
-                        </p:par>
-                      </p:childTnLst>
-                    </p:cTn>
-                  </p:par>
-                </p:childTnLst>
-              </p:cTn>
-              <p:prevCondLst>
-                <p:cond evt="onPrev" delay="0">
-                  <p:tgtEl>
-                    <p:sldTgt/>
-                  </p:tgtEl>
-                </p:cond>
-              </p:prevCondLst>
-              <p:nextCondLst>
-                <p:cond evt="onNext" delay="0">
-                  <p:tgtEl>
-                    <p:sldTgt/>
-                  </p:tgtEl>
-                </p:cond>
-              </p:nextCondLst>
-            </p:seq>
-          </p:childTnLst>
-        </p:cTn>
-      </p:par>
-    </p:tnLst>
-  </p:timing>
 </p:sld>
 </file>
 

</xml_diff>